<commit_message>
refine critical PD deck graphic slides
</commit_message>
<xml_diff>
--- a/llm/kubecon-na-2026-pd-disaggregation.pptx
+++ b/llm/kubecon-na-2026-pd-disaggregation.pptx
@@ -3176,19 +3176,64 @@
       </p:sp>
       <p:sp>
         <p:nvSpPr>
-          <p:cNvPr id="3" name="Rounded Rectangle 2"/>
-          <p:cNvSpPr/>
-          <p:nvPr/>
-        </p:nvSpPr>
-        <p:spPr>
-          <a:xfrm>
-            <a:off x="685800" y="868680"/>
-            <a:ext cx="6766560" cy="1143000"/>
+          <p:cNvPr id="3" name="Rectangle 2"/>
+          <p:cNvSpPr/>
+          <p:nvPr/>
+        </p:nvSpPr>
+        <p:spPr>
+          <a:xfrm>
+            <a:off x="8138160" y="128016"/>
+            <a:ext cx="4069080" cy="6729984"/>
+          </a:xfrm>
+          <a:prstGeom prst="rect">
+            <a:avLst/>
+          </a:prstGeom>
+          <a:solidFill>
+            <a:srgbClr val="16203A"/>
+          </a:solidFill>
+          <a:ln>
+            <a:noFill/>
+          </a:ln>
+        </p:spPr>
+        <p:style>
+          <a:lnRef idx="1">
+            <a:schemeClr val="accent1"/>
+          </a:lnRef>
+          <a:fillRef idx="3">
+            <a:schemeClr val="accent1"/>
+          </a:fillRef>
+          <a:effectRef idx="2">
+            <a:schemeClr val="accent1"/>
+          </a:effectRef>
+          <a:fontRef idx="minor">
+            <a:schemeClr val="lt1"/>
+          </a:fontRef>
+        </p:style>
+        <p:txBody>
+          <a:bodyPr rtlCol="0" anchor="ctr"/>
+          <a:lstStyle/>
+          <a:p>
+            <a:pPr algn="ctr"/>
+          </a:p>
+        </p:txBody>
+      </p:sp>
+      <p:sp>
+        <p:nvSpPr>
+          <p:cNvPr id="4" name="Rounded Rectangle 3"/>
+          <p:cNvSpPr/>
+          <p:nvPr/>
+        </p:nvSpPr>
+        <p:spPr>
+          <a:xfrm>
+            <a:off x="749808" y="822960"/>
+            <a:ext cx="896112" cy="384048"/>
           </a:xfrm>
           <a:prstGeom prst="roundRect">
             <a:avLst/>
           </a:prstGeom>
-          <a:noFill/>
+          <a:solidFill>
+            <a:srgbClr val="FFFFFF"/>
+          </a:solidFill>
           <a:ln>
             <a:noFill/>
           </a:ln>
@@ -3217,14 +3262,14 @@
       </p:sp>
       <p:sp>
         <p:nvSpPr>
-          <p:cNvPr id="4" name="Rectangle 3"/>
-          <p:cNvSpPr/>
-          <p:nvPr/>
-        </p:nvSpPr>
-        <p:spPr>
-          <a:xfrm>
-            <a:off x="749808" y="914400"/>
-            <a:ext cx="6675120" cy="914400"/>
+          <p:cNvPr id="5" name="Rectangle 4"/>
+          <p:cNvSpPr/>
+          <p:nvPr/>
+        </p:nvSpPr>
+        <p:spPr>
+          <a:xfrm>
+            <a:off x="822960" y="873252"/>
+            <a:ext cx="749808" cy="201168"/>
           </a:xfrm>
           <a:prstGeom prst="rect">
             <a:avLst/>
@@ -3254,9 +3299,61 @@
           </a:bodyPr>
           <a:lstStyle/>
           <a:p>
+            <a:pPr algn="ctr"/>
+            <a:r>
+              <a:rPr sz="1200" b="1">
+                <a:solidFill>
+                  <a:srgbClr val="0F172A"/>
+                </a:solidFill>
+                <a:latin typeface="Aptos"/>
+              </a:rPr>
+              <a:t>KubeCon '26</a:t>
+            </a:r>
+          </a:p>
+        </p:txBody>
+      </p:sp>
+      <p:sp>
+        <p:nvSpPr>
+          <p:cNvPr id="6" name="Rectangle 5"/>
+          <p:cNvSpPr/>
+          <p:nvPr/>
+        </p:nvSpPr>
+        <p:spPr>
+          <a:xfrm>
+            <a:off x="749808" y="1325880"/>
+            <a:ext cx="6995160" cy="1051560"/>
+          </a:xfrm>
+          <a:prstGeom prst="rect">
+            <a:avLst/>
+          </a:prstGeom>
+          <a:noFill/>
+          <a:ln>
+            <a:noFill/>
+          </a:ln>
+        </p:spPr>
+        <p:style>
+          <a:lnRef idx="1">
+            <a:schemeClr val="accent1"/>
+          </a:lnRef>
+          <a:fillRef idx="3">
+            <a:schemeClr val="accent1"/>
+          </a:fillRef>
+          <a:effectRef idx="2">
+            <a:schemeClr val="accent1"/>
+          </a:effectRef>
+          <a:fontRef idx="minor">
+            <a:schemeClr val="lt1"/>
+          </a:fontRef>
+        </p:style>
+        <p:txBody>
+          <a:bodyPr rtlCol="0" anchor="ctr" wrap="square" tIns="91440" bIns="91440">
+            <a:noAutofit/>
+          </a:bodyPr>
+          <a:lstStyle/>
+          <a:p>
             <a:pPr algn="l"/>
             <a:r>
-              <a:rPr sz="3000" b="1">
+              <a:rPr sz="3200" b="1">
                 <a:solidFill>
                   <a:srgbClr val="FFFFFF"/>
                 </a:solidFill>
@@ -3269,14 +3366,14 @@
       </p:sp>
       <p:sp>
         <p:nvSpPr>
-          <p:cNvPr id="5" name="Rectangle 4"/>
-          <p:cNvSpPr/>
-          <p:nvPr/>
-        </p:nvSpPr>
-        <p:spPr>
-          <a:xfrm>
-            <a:off x="768096" y="1874519"/>
-            <a:ext cx="7680960" cy="822960"/>
+          <p:cNvPr id="7" name="Rectangle 6"/>
+          <p:cNvSpPr/>
+          <p:nvPr/>
+        </p:nvSpPr>
+        <p:spPr>
+          <a:xfrm>
+            <a:off x="768096" y="2395728"/>
+            <a:ext cx="7223760" cy="786384"/>
           </a:xfrm>
           <a:prstGeom prst="rect">
             <a:avLst/>
@@ -3308,7 +3405,7 @@
           <a:p>
             <a:pPr algn="l"/>
             <a:r>
-              <a:rPr sz="2100" b="0">
+              <a:rPr sz="2000" b="0">
                 <a:solidFill>
                   <a:srgbClr val="C9D6FF"/>
                 </a:solidFill>
@@ -3321,14 +3418,14 @@
       </p:sp>
       <p:sp>
         <p:nvSpPr>
-          <p:cNvPr id="6" name="Rectangle 5"/>
-          <p:cNvSpPr/>
-          <p:nvPr/>
-        </p:nvSpPr>
-        <p:spPr>
-          <a:xfrm>
-            <a:off x="786384" y="2907792"/>
-            <a:ext cx="4297680" cy="1737360"/>
+          <p:cNvPr id="8" name="Rectangle 7"/>
+          <p:cNvSpPr/>
+          <p:nvPr/>
+        </p:nvSpPr>
+        <p:spPr>
+          <a:xfrm>
+            <a:off x="786384" y="3749039"/>
+            <a:ext cx="5120640" cy="1143000"/>
           </a:xfrm>
           <a:prstGeom prst="rect">
             <a:avLst/>
@@ -3360,79 +3457,39 @@
           <a:p>
             <a:pPr algn="l"/>
             <a:r>
-              <a:rPr sz="1600" b="0">
+              <a:rPr sz="1700" b="0">
                 <a:solidFill>
                   <a:srgbClr val="FFFFFF"/>
                 </a:solidFill>
                 <a:latin typeface="Aptos"/>
               </a:rPr>
-              <a:t>KubeCon + CloudNativeCon North America 2026
-KAITO · llm-d · GWIE · KEDA
-Generated directly from the markdown deck outline</a:t>
-            </a:r>
-          </a:p>
-        </p:txBody>
-      </p:sp>
-      <p:sp>
-        <p:nvSpPr>
-          <p:cNvPr id="7" name="Rounded Rectangle 6"/>
-          <p:cNvSpPr/>
-          <p:nvPr/>
-        </p:nvSpPr>
-        <p:spPr>
-          <a:xfrm>
-            <a:off x="6812280" y="1417320"/>
-            <a:ext cx="4480560" cy="3291840"/>
+              <a:t>A Kubernetes-native story about KAITO, llm-d,
+prefill/decode disaggregation, and inference-aware autoscaling.</a:t>
+            </a:r>
+          </a:p>
+        </p:txBody>
+      </p:sp>
+      <p:sp>
+        <p:nvSpPr>
+          <p:cNvPr id="9" name="Rounded Rectangle 8"/>
+          <p:cNvSpPr/>
+          <p:nvPr/>
+        </p:nvSpPr>
+        <p:spPr>
+          <a:xfrm>
+            <a:off x="786384" y="5230368"/>
+            <a:ext cx="1115568" cy="420624"/>
           </a:xfrm>
           <a:prstGeom prst="roundRect">
             <a:avLst/>
           </a:prstGeom>
           <a:solidFill>
-            <a:srgbClr val="FFFFFF"/>
+            <a:srgbClr val="DBEAFE"/>
           </a:solidFill>
-          <a:ln>
-            <a:noFill/>
-          </a:ln>
-        </p:spPr>
-        <p:style>
-          <a:lnRef idx="1">
-            <a:schemeClr val="accent1"/>
-          </a:lnRef>
-          <a:fillRef idx="3">
-            <a:schemeClr val="accent1"/>
-          </a:fillRef>
-          <a:effectRef idx="2">
-            <a:schemeClr val="accent1"/>
-          </a:effectRef>
-          <a:fontRef idx="minor">
-            <a:schemeClr val="lt1"/>
-          </a:fontRef>
-        </p:style>
-        <p:txBody>
-          <a:bodyPr rtlCol="0" anchor="ctr"/>
-          <a:lstStyle/>
-          <a:p>
-            <a:pPr algn="ctr"/>
-          </a:p>
-        </p:txBody>
-      </p:sp>
-      <p:sp>
-        <p:nvSpPr>
-          <p:cNvPr id="8" name="Rectangle 7"/>
-          <p:cNvSpPr/>
-          <p:nvPr/>
-        </p:nvSpPr>
-        <p:spPr>
-          <a:xfrm>
-            <a:off x="7086600" y="1737360"/>
-            <a:ext cx="3840480" cy="502920"/>
-          </a:xfrm>
-          <a:prstGeom prst="rect">
-            <a:avLst/>
-          </a:prstGeom>
-          <a:noFill/>
-          <a:ln>
-            <a:noFill/>
+          <a:ln w="15875">
+            <a:solidFill>
+              <a:srgbClr val="2563EB"/>
+            </a:solidFill>
           </a:ln>
         </p:spPr>
         <p:style>
@@ -3457,27 +3514,27 @@
           <a:p>
             <a:pPr algn="ctr"/>
             <a:r>
-              <a:rPr sz="1600" b="1">
-                <a:solidFill>
-                  <a:srgbClr val="2563EB"/>
+              <a:rPr sz="1300" b="1">
+                <a:solidFill>
+                  <a:srgbClr val="0F172A"/>
                 </a:solidFill>
                 <a:latin typeface="Aptos"/>
               </a:rPr>
-              <a:t>Serving topology</a:t>
-            </a:r>
-          </a:p>
-        </p:txBody>
-      </p:sp>
-      <p:sp>
-        <p:nvSpPr>
-          <p:cNvPr id="9" name="Rounded Rectangle 8"/>
-          <p:cNvSpPr/>
-          <p:nvPr/>
-        </p:nvSpPr>
-        <p:spPr>
-          <a:xfrm>
-            <a:off x="7315200" y="2331720"/>
-            <a:ext cx="3383280" cy="640080"/>
+              <a:t>KAITO</a:t>
+            </a:r>
+          </a:p>
+        </p:txBody>
+      </p:sp>
+      <p:sp>
+        <p:nvSpPr>
+          <p:cNvPr id="10" name="Rounded Rectangle 9"/>
+          <p:cNvSpPr/>
+          <p:nvPr/>
+        </p:nvSpPr>
+        <p:spPr>
+          <a:xfrm>
+            <a:off x="2048256" y="5230368"/>
+            <a:ext cx="1115568" cy="420624"/>
           </a:xfrm>
           <a:prstGeom prst="roundRect">
             <a:avLst/>
@@ -3513,27 +3570,83 @@
           <a:p>
             <a:pPr algn="ctr"/>
             <a:r>
-              <a:rPr sz="2400" b="1">
+              <a:rPr sz="1300" b="1">
                 <a:solidFill>
                   <a:srgbClr val="0F172A"/>
                 </a:solidFill>
                 <a:latin typeface="Aptos"/>
               </a:rPr>
-              <a:t>prefill</a:t>
-            </a:r>
-          </a:p>
-        </p:txBody>
-      </p:sp>
-      <p:sp>
-        <p:nvSpPr>
-          <p:cNvPr id="10" name="Rounded Rectangle 9"/>
-          <p:cNvSpPr/>
-          <p:nvPr/>
-        </p:nvSpPr>
-        <p:spPr>
-          <a:xfrm>
-            <a:off x="7315200" y="3246120"/>
-            <a:ext cx="3383280" cy="640080"/>
+              <a:t>llm-d</a:t>
+            </a:r>
+          </a:p>
+        </p:txBody>
+      </p:sp>
+      <p:sp>
+        <p:nvSpPr>
+          <p:cNvPr id="11" name="Rounded Rectangle 10"/>
+          <p:cNvSpPr/>
+          <p:nvPr/>
+        </p:nvSpPr>
+        <p:spPr>
+          <a:xfrm>
+            <a:off x="3310128" y="5230368"/>
+            <a:ext cx="1115568" cy="420624"/>
+          </a:xfrm>
+          <a:prstGeom prst="roundRect">
+            <a:avLst/>
+          </a:prstGeom>
+          <a:solidFill>
+            <a:srgbClr val="DCFCE7"/>
+          </a:solidFill>
+          <a:ln w="15875">
+            <a:solidFill>
+              <a:srgbClr val="16A34A"/>
+            </a:solidFill>
+          </a:ln>
+        </p:spPr>
+        <p:style>
+          <a:lnRef idx="1">
+            <a:schemeClr val="accent1"/>
+          </a:lnRef>
+          <a:fillRef idx="3">
+            <a:schemeClr val="accent1"/>
+          </a:fillRef>
+          <a:effectRef idx="2">
+            <a:schemeClr val="accent1"/>
+          </a:effectRef>
+          <a:fontRef idx="minor">
+            <a:schemeClr val="lt1"/>
+          </a:fontRef>
+        </p:style>
+        <p:txBody>
+          <a:bodyPr rtlCol="0" anchor="ctr" wrap="square" tIns="91440" bIns="91440">
+            <a:noAutofit/>
+          </a:bodyPr>
+          <a:lstStyle/>
+          <a:p>
+            <a:pPr algn="ctr"/>
+            <a:r>
+              <a:rPr sz="1300" b="1">
+                <a:solidFill>
+                  <a:srgbClr val="0F172A"/>
+                </a:solidFill>
+                <a:latin typeface="Aptos"/>
+              </a:rPr>
+              <a:t>GWIE</a:t>
+            </a:r>
+          </a:p>
+        </p:txBody>
+      </p:sp>
+      <p:sp>
+        <p:nvSpPr>
+          <p:cNvPr id="12" name="Rounded Rectangle 11"/>
+          <p:cNvSpPr/>
+          <p:nvPr/>
+        </p:nvSpPr>
+        <p:spPr>
+          <a:xfrm>
+            <a:off x="4572000" y="5230368"/>
+            <a:ext cx="1115568" cy="420624"/>
           </a:xfrm>
           <a:prstGeom prst="roundRect">
             <a:avLst/>
@@ -3569,7 +3682,266 @@
           <a:p>
             <a:pPr algn="ctr"/>
             <a:r>
-              <a:rPr sz="2400" b="1">
+              <a:rPr sz="1300" b="1">
+                <a:solidFill>
+                  <a:srgbClr val="0F172A"/>
+                </a:solidFill>
+                <a:latin typeface="Aptos"/>
+              </a:rPr>
+              <a:t>KEDA</a:t>
+            </a:r>
+          </a:p>
+        </p:txBody>
+      </p:sp>
+      <p:sp>
+        <p:nvSpPr>
+          <p:cNvPr id="13" name="Rectangle 12"/>
+          <p:cNvSpPr/>
+          <p:nvPr/>
+        </p:nvSpPr>
+        <p:spPr>
+          <a:xfrm>
+            <a:off x="786384" y="5925312"/>
+            <a:ext cx="4480560" cy="411480"/>
+          </a:xfrm>
+          <a:prstGeom prst="rect">
+            <a:avLst/>
+          </a:prstGeom>
+          <a:noFill/>
+          <a:ln>
+            <a:noFill/>
+          </a:ln>
+        </p:spPr>
+        <p:style>
+          <a:lnRef idx="1">
+            <a:schemeClr val="accent1"/>
+          </a:lnRef>
+          <a:fillRef idx="3">
+            <a:schemeClr val="accent1"/>
+          </a:fillRef>
+          <a:effectRef idx="2">
+            <a:schemeClr val="accent1"/>
+          </a:effectRef>
+          <a:fontRef idx="minor">
+            <a:schemeClr val="lt1"/>
+          </a:fontRef>
+        </p:style>
+        <p:txBody>
+          <a:bodyPr rtlCol="0" anchor="ctr" wrap="square" tIns="91440" bIns="91440">
+            <a:noAutofit/>
+          </a:bodyPr>
+          <a:lstStyle/>
+          <a:p>
+            <a:pPr algn="l"/>
+            <a:r>
+              <a:rPr sz="1300" b="0">
+                <a:solidFill>
+                  <a:srgbClr val="C9D6FF"/>
+                </a:solidFill>
+                <a:latin typeface="Aptos"/>
+              </a:rPr>
+              <a:t>KubeCon + CloudNativeCon North America 2026</a:t>
+            </a:r>
+          </a:p>
+        </p:txBody>
+      </p:sp>
+      <p:sp>
+        <p:nvSpPr>
+          <p:cNvPr id="14" name="Rounded Rectangle 13"/>
+          <p:cNvSpPr/>
+          <p:nvPr/>
+        </p:nvSpPr>
+        <p:spPr>
+          <a:xfrm>
+            <a:off x="8549640" y="960120"/>
+            <a:ext cx="2880360" cy="4754880"/>
+          </a:xfrm>
+          <a:prstGeom prst="roundRect">
+            <a:avLst/>
+          </a:prstGeom>
+          <a:solidFill>
+            <a:srgbClr val="FFFFFF"/>
+          </a:solidFill>
+          <a:ln>
+            <a:noFill/>
+          </a:ln>
+        </p:spPr>
+        <p:style>
+          <a:lnRef idx="1">
+            <a:schemeClr val="accent1"/>
+          </a:lnRef>
+          <a:fillRef idx="3">
+            <a:schemeClr val="accent1"/>
+          </a:fillRef>
+          <a:effectRef idx="2">
+            <a:schemeClr val="accent1"/>
+          </a:effectRef>
+          <a:fontRef idx="minor">
+            <a:schemeClr val="lt1"/>
+          </a:fontRef>
+        </p:style>
+        <p:txBody>
+          <a:bodyPr rtlCol="0" anchor="ctr"/>
+          <a:lstStyle/>
+          <a:p>
+            <a:pPr algn="ctr"/>
+          </a:p>
+        </p:txBody>
+      </p:sp>
+      <p:sp>
+        <p:nvSpPr>
+          <p:cNvPr id="15" name="Rectangle 14"/>
+          <p:cNvSpPr/>
+          <p:nvPr/>
+        </p:nvSpPr>
+        <p:spPr>
+          <a:xfrm>
+            <a:off x="8823960" y="1261872"/>
+            <a:ext cx="2331720" cy="384048"/>
+          </a:xfrm>
+          <a:prstGeom prst="rect">
+            <a:avLst/>
+          </a:prstGeom>
+          <a:noFill/>
+          <a:ln>
+            <a:noFill/>
+          </a:ln>
+        </p:spPr>
+        <p:style>
+          <a:lnRef idx="1">
+            <a:schemeClr val="accent1"/>
+          </a:lnRef>
+          <a:fillRef idx="3">
+            <a:schemeClr val="accent1"/>
+          </a:fillRef>
+          <a:effectRef idx="2">
+            <a:schemeClr val="accent1"/>
+          </a:effectRef>
+          <a:fontRef idx="minor">
+            <a:schemeClr val="lt1"/>
+          </a:fontRef>
+        </p:style>
+        <p:txBody>
+          <a:bodyPr rtlCol="0" anchor="ctr" wrap="square" tIns="91440" bIns="91440">
+            <a:noAutofit/>
+          </a:bodyPr>
+          <a:lstStyle/>
+          <a:p>
+            <a:pPr algn="ctr"/>
+            <a:r>
+              <a:rPr sz="1500" b="1">
+                <a:solidFill>
+                  <a:srgbClr val="2563EB"/>
+                </a:solidFill>
+                <a:latin typeface="Aptos"/>
+              </a:rPr>
+              <a:t>Serving topology</a:t>
+            </a:r>
+          </a:p>
+        </p:txBody>
+      </p:sp>
+      <p:sp>
+        <p:nvSpPr>
+          <p:cNvPr id="16" name="Rounded Rectangle 15"/>
+          <p:cNvSpPr/>
+          <p:nvPr/>
+        </p:nvSpPr>
+        <p:spPr>
+          <a:xfrm>
+            <a:off x="8887968" y="1901952"/>
+            <a:ext cx="2194560" cy="566928"/>
+          </a:xfrm>
+          <a:prstGeom prst="roundRect">
+            <a:avLst/>
+          </a:prstGeom>
+          <a:solidFill>
+            <a:srgbClr val="FFEDD5"/>
+          </a:solidFill>
+          <a:ln w="15875">
+            <a:solidFill>
+              <a:srgbClr val="EA580C"/>
+            </a:solidFill>
+          </a:ln>
+        </p:spPr>
+        <p:style>
+          <a:lnRef idx="1">
+            <a:schemeClr val="accent1"/>
+          </a:lnRef>
+          <a:fillRef idx="3">
+            <a:schemeClr val="accent1"/>
+          </a:fillRef>
+          <a:effectRef idx="2">
+            <a:schemeClr val="accent1"/>
+          </a:effectRef>
+          <a:fontRef idx="minor">
+            <a:schemeClr val="lt1"/>
+          </a:fontRef>
+        </p:style>
+        <p:txBody>
+          <a:bodyPr rtlCol="0" anchor="ctr" wrap="square" tIns="91440" bIns="91440">
+            <a:noAutofit/>
+          </a:bodyPr>
+          <a:lstStyle/>
+          <a:p>
+            <a:pPr algn="ctr"/>
+            <a:r>
+              <a:rPr sz="2200" b="1">
+                <a:solidFill>
+                  <a:srgbClr val="0F172A"/>
+                </a:solidFill>
+                <a:latin typeface="Aptos"/>
+              </a:rPr>
+              <a:t>prefill</a:t>
+            </a:r>
+          </a:p>
+        </p:txBody>
+      </p:sp>
+      <p:sp>
+        <p:nvSpPr>
+          <p:cNvPr id="17" name="Rounded Rectangle 16"/>
+          <p:cNvSpPr/>
+          <p:nvPr/>
+        </p:nvSpPr>
+        <p:spPr>
+          <a:xfrm>
+            <a:off x="8887968" y="2852928"/>
+            <a:ext cx="2194560" cy="566928"/>
+          </a:xfrm>
+          <a:prstGeom prst="roundRect">
+            <a:avLst/>
+          </a:prstGeom>
+          <a:solidFill>
+            <a:srgbClr val="EDE9FE"/>
+          </a:solidFill>
+          <a:ln w="15875">
+            <a:solidFill>
+              <a:srgbClr val="6D28D9"/>
+            </a:solidFill>
+          </a:ln>
+        </p:spPr>
+        <p:style>
+          <a:lnRef idx="1">
+            <a:schemeClr val="accent1"/>
+          </a:lnRef>
+          <a:fillRef idx="3">
+            <a:schemeClr val="accent1"/>
+          </a:fillRef>
+          <a:effectRef idx="2">
+            <a:schemeClr val="accent1"/>
+          </a:effectRef>
+          <a:fontRef idx="minor">
+            <a:schemeClr val="lt1"/>
+          </a:fontRef>
+        </p:style>
+        <p:txBody>
+          <a:bodyPr rtlCol="0" anchor="ctr" wrap="square" tIns="91440" bIns="91440">
+            <a:noAutofit/>
+          </a:bodyPr>
+          <a:lstStyle/>
+          <a:p>
+            <a:pPr algn="ctr"/>
+            <a:r>
+              <a:rPr sz="2200" b="1">
                 <a:solidFill>
                   <a:srgbClr val="0F172A"/>
                 </a:solidFill>
@@ -3582,14 +3954,14 @@
       </p:sp>
       <p:sp>
         <p:nvSpPr>
-          <p:cNvPr id="11" name="Rounded Rectangle 10"/>
-          <p:cNvSpPr/>
-          <p:nvPr/>
-        </p:nvSpPr>
-        <p:spPr>
-          <a:xfrm>
-            <a:off x="7315200" y="4160520"/>
-            <a:ext cx="3383280" cy="640080"/>
+          <p:cNvPr id="18" name="Rounded Rectangle 17"/>
+          <p:cNvSpPr/>
+          <p:nvPr/>
+        </p:nvSpPr>
+        <p:spPr>
+          <a:xfrm>
+            <a:off x="8887968" y="3803904"/>
+            <a:ext cx="2194560" cy="566928"/>
           </a:xfrm>
           <a:prstGeom prst="roundRect">
             <a:avLst/>
@@ -3625,7 +3997,7 @@
           <a:p>
             <a:pPr algn="ctr"/>
             <a:r>
-              <a:rPr sz="2400" b="1">
+              <a:rPr sz="2200" b="1">
                 <a:solidFill>
                   <a:srgbClr val="0F172A"/>
                 </a:solidFill>
@@ -3638,14 +4010,14 @@
       </p:sp>
       <p:cxnSp>
         <p:nvCxnSpPr>
-          <p:cNvPr id="12" name="Connector 11"/>
+          <p:cNvPr id="19" name="Connector 18"/>
           <p:cNvCxnSpPr/>
           <p:nvPr/>
         </p:nvCxnSpPr>
         <p:spPr>
           <a:xfrm>
-            <a:off x="9006840" y="2971800"/>
-            <a:ext cx="0" cy="274320"/>
+            <a:off x="9985248" y="2468880"/>
+            <a:ext cx="0" cy="384048"/>
           </a:xfrm>
           <a:prstGeom prst="line">
             <a:avLst/>
@@ -3673,14 +4045,14 @@
       </p:cxnSp>
       <p:cxnSp>
         <p:nvCxnSpPr>
-          <p:cNvPr id="13" name="Connector 12"/>
+          <p:cNvPr id="20" name="Connector 19"/>
           <p:cNvCxnSpPr/>
           <p:nvPr/>
         </p:nvCxnSpPr>
         <p:spPr>
           <a:xfrm>
-            <a:off x="9006840" y="3886200"/>
-            <a:ext cx="0" cy="274320"/>
+            <a:off x="9985248" y="3419856"/>
+            <a:ext cx="0" cy="384048"/>
           </a:xfrm>
           <a:prstGeom prst="line">
             <a:avLst/>
@@ -3706,6 +4078,59 @@
           </a:fontRef>
         </p:style>
       </p:cxnSp>
+      <p:sp>
+        <p:nvSpPr>
+          <p:cNvPr id="21" name="Rectangle 20"/>
+          <p:cNvSpPr/>
+          <p:nvPr/>
+        </p:nvSpPr>
+        <p:spPr>
+          <a:xfrm>
+            <a:off x="8705088" y="4736592"/>
+            <a:ext cx="2578608" cy="603504"/>
+          </a:xfrm>
+          <a:prstGeom prst="rect">
+            <a:avLst/>
+          </a:prstGeom>
+          <a:noFill/>
+          <a:ln>
+            <a:noFill/>
+          </a:ln>
+        </p:spPr>
+        <p:style>
+          <a:lnRef idx="1">
+            <a:schemeClr val="accent1"/>
+          </a:lnRef>
+          <a:fillRef idx="3">
+            <a:schemeClr val="accent1"/>
+          </a:fillRef>
+          <a:effectRef idx="2">
+            <a:schemeClr val="accent1"/>
+          </a:effectRef>
+          <a:fontRef idx="minor">
+            <a:schemeClr val="lt1"/>
+          </a:fontRef>
+        </p:style>
+        <p:txBody>
+          <a:bodyPr rtlCol="0" anchor="ctr" wrap="square" tIns="91440" bIns="91440">
+            <a:noAutofit/>
+          </a:bodyPr>
+          <a:lstStyle/>
+          <a:p>
+            <a:pPr algn="ctr"/>
+            <a:r>
+              <a:rPr sz="1300" b="0">
+                <a:solidFill>
+                  <a:srgbClr val="64748B"/>
+                </a:solidFill>
+                <a:latin typeface="Aptos"/>
+              </a:rPr>
+              <a:t>independent scaling
++ direct KV path</a:t>
+            </a:r>
+          </a:p>
+        </p:txBody>
+      </p:sp>
     </p:spTree>
   </p:cSld>
   <p:clrMapOvr>
@@ -4964,8 +5389,114 @@
         </p:nvSpPr>
         <p:spPr>
           <a:xfrm>
-            <a:off x="777240" y="1371600"/>
-            <a:ext cx="2514600" cy="4297680"/>
+            <a:off x="804672" y="1143000"/>
+            <a:ext cx="10698480" cy="566928"/>
+          </a:xfrm>
+          <a:prstGeom prst="roundRect">
+            <a:avLst/>
+          </a:prstGeom>
+          <a:solidFill>
+            <a:srgbClr val="FFFFFF"/>
+          </a:solidFill>
+          <a:ln>
+            <a:noFill/>
+          </a:ln>
+        </p:spPr>
+        <p:style>
+          <a:lnRef idx="1">
+            <a:schemeClr val="accent1"/>
+          </a:lnRef>
+          <a:fillRef idx="3">
+            <a:schemeClr val="accent1"/>
+          </a:fillRef>
+          <a:effectRef idx="2">
+            <a:schemeClr val="accent1"/>
+          </a:effectRef>
+          <a:fontRef idx="minor">
+            <a:schemeClr val="lt1"/>
+          </a:fontRef>
+        </p:style>
+        <p:txBody>
+          <a:bodyPr rtlCol="0" anchor="ctr" wrap="square" tIns="91440" bIns="91440">
+            <a:noAutofit/>
+          </a:bodyPr>
+          <a:lstStyle/>
+          <a:p>
+            <a:pPr algn="ctr"/>
+            <a:r>
+              <a:rPr sz="2100" b="1">
+                <a:solidFill>
+                  <a:srgbClr val="0F172A"/>
+                </a:solidFill>
+                <a:latin typeface="Aptos"/>
+              </a:rPr>
+              <a:t>KAITO grows in layers: serving -&gt; scaling -&gt; routing -&gt; distributed topology</a:t>
+            </a:r>
+          </a:p>
+        </p:txBody>
+      </p:sp>
+      <p:sp>
+        <p:nvSpPr>
+          <p:cNvPr id="7" name="Rectangle 6"/>
+          <p:cNvSpPr/>
+          <p:nvPr/>
+        </p:nvSpPr>
+        <p:spPr>
+          <a:xfrm>
+            <a:off x="868680" y="1581912"/>
+            <a:ext cx="2331720" cy="292608"/>
+          </a:xfrm>
+          <a:prstGeom prst="rect">
+            <a:avLst/>
+          </a:prstGeom>
+          <a:noFill/>
+          <a:ln>
+            <a:noFill/>
+          </a:ln>
+        </p:spPr>
+        <p:style>
+          <a:lnRef idx="1">
+            <a:schemeClr val="accent1"/>
+          </a:lnRef>
+          <a:fillRef idx="3">
+            <a:schemeClr val="accent1"/>
+          </a:fillRef>
+          <a:effectRef idx="2">
+            <a:schemeClr val="accent1"/>
+          </a:effectRef>
+          <a:fontRef idx="minor">
+            <a:schemeClr val="lt1"/>
+          </a:fontRef>
+        </p:style>
+        <p:txBody>
+          <a:bodyPr rtlCol="0" anchor="ctr" wrap="square" tIns="91440" bIns="91440">
+            <a:noAutofit/>
+          </a:bodyPr>
+          <a:lstStyle/>
+          <a:p>
+            <a:pPr algn="ctr"/>
+            <a:r>
+              <a:rPr sz="1200" b="1">
+                <a:solidFill>
+                  <a:srgbClr val="2563EB"/>
+                </a:solidFill>
+                <a:latin typeface="Aptos"/>
+              </a:rPr>
+              <a:t>Serving</a:t>
+            </a:r>
+          </a:p>
+        </p:txBody>
+      </p:sp>
+      <p:sp>
+        <p:nvSpPr>
+          <p:cNvPr id="8" name="Rounded Rectangle 7"/>
+          <p:cNvSpPr/>
+          <p:nvPr/>
+        </p:nvSpPr>
+        <p:spPr>
+          <a:xfrm>
+            <a:off x="868680" y="1965960"/>
+            <a:ext cx="2331720" cy="3611880"/>
           </a:xfrm>
           <a:prstGeom prst="roundRect">
             <a:avLst/>
@@ -5014,14 +5545,14 @@
       </p:sp>
       <p:sp>
         <p:nvSpPr>
-          <p:cNvPr id="7" name="Rectangle 6"/>
-          <p:cNvSpPr/>
-          <p:nvPr/>
-        </p:nvSpPr>
-        <p:spPr>
-          <a:xfrm>
-            <a:off x="941832" y="1463040"/>
-            <a:ext cx="2185416" cy="384048"/>
+          <p:cNvPr id="9" name="Rectangle 8"/>
+          <p:cNvSpPr/>
+          <p:nvPr/>
+        </p:nvSpPr>
+        <p:spPr>
+          <a:xfrm>
+            <a:off x="1033272" y="2057400"/>
+            <a:ext cx="2002536" cy="384048"/>
           </a:xfrm>
           <a:prstGeom prst="rect">
             <a:avLst/>
@@ -5066,14 +5597,14 @@
       </p:sp>
       <p:sp>
         <p:nvSpPr>
-          <p:cNvPr id="8" name="TextBox 7"/>
+          <p:cNvPr id="10" name="TextBox 9"/>
           <p:cNvSpPr txBox="1"/>
           <p:nvPr/>
         </p:nvSpPr>
         <p:spPr>
           <a:xfrm>
-            <a:off x="960120" y="1901952"/>
-            <a:ext cx="2148840" cy="3639312"/>
+            <a:off x="1051560" y="2496312"/>
+            <a:ext cx="1965960" cy="2953512"/>
           </a:xfrm>
           <a:prstGeom prst="rect">
             <a:avLst/>
@@ -5127,21 +5658,116 @@
               </a:defRPr>
             </a:pPr>
             <a:r>
-              <a:t>Basic building block</a:t>
-            </a:r>
-          </a:p>
-        </p:txBody>
-      </p:sp>
-      <p:sp>
-        <p:nvSpPr>
-          <p:cNvPr id="9" name="Rounded Rectangle 8"/>
-          <p:cNvSpPr/>
-          <p:nvPr/>
-        </p:nvSpPr>
-        <p:spPr>
-          <a:xfrm>
-            <a:off x="3429000" y="1965960"/>
-            <a:ext cx="2514600" cy="3703320"/>
+              <a:t>The basic workload entrypoint</a:t>
+            </a:r>
+          </a:p>
+        </p:txBody>
+      </p:sp>
+      <p:sp>
+        <p:nvSpPr>
+          <p:cNvPr id="11" name="Rounded Rectangle 10"/>
+          <p:cNvSpPr/>
+          <p:nvPr/>
+        </p:nvSpPr>
+        <p:spPr>
+          <a:xfrm>
+            <a:off x="1033272" y="2130552"/>
+            <a:ext cx="2002536" cy="146304"/>
+          </a:xfrm>
+          <a:prstGeom prst="roundRect">
+            <a:avLst/>
+          </a:prstGeom>
+          <a:solidFill>
+            <a:srgbClr val="DBEAFE"/>
+          </a:solidFill>
+          <a:ln>
+            <a:noFill/>
+          </a:ln>
+        </p:spPr>
+        <p:style>
+          <a:lnRef idx="1">
+            <a:schemeClr val="accent1"/>
+          </a:lnRef>
+          <a:fillRef idx="3">
+            <a:schemeClr val="accent1"/>
+          </a:fillRef>
+          <a:effectRef idx="2">
+            <a:schemeClr val="accent1"/>
+          </a:effectRef>
+          <a:fontRef idx="minor">
+            <a:schemeClr val="lt1"/>
+          </a:fontRef>
+        </p:style>
+        <p:txBody>
+          <a:bodyPr rtlCol="0" anchor="ctr"/>
+          <a:lstStyle/>
+          <a:p>
+            <a:pPr algn="ctr"/>
+          </a:p>
+        </p:txBody>
+      </p:sp>
+      <p:sp>
+        <p:nvSpPr>
+          <p:cNvPr id="12" name="Rectangle 11"/>
+          <p:cNvSpPr/>
+          <p:nvPr/>
+        </p:nvSpPr>
+        <p:spPr>
+          <a:xfrm>
+            <a:off x="3383280" y="1901952"/>
+            <a:ext cx="2331720" cy="292608"/>
+          </a:xfrm>
+          <a:prstGeom prst="rect">
+            <a:avLst/>
+          </a:prstGeom>
+          <a:noFill/>
+          <a:ln>
+            <a:noFill/>
+          </a:ln>
+        </p:spPr>
+        <p:style>
+          <a:lnRef idx="1">
+            <a:schemeClr val="accent1"/>
+          </a:lnRef>
+          <a:fillRef idx="3">
+            <a:schemeClr val="accent1"/>
+          </a:fillRef>
+          <a:effectRef idx="2">
+            <a:schemeClr val="accent1"/>
+          </a:effectRef>
+          <a:fontRef idx="minor">
+            <a:schemeClr val="lt1"/>
+          </a:fontRef>
+        </p:style>
+        <p:txBody>
+          <a:bodyPr rtlCol="0" anchor="ctr" wrap="square" tIns="91440" bIns="91440">
+            <a:noAutofit/>
+          </a:bodyPr>
+          <a:lstStyle/>
+          <a:p>
+            <a:pPr algn="ctr"/>
+            <a:r>
+              <a:rPr sz="1200" b="1">
+                <a:solidFill>
+                  <a:srgbClr val="16A34A"/>
+                </a:solidFill>
+                <a:latin typeface="Aptos"/>
+              </a:rPr>
+              <a:t>Scaling</a:t>
+            </a:r>
+          </a:p>
+        </p:txBody>
+      </p:sp>
+      <p:sp>
+        <p:nvSpPr>
+          <p:cNvPr id="13" name="Rounded Rectangle 12"/>
+          <p:cNvSpPr/>
+          <p:nvPr/>
+        </p:nvSpPr>
+        <p:spPr>
+          <a:xfrm>
+            <a:off x="3383280" y="2286000"/>
+            <a:ext cx="2331720" cy="3291840"/>
           </a:xfrm>
           <a:prstGeom prst="roundRect">
             <a:avLst/>
@@ -5190,14 +5816,14 @@
       </p:sp>
       <p:sp>
         <p:nvSpPr>
-          <p:cNvPr id="10" name="Rectangle 9"/>
-          <p:cNvSpPr/>
-          <p:nvPr/>
-        </p:nvSpPr>
-        <p:spPr>
-          <a:xfrm>
-            <a:off x="3593592" y="2057400"/>
-            <a:ext cx="2185416" cy="384048"/>
+          <p:cNvPr id="14" name="Rectangle 13"/>
+          <p:cNvSpPr/>
+          <p:nvPr/>
+        </p:nvSpPr>
+        <p:spPr>
+          <a:xfrm>
+            <a:off x="3547872" y="2377440"/>
+            <a:ext cx="2002536" cy="384048"/>
           </a:xfrm>
           <a:prstGeom prst="rect">
             <a:avLst/>
@@ -5242,14 +5868,14 @@
       </p:sp>
       <p:sp>
         <p:nvSpPr>
-          <p:cNvPr id="11" name="TextBox 10"/>
+          <p:cNvPr id="15" name="TextBox 14"/>
           <p:cNvSpPr txBox="1"/>
           <p:nvPr/>
         </p:nvSpPr>
         <p:spPr>
           <a:xfrm>
-            <a:off x="3611880" y="2496312"/>
-            <a:ext cx="2148840" cy="3044952"/>
+            <a:off x="3566160" y="2816352"/>
+            <a:ext cx="1965960" cy="2633472"/>
           </a:xfrm>
           <a:prstGeom prst="rect">
             <a:avLst/>
@@ -5310,14 +5936,109 @@
       </p:sp>
       <p:sp>
         <p:nvSpPr>
-          <p:cNvPr id="12" name="Rounded Rectangle 11"/>
-          <p:cNvSpPr/>
-          <p:nvPr/>
-        </p:nvSpPr>
-        <p:spPr>
-          <a:xfrm>
-            <a:off x="6080760" y="2560320"/>
-            <a:ext cx="2514600" cy="3108960"/>
+          <p:cNvPr id="16" name="Rounded Rectangle 15"/>
+          <p:cNvSpPr/>
+          <p:nvPr/>
+        </p:nvSpPr>
+        <p:spPr>
+          <a:xfrm>
+            <a:off x="3547872" y="2450592"/>
+            <a:ext cx="2002536" cy="146304"/>
+          </a:xfrm>
+          <a:prstGeom prst="roundRect">
+            <a:avLst/>
+          </a:prstGeom>
+          <a:solidFill>
+            <a:srgbClr val="DCFCE7"/>
+          </a:solidFill>
+          <a:ln>
+            <a:noFill/>
+          </a:ln>
+        </p:spPr>
+        <p:style>
+          <a:lnRef idx="1">
+            <a:schemeClr val="accent1"/>
+          </a:lnRef>
+          <a:fillRef idx="3">
+            <a:schemeClr val="accent1"/>
+          </a:fillRef>
+          <a:effectRef idx="2">
+            <a:schemeClr val="accent1"/>
+          </a:effectRef>
+          <a:fontRef idx="minor">
+            <a:schemeClr val="lt1"/>
+          </a:fontRef>
+        </p:style>
+        <p:txBody>
+          <a:bodyPr rtlCol="0" anchor="ctr"/>
+          <a:lstStyle/>
+          <a:p>
+            <a:pPr algn="ctr"/>
+          </a:p>
+        </p:txBody>
+      </p:sp>
+      <p:sp>
+        <p:nvSpPr>
+          <p:cNvPr id="17" name="Rectangle 16"/>
+          <p:cNvSpPr/>
+          <p:nvPr/>
+        </p:nvSpPr>
+        <p:spPr>
+          <a:xfrm>
+            <a:off x="5897880" y="2221992"/>
+            <a:ext cx="2331720" cy="292608"/>
+          </a:xfrm>
+          <a:prstGeom prst="rect">
+            <a:avLst/>
+          </a:prstGeom>
+          <a:noFill/>
+          <a:ln>
+            <a:noFill/>
+          </a:ln>
+        </p:spPr>
+        <p:style>
+          <a:lnRef idx="1">
+            <a:schemeClr val="accent1"/>
+          </a:lnRef>
+          <a:fillRef idx="3">
+            <a:schemeClr val="accent1"/>
+          </a:fillRef>
+          <a:effectRef idx="2">
+            <a:schemeClr val="accent1"/>
+          </a:effectRef>
+          <a:fontRef idx="minor">
+            <a:schemeClr val="lt1"/>
+          </a:fontRef>
+        </p:style>
+        <p:txBody>
+          <a:bodyPr rtlCol="0" anchor="ctr" wrap="square" tIns="91440" bIns="91440">
+            <a:noAutofit/>
+          </a:bodyPr>
+          <a:lstStyle/>
+          <a:p>
+            <a:pPr algn="ctr"/>
+            <a:r>
+              <a:rPr sz="1200" b="1">
+                <a:solidFill>
+                  <a:srgbClr val="EA580C"/>
+                </a:solidFill>
+                <a:latin typeface="Aptos"/>
+              </a:rPr>
+              <a:t>Routing</a:t>
+            </a:r>
+          </a:p>
+        </p:txBody>
+      </p:sp>
+      <p:sp>
+        <p:nvSpPr>
+          <p:cNvPr id="18" name="Rounded Rectangle 17"/>
+          <p:cNvSpPr/>
+          <p:nvPr/>
+        </p:nvSpPr>
+        <p:spPr>
+          <a:xfrm>
+            <a:off x="5897880" y="2606040"/>
+            <a:ext cx="2331720" cy="2971800"/>
           </a:xfrm>
           <a:prstGeom prst="roundRect">
             <a:avLst/>
@@ -5366,14 +6087,14 @@
       </p:sp>
       <p:sp>
         <p:nvSpPr>
-          <p:cNvPr id="13" name="Rectangle 12"/>
-          <p:cNvSpPr/>
-          <p:nvPr/>
-        </p:nvSpPr>
-        <p:spPr>
-          <a:xfrm>
-            <a:off x="6245352" y="2651760"/>
-            <a:ext cx="2185416" cy="384048"/>
+          <p:cNvPr id="19" name="Rectangle 18"/>
+          <p:cNvSpPr/>
+          <p:nvPr/>
+        </p:nvSpPr>
+        <p:spPr>
+          <a:xfrm>
+            <a:off x="6062472" y="2697480"/>
+            <a:ext cx="2002536" cy="384048"/>
           </a:xfrm>
           <a:prstGeom prst="rect">
             <a:avLst/>
@@ -5418,14 +6139,14 @@
       </p:sp>
       <p:sp>
         <p:nvSpPr>
-          <p:cNvPr id="14" name="TextBox 13"/>
+          <p:cNvPr id="20" name="TextBox 19"/>
           <p:cNvSpPr txBox="1"/>
           <p:nvPr/>
         </p:nvSpPr>
         <p:spPr>
           <a:xfrm>
-            <a:off x="6263640" y="3090672"/>
-            <a:ext cx="2148840" cy="2450592"/>
+            <a:off x="6080760" y="3136392"/>
+            <a:ext cx="1965960" cy="2313432"/>
           </a:xfrm>
           <a:prstGeom prst="rect">
             <a:avLst/>
@@ -5486,14 +6207,109 @@
       </p:sp>
       <p:sp>
         <p:nvSpPr>
-          <p:cNvPr id="15" name="Rounded Rectangle 14"/>
-          <p:cNvSpPr/>
-          <p:nvPr/>
-        </p:nvSpPr>
-        <p:spPr>
-          <a:xfrm>
-            <a:off x="8732520" y="3154680"/>
-            <a:ext cx="2514600" cy="2514600"/>
+          <p:cNvPr id="21" name="Rounded Rectangle 20"/>
+          <p:cNvSpPr/>
+          <p:nvPr/>
+        </p:nvSpPr>
+        <p:spPr>
+          <a:xfrm>
+            <a:off x="6062472" y="2770632"/>
+            <a:ext cx="2002536" cy="146304"/>
+          </a:xfrm>
+          <a:prstGeom prst="roundRect">
+            <a:avLst/>
+          </a:prstGeom>
+          <a:solidFill>
+            <a:srgbClr val="FFEDD5"/>
+          </a:solidFill>
+          <a:ln>
+            <a:noFill/>
+          </a:ln>
+        </p:spPr>
+        <p:style>
+          <a:lnRef idx="1">
+            <a:schemeClr val="accent1"/>
+          </a:lnRef>
+          <a:fillRef idx="3">
+            <a:schemeClr val="accent1"/>
+          </a:fillRef>
+          <a:effectRef idx="2">
+            <a:schemeClr val="accent1"/>
+          </a:effectRef>
+          <a:fontRef idx="minor">
+            <a:schemeClr val="lt1"/>
+          </a:fontRef>
+        </p:style>
+        <p:txBody>
+          <a:bodyPr rtlCol="0" anchor="ctr"/>
+          <a:lstStyle/>
+          <a:p>
+            <a:pPr algn="ctr"/>
+          </a:p>
+        </p:txBody>
+      </p:sp>
+      <p:sp>
+        <p:nvSpPr>
+          <p:cNvPr id="22" name="Rectangle 21"/>
+          <p:cNvSpPr/>
+          <p:nvPr/>
+        </p:nvSpPr>
+        <p:spPr>
+          <a:xfrm>
+            <a:off x="8412480" y="2542032"/>
+            <a:ext cx="2331720" cy="292608"/>
+          </a:xfrm>
+          <a:prstGeom prst="rect">
+            <a:avLst/>
+          </a:prstGeom>
+          <a:noFill/>
+          <a:ln>
+            <a:noFill/>
+          </a:ln>
+        </p:spPr>
+        <p:style>
+          <a:lnRef idx="1">
+            <a:schemeClr val="accent1"/>
+          </a:lnRef>
+          <a:fillRef idx="3">
+            <a:schemeClr val="accent1"/>
+          </a:fillRef>
+          <a:effectRef idx="2">
+            <a:schemeClr val="accent1"/>
+          </a:effectRef>
+          <a:fontRef idx="minor">
+            <a:schemeClr val="lt1"/>
+          </a:fontRef>
+        </p:style>
+        <p:txBody>
+          <a:bodyPr rtlCol="0" anchor="ctr" wrap="square" tIns="91440" bIns="91440">
+            <a:noAutofit/>
+          </a:bodyPr>
+          <a:lstStyle/>
+          <a:p>
+            <a:pPr algn="ctr"/>
+            <a:r>
+              <a:rPr sz="1200" b="1">
+                <a:solidFill>
+                  <a:srgbClr val="6D28D9"/>
+                </a:solidFill>
+                <a:latin typeface="Aptos"/>
+              </a:rPr>
+              <a:t>Topology</a:t>
+            </a:r>
+          </a:p>
+        </p:txBody>
+      </p:sp>
+      <p:sp>
+        <p:nvSpPr>
+          <p:cNvPr id="23" name="Rounded Rectangle 22"/>
+          <p:cNvSpPr/>
+          <p:nvPr/>
+        </p:nvSpPr>
+        <p:spPr>
+          <a:xfrm>
+            <a:off x="8412480" y="2926080"/>
+            <a:ext cx="2331720" cy="2651760"/>
           </a:xfrm>
           <a:prstGeom prst="roundRect">
             <a:avLst/>
@@ -5542,14 +6358,14 @@
       </p:sp>
       <p:sp>
         <p:nvSpPr>
-          <p:cNvPr id="16" name="Rectangle 15"/>
-          <p:cNvSpPr/>
-          <p:nvPr/>
-        </p:nvSpPr>
-        <p:spPr>
-          <a:xfrm>
-            <a:off x="8897112" y="3246120"/>
-            <a:ext cx="2185416" cy="384048"/>
+          <p:cNvPr id="24" name="Rectangle 23"/>
+          <p:cNvSpPr/>
+          <p:nvPr/>
+        </p:nvSpPr>
+        <p:spPr>
+          <a:xfrm>
+            <a:off x="8577072" y="3017520"/>
+            <a:ext cx="2002536" cy="384048"/>
           </a:xfrm>
           <a:prstGeom prst="rect">
             <a:avLst/>
@@ -5594,14 +6410,14 @@
       </p:sp>
       <p:sp>
         <p:nvSpPr>
-          <p:cNvPr id="17" name="TextBox 16"/>
+          <p:cNvPr id="25" name="TextBox 24"/>
           <p:cNvSpPr txBox="1"/>
           <p:nvPr/>
         </p:nvSpPr>
         <p:spPr>
           <a:xfrm>
-            <a:off x="8915400" y="3685032"/>
-            <a:ext cx="2148840" cy="1856232"/>
+            <a:off x="8595360" y="3456432"/>
+            <a:ext cx="1965960" cy="1993392"/>
           </a:xfrm>
           <a:prstGeom prst="rect">
             <a:avLst/>
@@ -5660,16 +6476,59 @@
           </a:p>
         </p:txBody>
       </p:sp>
+      <p:sp>
+        <p:nvSpPr>
+          <p:cNvPr id="26" name="Rounded Rectangle 25"/>
+          <p:cNvSpPr/>
+          <p:nvPr/>
+        </p:nvSpPr>
+        <p:spPr>
+          <a:xfrm>
+            <a:off x="8577072" y="3090672"/>
+            <a:ext cx="2002536" cy="146304"/>
+          </a:xfrm>
+          <a:prstGeom prst="roundRect">
+            <a:avLst/>
+          </a:prstGeom>
+          <a:solidFill>
+            <a:srgbClr val="EDE9FE"/>
+          </a:solidFill>
+          <a:ln>
+            <a:noFill/>
+          </a:ln>
+        </p:spPr>
+        <p:style>
+          <a:lnRef idx="1">
+            <a:schemeClr val="accent1"/>
+          </a:lnRef>
+          <a:fillRef idx="3">
+            <a:schemeClr val="accent1"/>
+          </a:fillRef>
+          <a:effectRef idx="2">
+            <a:schemeClr val="accent1"/>
+          </a:effectRef>
+          <a:fontRef idx="minor">
+            <a:schemeClr val="lt1"/>
+          </a:fontRef>
+        </p:style>
+        <p:txBody>
+          <a:bodyPr rtlCol="0" anchor="ctr"/>
+          <a:lstStyle/>
+          <a:p>
+            <a:pPr algn="ctr"/>
+          </a:p>
+        </p:txBody>
+      </p:sp>
       <p:cxnSp>
         <p:nvCxnSpPr>
-          <p:cNvPr id="18" name="Connector 17"/>
+          <p:cNvPr id="27" name="Connector 26"/>
           <p:cNvCxnSpPr/>
           <p:nvPr/>
         </p:nvCxnSpPr>
         <p:spPr>
           <a:xfrm>
-            <a:off x="3291840" y="3429000"/>
-            <a:ext cx="137160" cy="320039"/>
+            <a:off x="3200400" y="3886200"/>
+            <a:ext cx="182880" cy="0"/>
           </a:xfrm>
           <a:prstGeom prst="line">
             <a:avLst/>
@@ -5697,14 +6556,14 @@
       </p:cxnSp>
       <p:cxnSp>
         <p:nvCxnSpPr>
-          <p:cNvPr id="19" name="Connector 18"/>
+          <p:cNvPr id="28" name="Connector 27"/>
           <p:cNvCxnSpPr/>
           <p:nvPr/>
         </p:nvCxnSpPr>
         <p:spPr>
           <a:xfrm>
-            <a:off x="5943600" y="3749039"/>
-            <a:ext cx="137160" cy="320041"/>
+            <a:off x="5715000" y="4206240"/>
+            <a:ext cx="182880" cy="0"/>
           </a:xfrm>
           <a:prstGeom prst="line">
             <a:avLst/>
@@ -5732,14 +6591,14 @@
       </p:cxnSp>
       <p:cxnSp>
         <p:nvCxnSpPr>
-          <p:cNvPr id="20" name="Connector 19"/>
+          <p:cNvPr id="29" name="Connector 28"/>
           <p:cNvCxnSpPr/>
           <p:nvPr/>
         </p:nvCxnSpPr>
         <p:spPr>
           <a:xfrm>
-            <a:off x="8595360" y="4069080"/>
-            <a:ext cx="137160" cy="320040"/>
+            <a:off x="8229600" y="4526280"/>
+            <a:ext cx="182880" cy="0"/>
           </a:xfrm>
           <a:prstGeom prst="line">
             <a:avLst/>
@@ -5765,6 +6624,58 @@
           </a:fontRef>
         </p:style>
       </p:cxnSp>
+      <p:sp>
+        <p:nvSpPr>
+          <p:cNvPr id="30" name="Rectangle 29"/>
+          <p:cNvSpPr/>
+          <p:nvPr/>
+        </p:nvSpPr>
+        <p:spPr>
+          <a:xfrm>
+            <a:off x="1600200" y="5870448"/>
+            <a:ext cx="9052560" cy="365760"/>
+          </a:xfrm>
+          <a:prstGeom prst="rect">
+            <a:avLst/>
+          </a:prstGeom>
+          <a:noFill/>
+          <a:ln>
+            <a:noFill/>
+          </a:ln>
+        </p:spPr>
+        <p:style>
+          <a:lnRef idx="1">
+            <a:schemeClr val="accent1"/>
+          </a:lnRef>
+          <a:fillRef idx="3">
+            <a:schemeClr val="accent1"/>
+          </a:fillRef>
+          <a:effectRef idx="2">
+            <a:schemeClr val="accent1"/>
+          </a:effectRef>
+          <a:fontRef idx="minor">
+            <a:schemeClr val="lt1"/>
+          </a:fontRef>
+        </p:style>
+        <p:txBody>
+          <a:bodyPr rtlCol="0" anchor="ctr" wrap="square" tIns="91440" bIns="91440">
+            <a:noAutofit/>
+          </a:bodyPr>
+          <a:lstStyle/>
+          <a:p>
+            <a:pPr algn="ctr"/>
+            <a:r>
+              <a:rPr sz="1400" b="0">
+                <a:solidFill>
+                  <a:srgbClr val="64748B"/>
+                </a:solidFill>
+                <a:latin typeface="Aptos"/>
+              </a:rPr>
+              <a:t>The object model stays consistent even as the inference topology becomes more advanced.</a:t>
+            </a:r>
+          </a:p>
+        </p:txBody>
+      </p:sp>
     </p:spTree>
   </p:cSld>
   <p:clrMapOvr>
@@ -8728,8 +9639,155 @@
         </p:nvSpPr>
         <p:spPr>
           <a:xfrm>
-            <a:off x="502920" y="2743200"/>
-            <a:ext cx="1097280" cy="731520"/>
+            <a:off x="731520" y="1325880"/>
+            <a:ext cx="10835640" cy="4526280"/>
+          </a:xfrm>
+          <a:prstGeom prst="roundRect">
+            <a:avLst/>
+          </a:prstGeom>
+          <a:solidFill>
+            <a:srgbClr val="FFFFFF"/>
+          </a:solidFill>
+          <a:ln>
+            <a:noFill/>
+          </a:ln>
+        </p:spPr>
+        <p:style>
+          <a:lnRef idx="1">
+            <a:schemeClr val="accent1"/>
+          </a:lnRef>
+          <a:fillRef idx="3">
+            <a:schemeClr val="accent1"/>
+          </a:fillRef>
+          <a:effectRef idx="2">
+            <a:schemeClr val="accent1"/>
+          </a:effectRef>
+          <a:fontRef idx="minor">
+            <a:schemeClr val="lt1"/>
+          </a:fontRef>
+        </p:style>
+        <p:txBody>
+          <a:bodyPr rtlCol="0" anchor="ctr"/>
+          <a:lstStyle/>
+          <a:p>
+            <a:pPr algn="ctr"/>
+          </a:p>
+        </p:txBody>
+      </p:sp>
+      <p:sp>
+        <p:nvSpPr>
+          <p:cNvPr id="7" name="Rectangle 6"/>
+          <p:cNvSpPr/>
+          <p:nvPr/>
+        </p:nvSpPr>
+        <p:spPr>
+          <a:xfrm>
+            <a:off x="960120" y="1572768"/>
+            <a:ext cx="1097280" cy="256032"/>
+          </a:xfrm>
+          <a:prstGeom prst="rect">
+            <a:avLst/>
+          </a:prstGeom>
+          <a:noFill/>
+          <a:ln>
+            <a:noFill/>
+          </a:ln>
+        </p:spPr>
+        <p:style>
+          <a:lnRef idx="1">
+            <a:schemeClr val="accent1"/>
+          </a:lnRef>
+          <a:fillRef idx="3">
+            <a:schemeClr val="accent1"/>
+          </a:fillRef>
+          <a:effectRef idx="2">
+            <a:schemeClr val="accent1"/>
+          </a:effectRef>
+          <a:fontRef idx="minor">
+            <a:schemeClr val="lt1"/>
+          </a:fontRef>
+        </p:style>
+        <p:txBody>
+          <a:bodyPr rtlCol="0" anchor="ctr" wrap="square" tIns="91440" bIns="91440">
+            <a:noAutofit/>
+          </a:bodyPr>
+          <a:lstStyle/>
+          <a:p>
+            <a:pPr algn="ctr"/>
+            <a:r>
+              <a:rPr sz="1200" b="1">
+                <a:solidFill>
+                  <a:srgbClr val="2563EB"/>
+                </a:solidFill>
+                <a:latin typeface="Aptos"/>
+              </a:rPr>
+              <a:t>request path</a:t>
+            </a:r>
+          </a:p>
+        </p:txBody>
+      </p:sp>
+      <p:sp>
+        <p:nvSpPr>
+          <p:cNvPr id="8" name="Rectangle 7"/>
+          <p:cNvSpPr/>
+          <p:nvPr/>
+        </p:nvSpPr>
+        <p:spPr>
+          <a:xfrm>
+            <a:off x="960120" y="4709160"/>
+            <a:ext cx="1097280" cy="256032"/>
+          </a:xfrm>
+          <a:prstGeom prst="rect">
+            <a:avLst/>
+          </a:prstGeom>
+          <a:noFill/>
+          <a:ln>
+            <a:noFill/>
+          </a:ln>
+        </p:spPr>
+        <p:style>
+          <a:lnRef idx="1">
+            <a:schemeClr val="accent1"/>
+          </a:lnRef>
+          <a:fillRef idx="3">
+            <a:schemeClr val="accent1"/>
+          </a:fillRef>
+          <a:effectRef idx="2">
+            <a:schemeClr val="accent1"/>
+          </a:effectRef>
+          <a:fontRef idx="minor">
+            <a:schemeClr val="lt1"/>
+          </a:fontRef>
+        </p:style>
+        <p:txBody>
+          <a:bodyPr rtlCol="0" anchor="ctr" wrap="square" tIns="91440" bIns="91440">
+            <a:noAutofit/>
+          </a:bodyPr>
+          <a:lstStyle/>
+          <a:p>
+            <a:pPr algn="ctr"/>
+            <a:r>
+              <a:rPr sz="1200" b="1">
+                <a:solidFill>
+                  <a:srgbClr val="6D28D9"/>
+                </a:solidFill>
+                <a:latin typeface="Aptos"/>
+              </a:rPr>
+              <a:t>KV path</a:t>
+            </a:r>
+          </a:p>
+        </p:txBody>
+      </p:sp>
+      <p:sp>
+        <p:nvSpPr>
+          <p:cNvPr id="9" name="Rounded Rectangle 8"/>
+          <p:cNvSpPr/>
+          <p:nvPr/>
+        </p:nvSpPr>
+        <p:spPr>
+          <a:xfrm>
+            <a:off x="960120" y="2057400"/>
+            <a:ext cx="1005840" cy="713232"/>
           </a:xfrm>
           <a:prstGeom prst="roundRect">
             <a:avLst/>
@@ -8778,14 +9836,14 @@
       </p:sp>
       <p:sp>
         <p:nvSpPr>
-          <p:cNvPr id="7" name="Rounded Rectangle 6"/>
-          <p:cNvSpPr/>
-          <p:nvPr/>
-        </p:nvSpPr>
-        <p:spPr>
-          <a:xfrm>
-            <a:off x="1783080" y="2743200"/>
-            <a:ext cx="1371600" cy="731520"/>
+          <p:cNvPr id="10" name="Rounded Rectangle 9"/>
+          <p:cNvSpPr/>
+          <p:nvPr/>
+        </p:nvSpPr>
+        <p:spPr>
+          <a:xfrm>
+            <a:off x="2148840" y="2057400"/>
+            <a:ext cx="1325880" cy="713232"/>
           </a:xfrm>
           <a:prstGeom prst="roundRect">
             <a:avLst/>
@@ -8834,14 +9892,14 @@
       </p:sp>
       <p:sp>
         <p:nvSpPr>
-          <p:cNvPr id="8" name="Rounded Rectangle 7"/>
-          <p:cNvSpPr/>
-          <p:nvPr/>
-        </p:nvSpPr>
-        <p:spPr>
-          <a:xfrm>
-            <a:off x="3429000" y="2468880"/>
-            <a:ext cx="2011680" cy="1280160"/>
+          <p:cNvPr id="11" name="Rounded Rectangle 10"/>
+          <p:cNvSpPr/>
+          <p:nvPr/>
+        </p:nvSpPr>
+        <p:spPr>
+          <a:xfrm>
+            <a:off x="3703320" y="1874519"/>
+            <a:ext cx="1965960" cy="1078992"/>
           </a:xfrm>
           <a:prstGeom prst="roundRect">
             <a:avLst/>
@@ -8877,7 +9935,7 @@
           <a:p>
             <a:pPr algn="ctr"/>
             <a:r>
-              <a:rPr sz="1900" b="1">
+              <a:rPr sz="1800" b="1">
                 <a:solidFill>
                   <a:srgbClr val="0F172A"/>
                 </a:solidFill>
@@ -8891,14 +9949,14 @@
       </p:sp>
       <p:sp>
         <p:nvSpPr>
-          <p:cNvPr id="9" name="Rounded Rectangle 8"/>
-          <p:cNvSpPr/>
-          <p:nvPr/>
-        </p:nvSpPr>
-        <p:spPr>
-          <a:xfrm>
-            <a:off x="5897880" y="1600200"/>
-            <a:ext cx="2377440" cy="1234440"/>
+          <p:cNvPr id="12" name="Rounded Rectangle 11"/>
+          <p:cNvSpPr/>
+          <p:nvPr/>
+        </p:nvSpPr>
+        <p:spPr>
+          <a:xfrm>
+            <a:off x="6080760" y="1417320"/>
+            <a:ext cx="2240280" cy="987552"/>
           </a:xfrm>
           <a:prstGeom prst="roundRect">
             <a:avLst/>
@@ -8934,7 +9992,7 @@
           <a:p>
             <a:pPr algn="ctr"/>
             <a:r>
-              <a:rPr sz="1900" b="1">
+              <a:rPr sz="1800" b="1">
                 <a:solidFill>
                   <a:srgbClr val="0F172A"/>
                 </a:solidFill>
@@ -8948,14 +10006,14 @@
       </p:sp>
       <p:sp>
         <p:nvSpPr>
-          <p:cNvPr id="10" name="Rounded Rectangle 9"/>
-          <p:cNvSpPr/>
-          <p:nvPr/>
-        </p:nvSpPr>
-        <p:spPr>
-          <a:xfrm>
-            <a:off x="5897880" y="3886200"/>
-            <a:ext cx="2377440" cy="1234440"/>
+          <p:cNvPr id="13" name="Rounded Rectangle 12"/>
+          <p:cNvSpPr/>
+          <p:nvPr/>
+        </p:nvSpPr>
+        <p:spPr>
+          <a:xfrm>
+            <a:off x="6080760" y="3246120"/>
+            <a:ext cx="2240280" cy="987552"/>
           </a:xfrm>
           <a:prstGeom prst="roundRect">
             <a:avLst/>
@@ -8991,7 +10049,7 @@
           <a:p>
             <a:pPr algn="ctr"/>
             <a:r>
-              <a:rPr sz="1900" b="1">
+              <a:rPr sz="1800" b="1">
                 <a:solidFill>
                   <a:srgbClr val="0F172A"/>
                 </a:solidFill>
@@ -9005,14 +10063,14 @@
       </p:sp>
       <p:sp>
         <p:nvSpPr>
-          <p:cNvPr id="11" name="Rounded Rectangle 10"/>
-          <p:cNvSpPr/>
-          <p:nvPr/>
-        </p:nvSpPr>
-        <p:spPr>
-          <a:xfrm>
-            <a:off x="8915400" y="2468880"/>
-            <a:ext cx="2377440" cy="1280160"/>
+          <p:cNvPr id="14" name="Rounded Rectangle 13"/>
+          <p:cNvSpPr/>
+          <p:nvPr/>
+        </p:nvSpPr>
+        <p:spPr>
+          <a:xfrm>
+            <a:off x="8732520" y="2267712"/>
+            <a:ext cx="2103120" cy="914400"/>
           </a:xfrm>
           <a:prstGeom prst="roundRect">
             <a:avLst/>
@@ -9048,123 +10106,18 @@
           <a:p>
             <a:pPr algn="ctr"/>
             <a:r>
-              <a:rPr sz="1800" b="1">
+              <a:rPr sz="1700" b="1">
                 <a:solidFill>
                   <a:srgbClr val="0F172A"/>
                 </a:solidFill>
                 <a:latin typeface="Aptos"/>
               </a:rPr>
-              <a:t>KV handoff
-NIXL + sidecar</a:t>
-            </a:r>
-          </a:p>
-        </p:txBody>
-      </p:sp>
-      <p:cxnSp>
-        <p:nvCxnSpPr>
-          <p:cNvPr id="12" name="Connector 11"/>
-          <p:cNvCxnSpPr/>
-          <p:nvPr/>
-        </p:nvCxnSpPr>
-        <p:spPr>
-          <a:xfrm>
-            <a:off x="1600200" y="3108960"/>
-            <a:ext cx="182880" cy="0"/>
-          </a:xfrm>
-          <a:prstGeom prst="line">
-            <a:avLst/>
-          </a:prstGeom>
-          <a:ln w="38100">
-            <a:solidFill>
-              <a:srgbClr val="2563EB"/>
-            </a:solidFill>
-          </a:ln>
-        </p:spPr>
-        <p:style>
-          <a:lnRef idx="2">
-            <a:schemeClr val="accent1"/>
-          </a:lnRef>
-          <a:fillRef idx="0">
-            <a:schemeClr val="accent1"/>
-          </a:fillRef>
-          <a:effectRef idx="1">
-            <a:schemeClr val="accent1"/>
-          </a:effectRef>
-          <a:fontRef idx="minor">
-            <a:schemeClr val="tx1"/>
-          </a:fontRef>
-        </p:style>
-      </p:cxnSp>
-      <p:cxnSp>
-        <p:nvCxnSpPr>
-          <p:cNvPr id="13" name="Connector 12"/>
-          <p:cNvCxnSpPr/>
-          <p:nvPr/>
-        </p:nvCxnSpPr>
-        <p:spPr>
-          <a:xfrm>
-            <a:off x="3154680" y="3108960"/>
-            <a:ext cx="274320" cy="0"/>
-          </a:xfrm>
-          <a:prstGeom prst="line">
-            <a:avLst/>
-          </a:prstGeom>
-          <a:ln w="38100">
-            <a:solidFill>
-              <a:srgbClr val="2563EB"/>
-            </a:solidFill>
-          </a:ln>
-        </p:spPr>
-        <p:style>
-          <a:lnRef idx="2">
-            <a:schemeClr val="accent1"/>
-          </a:lnRef>
-          <a:fillRef idx="0">
-            <a:schemeClr val="accent1"/>
-          </a:fillRef>
-          <a:effectRef idx="1">
-            <a:schemeClr val="accent1"/>
-          </a:effectRef>
-          <a:fontRef idx="minor">
-            <a:schemeClr val="tx1"/>
-          </a:fontRef>
-        </p:style>
-      </p:cxnSp>
-      <p:cxnSp>
-        <p:nvCxnSpPr>
-          <p:cNvPr id="14" name="Connector 13"/>
-          <p:cNvCxnSpPr/>
-          <p:nvPr/>
-        </p:nvCxnSpPr>
-        <p:spPr>
-          <a:xfrm flipV="1">
-            <a:off x="5440680" y="2240280"/>
-            <a:ext cx="457200" cy="594360"/>
-          </a:xfrm>
-          <a:prstGeom prst="line">
-            <a:avLst/>
-          </a:prstGeom>
-          <a:ln w="25400">
-            <a:solidFill>
-              <a:srgbClr val="EA580C"/>
-            </a:solidFill>
-          </a:ln>
-        </p:spPr>
-        <p:style>
-          <a:lnRef idx="2">
-            <a:schemeClr val="accent1"/>
-          </a:lnRef>
-          <a:fillRef idx="0">
-            <a:schemeClr val="accent1"/>
-          </a:fillRef>
-          <a:effectRef idx="1">
-            <a:schemeClr val="accent1"/>
-          </a:effectRef>
-          <a:fontRef idx="minor">
-            <a:schemeClr val="tx1"/>
-          </a:fontRef>
-        </p:style>
-      </p:cxnSp>
+              <a:t>Routing sidecar
++ local vLLM</a:t>
+            </a:r>
+          </a:p>
+        </p:txBody>
+      </p:sp>
       <p:cxnSp>
         <p:nvCxnSpPr>
           <p:cNvPr id="15" name="Connector 14"/>
@@ -9173,13 +10126,13 @@
         </p:nvCxnSpPr>
         <p:spPr>
           <a:xfrm>
-            <a:off x="5440680" y="3383280"/>
-            <a:ext cx="457200" cy="1143000"/>
+            <a:off x="1965960" y="2414016"/>
+            <a:ext cx="182880" cy="0"/>
           </a:xfrm>
           <a:prstGeom prst="line">
             <a:avLst/>
           </a:prstGeom>
-          <a:ln w="25400">
+          <a:ln w="38100">
             <a:solidFill>
               <a:srgbClr val="2563EB"/>
             </a:solidFill>
@@ -9208,15 +10161,15 @@
         </p:nvCxnSpPr>
         <p:spPr>
           <a:xfrm>
-            <a:off x="8275320" y="2240280"/>
-            <a:ext cx="640080" cy="548640"/>
+            <a:off x="3474720" y="2414016"/>
+            <a:ext cx="228600" cy="0"/>
           </a:xfrm>
           <a:prstGeom prst="line">
             <a:avLst/>
           </a:prstGeom>
-          <a:ln w="25400">
+          <a:ln w="38100">
             <a:solidFill>
-              <a:srgbClr val="6D28D9"/>
+              <a:srgbClr val="2563EB"/>
             </a:solidFill>
           </a:ln>
         </p:spPr>
@@ -9243,13 +10196,118 @@
         </p:nvCxnSpPr>
         <p:spPr>
           <a:xfrm flipV="1">
-            <a:off x="8275320" y="3429000"/>
-            <a:ext cx="640080" cy="1097280"/>
+            <a:off x="5669280" y="1874519"/>
+            <a:ext cx="411480" cy="320041"/>
           </a:xfrm>
           <a:prstGeom prst="line">
             <a:avLst/>
           </a:prstGeom>
-          <a:ln w="25400">
+          <a:ln w="31750">
+            <a:solidFill>
+              <a:srgbClr val="2563EB"/>
+            </a:solidFill>
+          </a:ln>
+        </p:spPr>
+        <p:style>
+          <a:lnRef idx="2">
+            <a:schemeClr val="accent1"/>
+          </a:lnRef>
+          <a:fillRef idx="0">
+            <a:schemeClr val="accent1"/>
+          </a:fillRef>
+          <a:effectRef idx="1">
+            <a:schemeClr val="accent1"/>
+          </a:effectRef>
+          <a:fontRef idx="minor">
+            <a:schemeClr val="tx1"/>
+          </a:fontRef>
+        </p:style>
+      </p:cxnSp>
+      <p:cxnSp>
+        <p:nvCxnSpPr>
+          <p:cNvPr id="18" name="Connector 17"/>
+          <p:cNvCxnSpPr/>
+          <p:nvPr/>
+        </p:nvCxnSpPr>
+        <p:spPr>
+          <a:xfrm>
+            <a:off x="5669280" y="2633472"/>
+            <a:ext cx="411480" cy="1069848"/>
+          </a:xfrm>
+          <a:prstGeom prst="line">
+            <a:avLst/>
+          </a:prstGeom>
+          <a:ln w="31750">
+            <a:solidFill>
+              <a:srgbClr val="2563EB"/>
+            </a:solidFill>
+          </a:ln>
+        </p:spPr>
+        <p:style>
+          <a:lnRef idx="2">
+            <a:schemeClr val="accent1"/>
+          </a:lnRef>
+          <a:fillRef idx="0">
+            <a:schemeClr val="accent1"/>
+          </a:fillRef>
+          <a:effectRef idx="1">
+            <a:schemeClr val="accent1"/>
+          </a:effectRef>
+          <a:fontRef idx="minor">
+            <a:schemeClr val="tx1"/>
+          </a:fontRef>
+        </p:style>
+      </p:cxnSp>
+      <p:cxnSp>
+        <p:nvCxnSpPr>
+          <p:cNvPr id="19" name="Connector 18"/>
+          <p:cNvCxnSpPr/>
+          <p:nvPr/>
+        </p:nvCxnSpPr>
+        <p:spPr>
+          <a:xfrm flipV="1">
+            <a:off x="8321040" y="2724912"/>
+            <a:ext cx="411480" cy="978408"/>
+          </a:xfrm>
+          <a:prstGeom prst="line">
+            <a:avLst/>
+          </a:prstGeom>
+          <a:ln w="31750">
+            <a:solidFill>
+              <a:srgbClr val="2563EB"/>
+            </a:solidFill>
+          </a:ln>
+        </p:spPr>
+        <p:style>
+          <a:lnRef idx="2">
+            <a:schemeClr val="accent1"/>
+          </a:lnRef>
+          <a:fillRef idx="0">
+            <a:schemeClr val="accent1"/>
+          </a:fillRef>
+          <a:effectRef idx="1">
+            <a:schemeClr val="accent1"/>
+          </a:effectRef>
+          <a:fontRef idx="minor">
+            <a:schemeClr val="tx1"/>
+          </a:fontRef>
+        </p:style>
+      </p:cxnSp>
+      <p:cxnSp>
+        <p:nvCxnSpPr>
+          <p:cNvPr id="20" name="Connector 19"/>
+          <p:cNvCxnSpPr/>
+          <p:nvPr/>
+        </p:nvCxnSpPr>
+        <p:spPr>
+          <a:xfrm>
+            <a:off x="8321040" y="1874519"/>
+            <a:ext cx="411480" cy="850393"/>
+          </a:xfrm>
+          <a:prstGeom prst="line">
+            <a:avLst/>
+          </a:prstGeom>
+          <a:ln w="31750">
             <a:solidFill>
               <a:srgbClr val="6D28D9"/>
             </a:solidFill>
@@ -9272,14 +10330,14 @@
       </p:cxnSp>
       <p:sp>
         <p:nvSpPr>
-          <p:cNvPr id="18" name="Rectangle 17"/>
-          <p:cNvSpPr/>
-          <p:nvPr/>
-        </p:nvSpPr>
-        <p:spPr>
-          <a:xfrm>
-            <a:off x="3383280" y="5440680"/>
-            <a:ext cx="5486400" cy="502920"/>
+          <p:cNvPr id="21" name="Rectangle 20"/>
+          <p:cNvSpPr/>
+          <p:nvPr/>
+        </p:nvSpPr>
+        <p:spPr>
+          <a:xfrm>
+            <a:off x="6217920" y="4709160"/>
+            <a:ext cx="4343400" cy="640080"/>
           </a:xfrm>
           <a:prstGeom prst="rect">
             <a:avLst/>
@@ -9311,13 +10369,108 @@
           <a:p>
             <a:pPr algn="ctr"/>
             <a:r>
-              <a:rPr sz="1600" b="1">
+              <a:rPr sz="1500" b="1">
                 <a:solidFill>
                   <a:srgbClr val="334155"/>
                 </a:solidFill>
                 <a:latin typeface="Aptos"/>
               </a:rPr>
-              <a:t>Gateway routes requests; KV data moves directly between pods.</a:t>
+              <a:t>Gateway routes requests; KV data moves directly between prefill and decode workers.</a:t>
+            </a:r>
+          </a:p>
+        </p:txBody>
+      </p:sp>
+      <p:sp>
+        <p:nvSpPr>
+          <p:cNvPr id="22" name="Rounded Rectangle 21"/>
+          <p:cNvSpPr/>
+          <p:nvPr/>
+        </p:nvSpPr>
+        <p:spPr>
+          <a:xfrm>
+            <a:off x="914400" y="4526280"/>
+            <a:ext cx="4297680" cy="658368"/>
+          </a:xfrm>
+          <a:prstGeom prst="roundRect">
+            <a:avLst/>
+          </a:prstGeom>
+          <a:solidFill>
+            <a:srgbClr val="F1F5F9"/>
+          </a:solidFill>
+          <a:ln>
+            <a:noFill/>
+          </a:ln>
+        </p:spPr>
+        <p:style>
+          <a:lnRef idx="1">
+            <a:schemeClr val="accent1"/>
+          </a:lnRef>
+          <a:fillRef idx="3">
+            <a:schemeClr val="accent1"/>
+          </a:fillRef>
+          <a:effectRef idx="2">
+            <a:schemeClr val="accent1"/>
+          </a:effectRef>
+          <a:fontRef idx="minor">
+            <a:schemeClr val="lt1"/>
+          </a:fontRef>
+        </p:style>
+        <p:txBody>
+          <a:bodyPr rtlCol="0" anchor="ctr"/>
+          <a:lstStyle/>
+          <a:p>
+            <a:pPr algn="ctr"/>
+          </a:p>
+        </p:txBody>
+      </p:sp>
+      <p:sp>
+        <p:nvSpPr>
+          <p:cNvPr id="23" name="Rectangle 22"/>
+          <p:cNvSpPr/>
+          <p:nvPr/>
+        </p:nvSpPr>
+        <p:spPr>
+          <a:xfrm>
+            <a:off x="1051560" y="4663440"/>
+            <a:ext cx="4023360" cy="329184"/>
+          </a:xfrm>
+          <a:prstGeom prst="rect">
+            <a:avLst/>
+          </a:prstGeom>
+          <a:noFill/>
+          <a:ln>
+            <a:noFill/>
+          </a:ln>
+        </p:spPr>
+        <p:style>
+          <a:lnRef idx="1">
+            <a:schemeClr val="accent1"/>
+          </a:lnRef>
+          <a:fillRef idx="3">
+            <a:schemeClr val="accent1"/>
+          </a:fillRef>
+          <a:effectRef idx="2">
+            <a:schemeClr val="accent1"/>
+          </a:effectRef>
+          <a:fontRef idx="minor">
+            <a:schemeClr val="lt1"/>
+          </a:fontRef>
+        </p:style>
+        <p:txBody>
+          <a:bodyPr rtlCol="0" anchor="ctr" wrap="square" tIns="91440" bIns="91440">
+            <a:noAutofit/>
+          </a:bodyPr>
+          <a:lstStyle/>
+          <a:p>
+            <a:pPr algn="ctr"/>
+            <a:r>
+              <a:rPr sz="1300" b="1">
+                <a:solidFill>
+                  <a:srgbClr val="64748B"/>
+                </a:solidFill>
+                <a:latin typeface="Aptos"/>
+              </a:rPr>
+              <a:t>Data-plane split: request path and KV-transfer path are different</a:t>
             </a:r>
           </a:p>
         </p:txBody>
@@ -12552,8 +13705,8 @@
         </p:nvSpPr>
         <p:spPr>
           <a:xfrm>
-            <a:off x="685800" y="1234440"/>
-            <a:ext cx="10972800" cy="822960"/>
+            <a:off x="685800" y="1188720"/>
+            <a:ext cx="10972800" cy="749808"/>
           </a:xfrm>
           <a:prstGeom prst="roundRect">
             <a:avLst/>
@@ -12593,7 +13746,7 @@
                 </a:solidFill>
                 <a:latin typeface="Aptos"/>
               </a:rPr>
-              <a:t>Traditional CPU-based autoscaling proxies do not capture GPU-bound inference pain.</a:t>
+              <a:t>CPU-era autoscaling logic came from web workloads, not GPU-bound inference systems.</a:t>
             </a:r>
           </a:p>
         </p:txBody>
@@ -12606,8 +13759,8 @@
         </p:nvSpPr>
         <p:spPr>
           <a:xfrm>
-            <a:off x="777240" y="2286000"/>
-            <a:ext cx="5120640" cy="2880360"/>
+            <a:off x="804672" y="2103120"/>
+            <a:ext cx="4800600" cy="3017520"/>
           </a:xfrm>
           <a:prstGeom prst="roundRect">
             <a:avLst/>
@@ -12662,8 +13815,8 @@
         </p:nvSpPr>
         <p:spPr>
           <a:xfrm>
-            <a:off x="941832" y="2377440"/>
-            <a:ext cx="4791456" cy="384048"/>
+            <a:off x="969264" y="2194560"/>
+            <a:ext cx="4471416" cy="384048"/>
           </a:xfrm>
           <a:prstGeom prst="rect">
             <a:avLst/>
@@ -12714,8 +13867,8 @@
         </p:nvSpPr>
         <p:spPr>
           <a:xfrm>
-            <a:off x="960120" y="2816352"/>
-            <a:ext cx="4754880" cy="2221992"/>
+            <a:off x="987552" y="2633472"/>
+            <a:ext cx="4434840" cy="2359152"/>
           </a:xfrm>
           <a:prstGeom prst="rect">
             <a:avLst/>
@@ -12784,7 +13937,7 @@
               </a:defRPr>
             </a:pPr>
             <a:r>
-              <a:t>works for stateless request/response services</a:t>
+              <a:t>good enough for stateless request/response services</a:t>
             </a:r>
           </a:p>
         </p:txBody>
@@ -12797,8 +13950,64 @@
         </p:nvSpPr>
         <p:spPr>
           <a:xfrm>
-            <a:off x="6309360" y="2286000"/>
-            <a:ext cx="5120640" cy="2880360"/>
+            <a:off x="5074920" y="2761488"/>
+            <a:ext cx="2029968" cy="1353312"/>
+          </a:xfrm>
+          <a:prstGeom prst="roundRect">
+            <a:avLst/>
+          </a:prstGeom>
+          <a:solidFill>
+            <a:srgbClr val="DC2626"/>
+          </a:solidFill>
+          <a:ln>
+            <a:noFill/>
+          </a:ln>
+        </p:spPr>
+        <p:style>
+          <a:lnRef idx="1">
+            <a:schemeClr val="accent1"/>
+          </a:lnRef>
+          <a:fillRef idx="3">
+            <a:schemeClr val="accent1"/>
+          </a:fillRef>
+          <a:effectRef idx="2">
+            <a:schemeClr val="accent1"/>
+          </a:effectRef>
+          <a:fontRef idx="minor">
+            <a:schemeClr val="lt1"/>
+          </a:fontRef>
+        </p:style>
+        <p:txBody>
+          <a:bodyPr rtlCol="0" anchor="ctr" wrap="square" tIns="91440" bIns="91440">
+            <a:noAutofit/>
+          </a:bodyPr>
+          <a:lstStyle/>
+          <a:p>
+            <a:pPr algn="ctr"/>
+            <a:r>
+              <a:rPr sz="1900" b="1">
+                <a:solidFill>
+                  <a:srgbClr val="FFFFFF"/>
+                </a:solidFill>
+                <a:latin typeface="Aptos"/>
+              </a:rPr>
+              <a:t>same CPU
+very different
+user pain</a:t>
+            </a:r>
+          </a:p>
+        </p:txBody>
+      </p:sp>
+      <p:sp>
+        <p:nvSpPr>
+          <p:cNvPr id="11" name="Rounded Rectangle 10"/>
+          <p:cNvSpPr/>
+          <p:nvPr/>
+        </p:nvSpPr>
+        <p:spPr>
+          <a:xfrm>
+            <a:off x="6565392" y="2103120"/>
+            <a:ext cx="4800600" cy="3017520"/>
           </a:xfrm>
           <a:prstGeom prst="roundRect">
             <a:avLst/>
@@ -12847,14 +14056,14 @@
       </p:sp>
       <p:sp>
         <p:nvSpPr>
-          <p:cNvPr id="11" name="Rectangle 10"/>
-          <p:cNvSpPr/>
-          <p:nvPr/>
-        </p:nvSpPr>
-        <p:spPr>
-          <a:xfrm>
-            <a:off x="6473952" y="2377440"/>
-            <a:ext cx="4791456" cy="384048"/>
+          <p:cNvPr id="12" name="Rectangle 11"/>
+          <p:cNvSpPr/>
+          <p:nvPr/>
+        </p:nvSpPr>
+        <p:spPr>
+          <a:xfrm>
+            <a:off x="6729984" y="2194560"/>
+            <a:ext cx="4471416" cy="384048"/>
           </a:xfrm>
           <a:prstGeom prst="rect">
             <a:avLst/>
@@ -12899,14 +14108,14 @@
       </p:sp>
       <p:sp>
         <p:nvSpPr>
-          <p:cNvPr id="12" name="TextBox 11"/>
+          <p:cNvPr id="13" name="TextBox 12"/>
           <p:cNvSpPr txBox="1"/>
           <p:nvPr/>
         </p:nvSpPr>
         <p:spPr>
           <a:xfrm>
-            <a:off x="6492240" y="2816352"/>
-            <a:ext cx="4754880" cy="2221992"/>
+            <a:off x="6748272" y="2633472"/>
+            <a:ext cx="4434840" cy="2359152"/>
           </a:xfrm>
           <a:prstGeom prst="rect">
             <a:avLst/>
@@ -12991,6 +14200,58 @@
             </a:pPr>
             <a:r>
               <a:t>CPU can look fine while TTFT is already bad</a:t>
+            </a:r>
+          </a:p>
+        </p:txBody>
+      </p:sp>
+      <p:sp>
+        <p:nvSpPr>
+          <p:cNvPr id="14" name="Rectangle 13"/>
+          <p:cNvSpPr/>
+          <p:nvPr/>
+        </p:nvSpPr>
+        <p:spPr>
+          <a:xfrm>
+            <a:off x="2057400" y="5504688"/>
+            <a:ext cx="8092440" cy="420624"/>
+          </a:xfrm>
+          <a:prstGeom prst="rect">
+            <a:avLst/>
+          </a:prstGeom>
+          <a:noFill/>
+          <a:ln>
+            <a:noFill/>
+          </a:ln>
+        </p:spPr>
+        <p:style>
+          <a:lnRef idx="1">
+            <a:schemeClr val="accent1"/>
+          </a:lnRef>
+          <a:fillRef idx="3">
+            <a:schemeClr val="accent1"/>
+          </a:fillRef>
+          <a:effectRef idx="2">
+            <a:schemeClr val="accent1"/>
+          </a:effectRef>
+          <a:fontRef idx="minor">
+            <a:schemeClr val="lt1"/>
+          </a:fontRef>
+        </p:style>
+        <p:txBody>
+          <a:bodyPr rtlCol="0" anchor="ctr" wrap="square" tIns="91440" bIns="91440">
+            <a:noAutofit/>
+          </a:bodyPr>
+          <a:lstStyle/>
+          <a:p>
+            <a:pPr algn="ctr"/>
+            <a:r>
+              <a:rPr sz="1500" b="1">
+                <a:solidFill>
+                  <a:srgbClr val="334155"/>
+                </a:solidFill>
+                <a:latin typeface="Aptos"/>
+              </a:rPr>
+              <a:t>The autoscaler needs workload-aware signals, not generic resource proxies.</a:t>
             </a:r>
           </a:p>
         </p:txBody>
@@ -17160,8 +18421,8 @@
         </p:nvSpPr>
         <p:spPr>
           <a:xfrm>
-            <a:off x="3703320" y="1005840"/>
-            <a:ext cx="4754880" cy="457200"/>
+            <a:off x="3611880" y="1005840"/>
+            <a:ext cx="4937760" cy="457200"/>
           </a:xfrm>
           <a:prstGeom prst="rect">
             <a:avLst/>
@@ -17212,8 +18473,8 @@
         </p:nvSpPr>
         <p:spPr>
           <a:xfrm>
-            <a:off x="146304" y="2743200"/>
-            <a:ext cx="914400" cy="1463040"/>
+            <a:off x="164592" y="2697480"/>
+            <a:ext cx="896112" cy="1600200"/>
           </a:xfrm>
           <a:prstGeom prst="rect">
             <a:avLst/>
@@ -17258,14 +18519,223 @@
       </p:sp>
       <p:sp>
         <p:nvSpPr>
-          <p:cNvPr id="8" name="Rounded Rectangle 7"/>
-          <p:cNvSpPr/>
-          <p:nvPr/>
-        </p:nvSpPr>
-        <p:spPr>
-          <a:xfrm>
-            <a:off x="1143000" y="1691640"/>
-            <a:ext cx="4754880" cy="1828800"/>
+          <p:cNvPr id="8" name="Rectangle 7"/>
+          <p:cNvSpPr/>
+          <p:nvPr/>
+        </p:nvSpPr>
+        <p:spPr>
+          <a:xfrm>
+            <a:off x="1188720" y="1234440"/>
+            <a:ext cx="4617720" cy="292608"/>
+          </a:xfrm>
+          <a:prstGeom prst="rect">
+            <a:avLst/>
+          </a:prstGeom>
+          <a:noFill/>
+          <a:ln>
+            <a:noFill/>
+          </a:ln>
+        </p:spPr>
+        <p:style>
+          <a:lnRef idx="1">
+            <a:schemeClr val="accent1"/>
+          </a:lnRef>
+          <a:fillRef idx="3">
+            <a:schemeClr val="accent1"/>
+          </a:fillRef>
+          <a:effectRef idx="2">
+            <a:schemeClr val="accent1"/>
+          </a:effectRef>
+          <a:fontRef idx="minor">
+            <a:schemeClr val="lt1"/>
+          </a:fontRef>
+        </p:style>
+        <p:txBody>
+          <a:bodyPr rtlCol="0" anchor="ctr" wrap="square" tIns="91440" bIns="91440">
+            <a:noAutofit/>
+          </a:bodyPr>
+          <a:lstStyle/>
+          <a:p>
+            <a:pPr algn="ctr"/>
+            <a:r>
+              <a:rPr sz="1300" b="1">
+                <a:solidFill>
+                  <a:srgbClr val="64748B"/>
+                </a:solidFill>
+                <a:latin typeface="Aptos"/>
+              </a:rPr>
+              <a:t>transfer expensive / weak</a:t>
+            </a:r>
+          </a:p>
+        </p:txBody>
+      </p:sp>
+      <p:sp>
+        <p:nvSpPr>
+          <p:cNvPr id="9" name="Rectangle 8"/>
+          <p:cNvSpPr/>
+          <p:nvPr/>
+        </p:nvSpPr>
+        <p:spPr>
+          <a:xfrm>
+            <a:off x="6355080" y="1234440"/>
+            <a:ext cx="4617720" cy="292608"/>
+          </a:xfrm>
+          <a:prstGeom prst="rect">
+            <a:avLst/>
+          </a:prstGeom>
+          <a:noFill/>
+          <a:ln>
+            <a:noFill/>
+          </a:ln>
+        </p:spPr>
+        <p:style>
+          <a:lnRef idx="1">
+            <a:schemeClr val="accent1"/>
+          </a:lnRef>
+          <a:fillRef idx="3">
+            <a:schemeClr val="accent1"/>
+          </a:fillRef>
+          <a:effectRef idx="2">
+            <a:schemeClr val="accent1"/>
+          </a:effectRef>
+          <a:fontRef idx="minor">
+            <a:schemeClr val="lt1"/>
+          </a:fontRef>
+        </p:style>
+        <p:txBody>
+          <a:bodyPr rtlCol="0" anchor="ctr" wrap="square" tIns="91440" bIns="91440">
+            <a:noAutofit/>
+          </a:bodyPr>
+          <a:lstStyle/>
+          <a:p>
+            <a:pPr algn="ctr"/>
+            <a:r>
+              <a:rPr sz="1300" b="1">
+                <a:solidFill>
+                  <a:srgbClr val="64748B"/>
+                </a:solidFill>
+                <a:latin typeface="Aptos"/>
+              </a:rPr>
+              <a:t>transfer cheap / strong</a:t>
+            </a:r>
+          </a:p>
+        </p:txBody>
+      </p:sp>
+      <p:sp>
+        <p:nvSpPr>
+          <p:cNvPr id="10" name="Rectangle 9"/>
+          <p:cNvSpPr/>
+          <p:nvPr/>
+        </p:nvSpPr>
+        <p:spPr>
+          <a:xfrm>
+            <a:off x="164592" y="2148840"/>
+            <a:ext cx="868680" cy="621792"/>
+          </a:xfrm>
+          <a:prstGeom prst="rect">
+            <a:avLst/>
+          </a:prstGeom>
+          <a:noFill/>
+          <a:ln>
+            <a:noFill/>
+          </a:ln>
+        </p:spPr>
+        <p:style>
+          <a:lnRef idx="1">
+            <a:schemeClr val="accent1"/>
+          </a:lnRef>
+          <a:fillRef idx="3">
+            <a:schemeClr val="accent1"/>
+          </a:fillRef>
+          <a:effectRef idx="2">
+            <a:schemeClr val="accent1"/>
+          </a:effectRef>
+          <a:fontRef idx="minor">
+            <a:schemeClr val="lt1"/>
+          </a:fontRef>
+        </p:style>
+        <p:txBody>
+          <a:bodyPr rtlCol="0" anchor="ctr" wrap="square" tIns="91440" bIns="91440">
+            <a:noAutofit/>
+          </a:bodyPr>
+          <a:lstStyle/>
+          <a:p>
+            <a:pPr algn="ctr"/>
+            <a:r>
+              <a:rPr sz="1300" b="1">
+                <a:solidFill>
+                  <a:srgbClr val="64748B"/>
+                </a:solidFill>
+                <a:latin typeface="Aptos"/>
+              </a:rPr>
+              <a:t>similar</a:t>
+            </a:r>
+          </a:p>
+        </p:txBody>
+      </p:sp>
+      <p:sp>
+        <p:nvSpPr>
+          <p:cNvPr id="11" name="Rectangle 10"/>
+          <p:cNvSpPr/>
+          <p:nvPr/>
+        </p:nvSpPr>
+        <p:spPr>
+          <a:xfrm>
+            <a:off x="91440" y="4434840"/>
+            <a:ext cx="960120" cy="841248"/>
+          </a:xfrm>
+          <a:prstGeom prst="rect">
+            <a:avLst/>
+          </a:prstGeom>
+          <a:noFill/>
+          <a:ln>
+            <a:noFill/>
+          </a:ln>
+        </p:spPr>
+        <p:style>
+          <a:lnRef idx="1">
+            <a:schemeClr val="accent1"/>
+          </a:lnRef>
+          <a:fillRef idx="3">
+            <a:schemeClr val="accent1"/>
+          </a:fillRef>
+          <a:effectRef idx="2">
+            <a:schemeClr val="accent1"/>
+          </a:effectRef>
+          <a:fontRef idx="minor">
+            <a:schemeClr val="lt1"/>
+          </a:fontRef>
+        </p:style>
+        <p:txBody>
+          <a:bodyPr rtlCol="0" anchor="ctr" wrap="square" tIns="91440" bIns="91440">
+            <a:noAutofit/>
+          </a:bodyPr>
+          <a:lstStyle/>
+          <a:p>
+            <a:pPr algn="ctr"/>
+            <a:r>
+              <a:rPr sz="1300" b="1">
+                <a:solidFill>
+                  <a:srgbClr val="64748B"/>
+                </a:solidFill>
+                <a:latin typeface="Aptos"/>
+              </a:rPr>
+              <a:t>meaningfully
+different</a:t>
+            </a:r>
+          </a:p>
+        </p:txBody>
+      </p:sp>
+      <p:sp>
+        <p:nvSpPr>
+          <p:cNvPr id="12" name="Rounded Rectangle 11"/>
+          <p:cNvSpPr/>
+          <p:nvPr/>
+        </p:nvSpPr>
+        <p:spPr>
+          <a:xfrm>
+            <a:off x="1188720" y="1691640"/>
+            <a:ext cx="4617720" cy="1783080"/>
           </a:xfrm>
           <a:prstGeom prst="roundRect">
             <a:avLst/>
@@ -17314,14 +18784,14 @@
       </p:sp>
       <p:sp>
         <p:nvSpPr>
-          <p:cNvPr id="9" name="Rectangle 8"/>
-          <p:cNvSpPr/>
-          <p:nvPr/>
-        </p:nvSpPr>
-        <p:spPr>
-          <a:xfrm>
-            <a:off x="1307592" y="1783080"/>
-            <a:ext cx="4425696" cy="384048"/>
+          <p:cNvPr id="13" name="Rectangle 12"/>
+          <p:cNvSpPr/>
+          <p:nvPr/>
+        </p:nvSpPr>
+        <p:spPr>
+          <a:xfrm>
+            <a:off x="1353312" y="1783080"/>
+            <a:ext cx="4288536" cy="384048"/>
           </a:xfrm>
           <a:prstGeom prst="rect">
             <a:avLst/>
@@ -17366,14 +18836,14 @@
       </p:sp>
       <p:sp>
         <p:nvSpPr>
-          <p:cNvPr id="10" name="TextBox 9"/>
+          <p:cNvPr id="14" name="TextBox 13"/>
           <p:cNvSpPr txBox="1"/>
           <p:nvPr/>
         </p:nvSpPr>
         <p:spPr>
           <a:xfrm>
-            <a:off x="1325880" y="2221992"/>
-            <a:ext cx="4389120" cy="1170432"/>
+            <a:off x="1371600" y="2221992"/>
+            <a:ext cx="4251960" cy="1124712"/>
           </a:xfrm>
           <a:prstGeom prst="rect">
             <a:avLst/>
@@ -17404,14 +18874,14 @@
       </p:sp>
       <p:sp>
         <p:nvSpPr>
-          <p:cNvPr id="11" name="Rounded Rectangle 10"/>
-          <p:cNvSpPr/>
-          <p:nvPr/>
-        </p:nvSpPr>
-        <p:spPr>
-          <a:xfrm>
-            <a:off x="6172200" y="1691640"/>
-            <a:ext cx="4754880" cy="1828800"/>
+          <p:cNvPr id="15" name="Rounded Rectangle 14"/>
+          <p:cNvSpPr/>
+          <p:nvPr/>
+        </p:nvSpPr>
+        <p:spPr>
+          <a:xfrm>
+            <a:off x="6355080" y="1691640"/>
+            <a:ext cx="4617720" cy="1783080"/>
           </a:xfrm>
           <a:prstGeom prst="roundRect">
             <a:avLst/>
@@ -17460,14 +18930,14 @@
       </p:sp>
       <p:sp>
         <p:nvSpPr>
-          <p:cNvPr id="12" name="Rectangle 11"/>
-          <p:cNvSpPr/>
-          <p:nvPr/>
-        </p:nvSpPr>
-        <p:spPr>
-          <a:xfrm>
-            <a:off x="6336792" y="1783080"/>
-            <a:ext cx="4425696" cy="384048"/>
+          <p:cNvPr id="16" name="Rectangle 15"/>
+          <p:cNvSpPr/>
+          <p:nvPr/>
+        </p:nvSpPr>
+        <p:spPr>
+          <a:xfrm>
+            <a:off x="6519672" y="1783080"/>
+            <a:ext cx="4288536" cy="384048"/>
           </a:xfrm>
           <a:prstGeom prst="rect">
             <a:avLst/>
@@ -17512,14 +18982,14 @@
       </p:sp>
       <p:sp>
         <p:nvSpPr>
-          <p:cNvPr id="13" name="TextBox 12"/>
+          <p:cNvPr id="17" name="TextBox 16"/>
           <p:cNvSpPr txBox="1"/>
           <p:nvPr/>
         </p:nvSpPr>
         <p:spPr>
           <a:xfrm>
-            <a:off x="6355080" y="2221992"/>
-            <a:ext cx="4389120" cy="1170432"/>
+            <a:off x="6537960" y="2221992"/>
+            <a:ext cx="4251960" cy="1124712"/>
           </a:xfrm>
           <a:prstGeom prst="rect">
             <a:avLst/>
@@ -17550,14 +19020,14 @@
       </p:sp>
       <p:sp>
         <p:nvSpPr>
-          <p:cNvPr id="14" name="Rounded Rectangle 13"/>
-          <p:cNvSpPr/>
-          <p:nvPr/>
-        </p:nvSpPr>
-        <p:spPr>
-          <a:xfrm>
-            <a:off x="1143000" y="3840480"/>
-            <a:ext cx="4754880" cy="1828800"/>
+          <p:cNvPr id="18" name="Rounded Rectangle 17"/>
+          <p:cNvSpPr/>
+          <p:nvPr/>
+        </p:nvSpPr>
+        <p:spPr>
+          <a:xfrm>
+            <a:off x="1188720" y="3794760"/>
+            <a:ext cx="4617720" cy="1783080"/>
           </a:xfrm>
           <a:prstGeom prst="roundRect">
             <a:avLst/>
@@ -17606,14 +19076,14 @@
       </p:sp>
       <p:sp>
         <p:nvSpPr>
-          <p:cNvPr id="15" name="Rectangle 14"/>
-          <p:cNvSpPr/>
-          <p:nvPr/>
-        </p:nvSpPr>
-        <p:spPr>
-          <a:xfrm>
-            <a:off x="1307592" y="3931920"/>
-            <a:ext cx="4425696" cy="384048"/>
+          <p:cNvPr id="19" name="Rectangle 18"/>
+          <p:cNvSpPr/>
+          <p:nvPr/>
+        </p:nvSpPr>
+        <p:spPr>
+          <a:xfrm>
+            <a:off x="1353312" y="3886200"/>
+            <a:ext cx="4288536" cy="384048"/>
           </a:xfrm>
           <a:prstGeom prst="rect">
             <a:avLst/>
@@ -17658,14 +19128,14 @@
       </p:sp>
       <p:sp>
         <p:nvSpPr>
-          <p:cNvPr id="16" name="TextBox 15"/>
+          <p:cNvPr id="20" name="TextBox 19"/>
           <p:cNvSpPr txBox="1"/>
           <p:nvPr/>
         </p:nvSpPr>
         <p:spPr>
           <a:xfrm>
-            <a:off x="1325880" y="4370832"/>
-            <a:ext cx="4389120" cy="1170432"/>
+            <a:off x="1371600" y="4325112"/>
+            <a:ext cx="4251960" cy="1124712"/>
           </a:xfrm>
           <a:prstGeom prst="rect">
             <a:avLst/>
@@ -17696,14 +19166,14 @@
       </p:sp>
       <p:sp>
         <p:nvSpPr>
-          <p:cNvPr id="17" name="Rounded Rectangle 16"/>
-          <p:cNvSpPr/>
-          <p:nvPr/>
-        </p:nvSpPr>
-        <p:spPr>
-          <a:xfrm>
-            <a:off x="6172200" y="3840480"/>
-            <a:ext cx="4754880" cy="1828800"/>
+          <p:cNvPr id="21" name="Rounded Rectangle 20"/>
+          <p:cNvSpPr/>
+          <p:nvPr/>
+        </p:nvSpPr>
+        <p:spPr>
+          <a:xfrm>
+            <a:off x="6355080" y="3794760"/>
+            <a:ext cx="4617720" cy="1783080"/>
           </a:xfrm>
           <a:prstGeom prst="roundRect">
             <a:avLst/>
@@ -17752,14 +19222,14 @@
       </p:sp>
       <p:sp>
         <p:nvSpPr>
-          <p:cNvPr id="18" name="Rectangle 17"/>
-          <p:cNvSpPr/>
-          <p:nvPr/>
-        </p:nvSpPr>
-        <p:spPr>
-          <a:xfrm>
-            <a:off x="6336792" y="3931920"/>
-            <a:ext cx="4425696" cy="384048"/>
+          <p:cNvPr id="22" name="Rectangle 21"/>
+          <p:cNvSpPr/>
+          <p:nvPr/>
+        </p:nvSpPr>
+        <p:spPr>
+          <a:xfrm>
+            <a:off x="6519672" y="3886200"/>
+            <a:ext cx="4288536" cy="384048"/>
           </a:xfrm>
           <a:prstGeom prst="rect">
             <a:avLst/>
@@ -17804,14 +19274,14 @@
       </p:sp>
       <p:sp>
         <p:nvSpPr>
-          <p:cNvPr id="19" name="TextBox 18"/>
+          <p:cNvPr id="23" name="TextBox 22"/>
           <p:cNvSpPr txBox="1"/>
           <p:nvPr/>
         </p:nvSpPr>
         <p:spPr>
           <a:xfrm>
-            <a:off x="6355080" y="4370832"/>
-            <a:ext cx="4389120" cy="1170432"/>
+            <a:off x="6537960" y="4325112"/>
+            <a:ext cx="4251960" cy="1124712"/>
           </a:xfrm>
           <a:prstGeom prst="rect">
             <a:avLst/>
@@ -17842,14 +19312,57 @@
       </p:sp>
       <p:sp>
         <p:nvSpPr>
-          <p:cNvPr id="20" name="Rectangle 19"/>
-          <p:cNvSpPr/>
-          <p:nvPr/>
-        </p:nvSpPr>
-        <p:spPr>
-          <a:xfrm>
-            <a:off x="1143000" y="1234440"/>
-            <a:ext cx="4754880" cy="320040"/>
+          <p:cNvPr id="24" name="Rounded Rectangle 23"/>
+          <p:cNvSpPr/>
+          <p:nvPr/>
+        </p:nvSpPr>
+        <p:spPr>
+          <a:xfrm>
+            <a:off x="6291072" y="3730752"/>
+            <a:ext cx="4745736" cy="1911095"/>
+          </a:xfrm>
+          <a:prstGeom prst="roundRect">
+            <a:avLst/>
+          </a:prstGeom>
+          <a:noFill/>
+          <a:ln w="15875">
+            <a:solidFill>
+              <a:srgbClr val="16A34A"/>
+            </a:solidFill>
+          </a:ln>
+        </p:spPr>
+        <p:style>
+          <a:lnRef idx="1">
+            <a:schemeClr val="accent1"/>
+          </a:lnRef>
+          <a:fillRef idx="3">
+            <a:schemeClr val="accent1"/>
+          </a:fillRef>
+          <a:effectRef idx="2">
+            <a:schemeClr val="accent1"/>
+          </a:effectRef>
+          <a:fontRef idx="minor">
+            <a:schemeClr val="lt1"/>
+          </a:fontRef>
+        </p:style>
+        <p:txBody>
+          <a:bodyPr rtlCol="0" anchor="ctr"/>
+          <a:lstStyle/>
+          <a:p>
+            <a:pPr algn="ctr"/>
+          </a:p>
+        </p:txBody>
+      </p:sp>
+      <p:sp>
+        <p:nvSpPr>
+          <p:cNvPr id="25" name="Rectangle 24"/>
+          <p:cNvSpPr/>
+          <p:nvPr/>
+        </p:nvSpPr>
+        <p:spPr>
+          <a:xfrm>
+            <a:off x="7498079" y="5779008"/>
+            <a:ext cx="2377440" cy="310896"/>
           </a:xfrm>
           <a:prstGeom prst="rect">
             <a:avLst/>
@@ -17881,170 +19394,13 @@
           <a:p>
             <a:pPr algn="ctr"/>
             <a:r>
-              <a:rPr sz="1300" b="1">
-                <a:solidFill>
-                  <a:srgbClr val="64748B"/>
+              <a:rPr sz="1200" b="1">
+                <a:solidFill>
+                  <a:srgbClr val="16A34A"/>
                 </a:solidFill>
                 <a:latin typeface="Aptos"/>
               </a:rPr>
-              <a:t>transfer expensive / weak</a:t>
-            </a:r>
-          </a:p>
-        </p:txBody>
-      </p:sp>
-      <p:sp>
-        <p:nvSpPr>
-          <p:cNvPr id="21" name="Rectangle 20"/>
-          <p:cNvSpPr/>
-          <p:nvPr/>
-        </p:nvSpPr>
-        <p:spPr>
-          <a:xfrm>
-            <a:off x="6172200" y="1234440"/>
-            <a:ext cx="4754880" cy="320040"/>
-          </a:xfrm>
-          <a:prstGeom prst="rect">
-            <a:avLst/>
-          </a:prstGeom>
-          <a:noFill/>
-          <a:ln>
-            <a:noFill/>
-          </a:ln>
-        </p:spPr>
-        <p:style>
-          <a:lnRef idx="1">
-            <a:schemeClr val="accent1"/>
-          </a:lnRef>
-          <a:fillRef idx="3">
-            <a:schemeClr val="accent1"/>
-          </a:fillRef>
-          <a:effectRef idx="2">
-            <a:schemeClr val="accent1"/>
-          </a:effectRef>
-          <a:fontRef idx="minor">
-            <a:schemeClr val="lt1"/>
-          </a:fontRef>
-        </p:style>
-        <p:txBody>
-          <a:bodyPr rtlCol="0" anchor="ctr" wrap="square" tIns="91440" bIns="91440">
-            <a:noAutofit/>
-          </a:bodyPr>
-          <a:lstStyle/>
-          <a:p>
-            <a:pPr algn="ctr"/>
-            <a:r>
-              <a:rPr sz="1300" b="1">
-                <a:solidFill>
-                  <a:srgbClr val="64748B"/>
-                </a:solidFill>
-                <a:latin typeface="Aptos"/>
-              </a:rPr>
-              <a:t>transfer cheap / strong</a:t>
-            </a:r>
-          </a:p>
-        </p:txBody>
-      </p:sp>
-      <p:sp>
-        <p:nvSpPr>
-          <p:cNvPr id="22" name="Rectangle 21"/>
-          <p:cNvSpPr/>
-          <p:nvPr/>
-        </p:nvSpPr>
-        <p:spPr>
-          <a:xfrm>
-            <a:off x="146304" y="2148840"/>
-            <a:ext cx="868680" cy="640080"/>
-          </a:xfrm>
-          <a:prstGeom prst="rect">
-            <a:avLst/>
-          </a:prstGeom>
-          <a:noFill/>
-          <a:ln>
-            <a:noFill/>
-          </a:ln>
-        </p:spPr>
-        <p:style>
-          <a:lnRef idx="1">
-            <a:schemeClr val="accent1"/>
-          </a:lnRef>
-          <a:fillRef idx="3">
-            <a:schemeClr val="accent1"/>
-          </a:fillRef>
-          <a:effectRef idx="2">
-            <a:schemeClr val="accent1"/>
-          </a:effectRef>
-          <a:fontRef idx="minor">
-            <a:schemeClr val="lt1"/>
-          </a:fontRef>
-        </p:style>
-        <p:txBody>
-          <a:bodyPr rtlCol="0" anchor="ctr" wrap="square" tIns="91440" bIns="91440">
-            <a:noAutofit/>
-          </a:bodyPr>
-          <a:lstStyle/>
-          <a:p>
-            <a:pPr algn="ctr"/>
-            <a:r>
-              <a:rPr sz="1300" b="1">
-                <a:solidFill>
-                  <a:srgbClr val="64748B"/>
-                </a:solidFill>
-                <a:latin typeface="Aptos"/>
-              </a:rPr>
-              <a:t>similar</a:t>
-            </a:r>
-          </a:p>
-        </p:txBody>
-      </p:sp>
-      <p:sp>
-        <p:nvSpPr>
-          <p:cNvPr id="23" name="Rectangle 22"/>
-          <p:cNvSpPr/>
-          <p:nvPr/>
-        </p:nvSpPr>
-        <p:spPr>
-          <a:xfrm>
-            <a:off x="91440" y="4343400"/>
-            <a:ext cx="960120" cy="868680"/>
-          </a:xfrm>
-          <a:prstGeom prst="rect">
-            <a:avLst/>
-          </a:prstGeom>
-          <a:noFill/>
-          <a:ln>
-            <a:noFill/>
-          </a:ln>
-        </p:spPr>
-        <p:style>
-          <a:lnRef idx="1">
-            <a:schemeClr val="accent1"/>
-          </a:lnRef>
-          <a:fillRef idx="3">
-            <a:schemeClr val="accent1"/>
-          </a:fillRef>
-          <a:effectRef idx="2">
-            <a:schemeClr val="accent1"/>
-          </a:effectRef>
-          <a:fontRef idx="minor">
-            <a:schemeClr val="lt1"/>
-          </a:fontRef>
-        </p:style>
-        <p:txBody>
-          <a:bodyPr rtlCol="0" anchor="ctr" wrap="square" tIns="91440" bIns="91440">
-            <a:noAutofit/>
-          </a:bodyPr>
-          <a:lstStyle/>
-          <a:p>
-            <a:pPr algn="ctr"/>
-            <a:r>
-              <a:rPr sz="1300" b="1">
-                <a:solidFill>
-                  <a:srgbClr val="64748B"/>
-                </a:solidFill>
-                <a:latin typeface="Aptos"/>
-              </a:rPr>
-              <a:t>meaningfully
-different</a:t>
+              <a:t>recommended starting point</a:t>
             </a:r>
           </a:p>
         </p:txBody>

</xml_diff>

<commit_message>
use KAITO docs visuals in PD deck
</commit_message>
<xml_diff>
--- a/llm/kubecon-na-2026-pd-disaggregation.pptx
+++ b/llm/kubecon-na-2026-pd-disaggregation.pptx
@@ -3469,9 +3469,33 @@
           </a:p>
         </p:txBody>
       </p:sp>
-      <p:sp>
-        <p:nvSpPr>
-          <p:cNvPr id="9" name="Rounded Rectangle 8"/>
+      <p:pic>
+        <p:nvPicPr>
+          <p:cNvPr id="9" name="Picture 8" descr="kaito-logo.png"/>
+          <p:cNvPicPr>
+            <a:picLocks noChangeAspect="1"/>
+          </p:cNvPicPr>
+          <p:nvPr/>
+        </p:nvPicPr>
+        <p:blipFill>
+          <a:blip r:embed="rId2"/>
+          <a:stretch>
+            <a:fillRect/>
+          </a:stretch>
+        </p:blipFill>
+        <p:spPr>
+          <a:xfrm>
+            <a:off x="6355080" y="5440680"/>
+            <a:ext cx="502920" cy="502920"/>
+          </a:xfrm>
+          <a:prstGeom prst="rect">
+            <a:avLst/>
+          </a:prstGeom>
+        </p:spPr>
+      </p:pic>
+      <p:sp>
+        <p:nvSpPr>
+          <p:cNvPr id="10" name="Rounded Rectangle 9"/>
           <p:cNvSpPr/>
           <p:nvPr/>
         </p:nvSpPr>
@@ -3527,7 +3551,7 @@
       </p:sp>
       <p:sp>
         <p:nvSpPr>
-          <p:cNvPr id="10" name="Rounded Rectangle 9"/>
+          <p:cNvPr id="11" name="Rounded Rectangle 10"/>
           <p:cNvSpPr/>
           <p:nvPr/>
         </p:nvSpPr>
@@ -3583,7 +3607,7 @@
       </p:sp>
       <p:sp>
         <p:nvSpPr>
-          <p:cNvPr id="11" name="Rounded Rectangle 10"/>
+          <p:cNvPr id="12" name="Rounded Rectangle 11"/>
           <p:cNvSpPr/>
           <p:nvPr/>
         </p:nvSpPr>
@@ -3639,7 +3663,7 @@
       </p:sp>
       <p:sp>
         <p:nvSpPr>
-          <p:cNvPr id="12" name="Rounded Rectangle 11"/>
+          <p:cNvPr id="13" name="Rounded Rectangle 12"/>
           <p:cNvSpPr/>
           <p:nvPr/>
         </p:nvSpPr>
@@ -3695,7 +3719,7 @@
       </p:sp>
       <p:sp>
         <p:nvSpPr>
-          <p:cNvPr id="13" name="Rectangle 12"/>
+          <p:cNvPr id="14" name="Rectangle 13"/>
           <p:cNvSpPr/>
           <p:nvPr/>
         </p:nvSpPr>
@@ -3747,7 +3771,7 @@
       </p:sp>
       <p:sp>
         <p:nvSpPr>
-          <p:cNvPr id="14" name="Rounded Rectangle 13"/>
+          <p:cNvPr id="15" name="Rounded Rectangle 14"/>
           <p:cNvSpPr/>
           <p:nvPr/>
         </p:nvSpPr>
@@ -3790,7 +3814,7 @@
       </p:sp>
       <p:sp>
         <p:nvSpPr>
-          <p:cNvPr id="15" name="Rectangle 14"/>
+          <p:cNvPr id="16" name="Rectangle 15"/>
           <p:cNvSpPr/>
           <p:nvPr/>
         </p:nvSpPr>
@@ -3842,7 +3866,7 @@
       </p:sp>
       <p:sp>
         <p:nvSpPr>
-          <p:cNvPr id="16" name="Rounded Rectangle 15"/>
+          <p:cNvPr id="17" name="Rounded Rectangle 16"/>
           <p:cNvSpPr/>
           <p:nvPr/>
         </p:nvSpPr>
@@ -3898,7 +3922,7 @@
       </p:sp>
       <p:sp>
         <p:nvSpPr>
-          <p:cNvPr id="17" name="Rounded Rectangle 16"/>
+          <p:cNvPr id="18" name="Rounded Rectangle 17"/>
           <p:cNvSpPr/>
           <p:nvPr/>
         </p:nvSpPr>
@@ -3954,7 +3978,7 @@
       </p:sp>
       <p:sp>
         <p:nvSpPr>
-          <p:cNvPr id="18" name="Rounded Rectangle 17"/>
+          <p:cNvPr id="19" name="Rounded Rectangle 18"/>
           <p:cNvSpPr/>
           <p:nvPr/>
         </p:nvSpPr>
@@ -4010,7 +4034,7 @@
       </p:sp>
       <p:cxnSp>
         <p:nvCxnSpPr>
-          <p:cNvPr id="19" name="Connector 18"/>
+          <p:cNvPr id="20" name="Connector 19"/>
           <p:cNvCxnSpPr/>
           <p:nvPr/>
         </p:nvCxnSpPr>
@@ -4045,7 +4069,7 @@
       </p:cxnSp>
       <p:cxnSp>
         <p:nvCxnSpPr>
-          <p:cNvPr id="20" name="Connector 19"/>
+          <p:cNvPr id="21" name="Connector 20"/>
           <p:cNvCxnSpPr/>
           <p:nvPr/>
         </p:nvCxnSpPr>
@@ -4080,7 +4104,7 @@
       </p:cxnSp>
       <p:sp>
         <p:nvSpPr>
-          <p:cNvPr id="21" name="Rectangle 20"/>
+          <p:cNvPr id="22" name="Rectangle 21"/>
           <p:cNvSpPr/>
           <p:nvPr/>
         </p:nvSpPr>
@@ -4734,8 +4758,8 @@
         </p:nvSpPr>
         <p:spPr>
           <a:xfrm>
-            <a:off x="777240" y="1234440"/>
-            <a:ext cx="10789920" cy="868680"/>
+            <a:off x="777240" y="1097280"/>
+            <a:ext cx="10789920" cy="786384"/>
           </a:xfrm>
           <a:prstGeom prst="roundRect">
             <a:avLst/>
@@ -4769,7 +4793,7 @@
           <a:p>
             <a:pPr algn="ctr"/>
             <a:r>
-              <a:rPr sz="2400" b="1">
+              <a:rPr sz="2200" b="1">
                 <a:solidFill>
                   <a:srgbClr val="0F172A"/>
                 </a:solidFill>
@@ -4788,19 +4812,82 @@
         </p:nvSpPr>
         <p:spPr>
           <a:xfrm>
-            <a:off x="749808" y="2743200"/>
-            <a:ext cx="2514600" cy="1645920"/>
+            <a:off x="749808" y="2011680"/>
+            <a:ext cx="3749039" cy="3611880"/>
           </a:xfrm>
           <a:prstGeom prst="roundRect">
             <a:avLst/>
           </a:prstGeom>
           <a:solidFill>
-            <a:srgbClr val="DBEAFE"/>
+            <a:srgbClr val="FFFFFF"/>
           </a:solidFill>
-          <a:ln w="15875">
-            <a:solidFill>
-              <a:srgbClr val="2563EB"/>
-            </a:solidFill>
+          <a:ln>
+            <a:noFill/>
+          </a:ln>
+        </p:spPr>
+        <p:style>
+          <a:lnRef idx="1">
+            <a:schemeClr val="accent1"/>
+          </a:lnRef>
+          <a:fillRef idx="3">
+            <a:schemeClr val="accent1"/>
+          </a:fillRef>
+          <a:effectRef idx="2">
+            <a:schemeClr val="accent1"/>
+          </a:effectRef>
+          <a:fontRef idx="minor">
+            <a:schemeClr val="lt1"/>
+          </a:fontRef>
+        </p:style>
+        <p:txBody>
+          <a:bodyPr rtlCol="0" anchor="ctr"/>
+          <a:lstStyle/>
+          <a:p>
+            <a:pPr algn="ctr"/>
+          </a:p>
+        </p:txBody>
+      </p:sp>
+      <p:pic>
+        <p:nvPicPr>
+          <p:cNvPr id="8" name="Picture 7" descr="kaito-logo.png"/>
+          <p:cNvPicPr>
+            <a:picLocks noChangeAspect="1"/>
+          </p:cNvPicPr>
+          <p:nvPr/>
+        </p:nvPicPr>
+        <p:blipFill>
+          <a:blip r:embed="rId2"/>
+          <a:stretch>
+            <a:fillRect/>
+          </a:stretch>
+        </p:blipFill>
+        <p:spPr>
+          <a:xfrm>
+            <a:off x="960120" y="2240280"/>
+            <a:ext cx="548640" cy="548640"/>
+          </a:xfrm>
+          <a:prstGeom prst="rect">
+            <a:avLst/>
+          </a:prstGeom>
+        </p:spPr>
+      </p:pic>
+      <p:sp>
+        <p:nvSpPr>
+          <p:cNvPr id="9" name="Rectangle 8"/>
+          <p:cNvSpPr/>
+          <p:nvPr/>
+        </p:nvSpPr>
+        <p:spPr>
+          <a:xfrm>
+            <a:off x="914400" y="2926080"/>
+            <a:ext cx="3337560" cy="2240280"/>
+          </a:xfrm>
+          <a:prstGeom prst="rect">
+            <a:avLst/>
+          </a:prstGeom>
+          <a:noFill/>
+          <a:ln>
+            <a:noFill/>
           </a:ln>
         </p:spPr>
         <p:style>
@@ -4823,41 +4910,106 @@
           </a:bodyPr>
           <a:lstStyle/>
           <a:p>
-            <a:pPr algn="ctr"/>
-            <a:r>
-              <a:rPr sz="2200" b="1">
-                <a:solidFill>
-                  <a:srgbClr val="0F172A"/>
+            <a:pPr algn="l"/>
+            <a:r>
+              <a:rPr sz="1800" b="0">
+                <a:solidFill>
+                  <a:srgbClr val="334155"/>
                 </a:solidFill>
                 <a:latin typeface="Aptos"/>
               </a:rPr>
-              <a:t>Workspace
-run one model workload</a:t>
-            </a:r>
-          </a:p>
-        </p:txBody>
-      </p:sp>
-      <p:sp>
-        <p:nvSpPr>
-          <p:cNvPr id="8" name="Rounded Rectangle 7"/>
-          <p:cNvSpPr/>
-          <p:nvPr/>
-        </p:nvSpPr>
-        <p:spPr>
-          <a:xfrm>
-            <a:off x="3557016" y="2743200"/>
-            <a:ext cx="2514600" cy="1645920"/>
+              <a:t>• Start with Workspace for one model workload
+• Add InferenceSet for replicas and autoscaling
+• Add InferencePool for inference-aware routing
+• Use MultiRoleInference for richer distributed topology</a:t>
+            </a:r>
+          </a:p>
+        </p:txBody>
+      </p:sp>
+      <p:sp>
+        <p:nvSpPr>
+          <p:cNvPr id="10" name="Rounded Rectangle 9"/>
+          <p:cNvSpPr/>
+          <p:nvPr/>
+        </p:nvSpPr>
+        <p:spPr>
+          <a:xfrm>
+            <a:off x="4709160" y="2011680"/>
+            <a:ext cx="6629400" cy="3611880"/>
           </a:xfrm>
           <a:prstGeom prst="roundRect">
             <a:avLst/>
           </a:prstGeom>
           <a:solidFill>
-            <a:srgbClr val="DCFCE7"/>
+            <a:srgbClr val="FFFFFF"/>
           </a:solidFill>
-          <a:ln w="15875">
-            <a:solidFill>
-              <a:srgbClr val="16A34A"/>
-            </a:solidFill>
+          <a:ln>
+            <a:noFill/>
+          </a:ln>
+        </p:spPr>
+        <p:style>
+          <a:lnRef idx="1">
+            <a:schemeClr val="accent1"/>
+          </a:lnRef>
+          <a:fillRef idx="3">
+            <a:schemeClr val="accent1"/>
+          </a:fillRef>
+          <a:effectRef idx="2">
+            <a:schemeClr val="accent1"/>
+          </a:effectRef>
+          <a:fontRef idx="minor">
+            <a:schemeClr val="lt1"/>
+          </a:fontRef>
+        </p:style>
+        <p:txBody>
+          <a:bodyPr rtlCol="0" anchor="ctr"/>
+          <a:lstStyle/>
+          <a:p>
+            <a:pPr algn="ctr"/>
+          </a:p>
+        </p:txBody>
+      </p:sp>
+      <p:pic>
+        <p:nvPicPr>
+          <p:cNvPr id="11" name="Picture 10" descr="kaito-docs-arch.png"/>
+          <p:cNvPicPr>
+            <a:picLocks noChangeAspect="1"/>
+          </p:cNvPicPr>
+          <p:nvPr/>
+        </p:nvPicPr>
+        <p:blipFill>
+          <a:blip r:embed="rId3"/>
+          <a:stretch>
+            <a:fillRect/>
+          </a:stretch>
+        </p:blipFill>
+        <p:spPr>
+          <a:xfrm>
+            <a:off x="4892040" y="2212848"/>
+            <a:ext cx="6263640" cy="3154680"/>
+          </a:xfrm>
+          <a:prstGeom prst="rect">
+            <a:avLst/>
+          </a:prstGeom>
+        </p:spPr>
+      </p:pic>
+      <p:sp>
+        <p:nvSpPr>
+          <p:cNvPr id="12" name="Rectangle 11"/>
+          <p:cNvSpPr/>
+          <p:nvPr/>
+        </p:nvSpPr>
+        <p:spPr>
+          <a:xfrm>
+            <a:off x="868680" y="5806440"/>
+            <a:ext cx="10424160" cy="310896"/>
+          </a:xfrm>
+          <a:prstGeom prst="rect">
+            <a:avLst/>
+          </a:prstGeom>
+          <a:noFill/>
+          <a:ln>
+            <a:noFill/>
           </a:ln>
         </p:spPr>
         <p:style>
@@ -4882,285 +5034,13 @@
           <a:p>
             <a:pPr algn="ctr"/>
             <a:r>
-              <a:rPr sz="2200" b="1">
-                <a:solidFill>
-                  <a:srgbClr val="0F172A"/>
+              <a:rPr sz="1300" b="0">
+                <a:solidFill>
+                  <a:srgbClr val="64748B"/>
                 </a:solidFill>
                 <a:latin typeface="Aptos"/>
               </a:rPr>
-              <a:t>InferenceSet
-replicas + autoscaling</a:t>
-            </a:r>
-          </a:p>
-        </p:txBody>
-      </p:sp>
-      <p:cxnSp>
-        <p:nvCxnSpPr>
-          <p:cNvPr id="9" name="Connector 8"/>
-          <p:cNvCxnSpPr/>
-          <p:nvPr/>
-        </p:nvCxnSpPr>
-        <p:spPr>
-          <a:xfrm>
-            <a:off x="3264408" y="3566160"/>
-            <a:ext cx="292608" cy="0"/>
-          </a:xfrm>
-          <a:prstGeom prst="line">
-            <a:avLst/>
-          </a:prstGeom>
-          <a:ln w="38100">
-            <a:solidFill>
-              <a:srgbClr val="2563EB"/>
-            </a:solidFill>
-          </a:ln>
-        </p:spPr>
-        <p:style>
-          <a:lnRef idx="2">
-            <a:schemeClr val="accent1"/>
-          </a:lnRef>
-          <a:fillRef idx="0">
-            <a:schemeClr val="accent1"/>
-          </a:fillRef>
-          <a:effectRef idx="1">
-            <a:schemeClr val="accent1"/>
-          </a:effectRef>
-          <a:fontRef idx="minor">
-            <a:schemeClr val="tx1"/>
-          </a:fontRef>
-        </p:style>
-      </p:cxnSp>
-      <p:sp>
-        <p:nvSpPr>
-          <p:cNvPr id="10" name="Rounded Rectangle 9"/>
-          <p:cNvSpPr/>
-          <p:nvPr/>
-        </p:nvSpPr>
-        <p:spPr>
-          <a:xfrm>
-            <a:off x="6364224" y="2743200"/>
-            <a:ext cx="2514600" cy="1645920"/>
-          </a:xfrm>
-          <a:prstGeom prst="roundRect">
-            <a:avLst/>
-          </a:prstGeom>
-          <a:solidFill>
-            <a:srgbClr val="FFEDD5"/>
-          </a:solidFill>
-          <a:ln w="15875">
-            <a:solidFill>
-              <a:srgbClr val="EA580C"/>
-            </a:solidFill>
-          </a:ln>
-        </p:spPr>
-        <p:style>
-          <a:lnRef idx="1">
-            <a:schemeClr val="accent1"/>
-          </a:lnRef>
-          <a:fillRef idx="3">
-            <a:schemeClr val="accent1"/>
-          </a:fillRef>
-          <a:effectRef idx="2">
-            <a:schemeClr val="accent1"/>
-          </a:effectRef>
-          <a:fontRef idx="minor">
-            <a:schemeClr val="lt1"/>
-          </a:fontRef>
-        </p:style>
-        <p:txBody>
-          <a:bodyPr rtlCol="0" anchor="ctr" wrap="square" tIns="91440" bIns="91440">
-            <a:noAutofit/>
-          </a:bodyPr>
-          <a:lstStyle/>
-          <a:p>
-            <a:pPr algn="ctr"/>
-            <a:r>
-              <a:rPr sz="2200" b="1">
-                <a:solidFill>
-                  <a:srgbClr val="0F172A"/>
-                </a:solidFill>
-                <a:latin typeface="Aptos"/>
-              </a:rPr>
-              <a:t>InferencePool
-inference-aware routing</a:t>
-            </a:r>
-          </a:p>
-        </p:txBody>
-      </p:sp>
-      <p:cxnSp>
-        <p:nvCxnSpPr>
-          <p:cNvPr id="11" name="Connector 10"/>
-          <p:cNvCxnSpPr/>
-          <p:nvPr/>
-        </p:nvCxnSpPr>
-        <p:spPr>
-          <a:xfrm>
-            <a:off x="6071616" y="3566160"/>
-            <a:ext cx="292608" cy="0"/>
-          </a:xfrm>
-          <a:prstGeom prst="line">
-            <a:avLst/>
-          </a:prstGeom>
-          <a:ln w="38100">
-            <a:solidFill>
-              <a:srgbClr val="2563EB"/>
-            </a:solidFill>
-          </a:ln>
-        </p:spPr>
-        <p:style>
-          <a:lnRef idx="2">
-            <a:schemeClr val="accent1"/>
-          </a:lnRef>
-          <a:fillRef idx="0">
-            <a:schemeClr val="accent1"/>
-          </a:fillRef>
-          <a:effectRef idx="1">
-            <a:schemeClr val="accent1"/>
-          </a:effectRef>
-          <a:fontRef idx="minor">
-            <a:schemeClr val="tx1"/>
-          </a:fontRef>
-        </p:style>
-      </p:cxnSp>
-      <p:sp>
-        <p:nvSpPr>
-          <p:cNvPr id="12" name="Rounded Rectangle 11"/>
-          <p:cNvSpPr/>
-          <p:nvPr/>
-        </p:nvSpPr>
-        <p:spPr>
-          <a:xfrm>
-            <a:off x="9171432" y="2743200"/>
-            <a:ext cx="2514600" cy="1645920"/>
-          </a:xfrm>
-          <a:prstGeom prst="roundRect">
-            <a:avLst/>
-          </a:prstGeom>
-          <a:solidFill>
-            <a:srgbClr val="EDE9FE"/>
-          </a:solidFill>
-          <a:ln w="15875">
-            <a:solidFill>
-              <a:srgbClr val="6D28D9"/>
-            </a:solidFill>
-          </a:ln>
-        </p:spPr>
-        <p:style>
-          <a:lnRef idx="1">
-            <a:schemeClr val="accent1"/>
-          </a:lnRef>
-          <a:fillRef idx="3">
-            <a:schemeClr val="accent1"/>
-          </a:fillRef>
-          <a:effectRef idx="2">
-            <a:schemeClr val="accent1"/>
-          </a:effectRef>
-          <a:fontRef idx="minor">
-            <a:schemeClr val="lt1"/>
-          </a:fontRef>
-        </p:style>
-        <p:txBody>
-          <a:bodyPr rtlCol="0" anchor="ctr" wrap="square" tIns="91440" bIns="91440">
-            <a:noAutofit/>
-          </a:bodyPr>
-          <a:lstStyle/>
-          <a:p>
-            <a:pPr algn="ctr"/>
-            <a:r>
-              <a:rPr sz="2000" b="1">
-                <a:solidFill>
-                  <a:srgbClr val="0F172A"/>
-                </a:solidFill>
-                <a:latin typeface="Aptos"/>
-              </a:rPr>
-              <a:t>MultiRoleInference
-distributed topology</a:t>
-            </a:r>
-          </a:p>
-        </p:txBody>
-      </p:sp>
-      <p:cxnSp>
-        <p:nvCxnSpPr>
-          <p:cNvPr id="13" name="Connector 12"/>
-          <p:cNvCxnSpPr/>
-          <p:nvPr/>
-        </p:nvCxnSpPr>
-        <p:spPr>
-          <a:xfrm>
-            <a:off x="8878824" y="3566160"/>
-            <a:ext cx="292608" cy="0"/>
-          </a:xfrm>
-          <a:prstGeom prst="line">
-            <a:avLst/>
-          </a:prstGeom>
-          <a:ln w="38100">
-            <a:solidFill>
-              <a:srgbClr val="2563EB"/>
-            </a:solidFill>
-          </a:ln>
-        </p:spPr>
-        <p:style>
-          <a:lnRef idx="2">
-            <a:schemeClr val="accent1"/>
-          </a:lnRef>
-          <a:fillRef idx="0">
-            <a:schemeClr val="accent1"/>
-          </a:fillRef>
-          <a:effectRef idx="1">
-            <a:schemeClr val="accent1"/>
-          </a:effectRef>
-          <a:fontRef idx="minor">
-            <a:schemeClr val="tx1"/>
-          </a:fontRef>
-        </p:style>
-      </p:cxnSp>
-      <p:sp>
-        <p:nvSpPr>
-          <p:cNvPr id="14" name="Rectangle 13"/>
-          <p:cNvSpPr/>
-          <p:nvPr/>
-        </p:nvSpPr>
-        <p:spPr>
-          <a:xfrm>
-            <a:off x="1143000" y="4892040"/>
-            <a:ext cx="9966960" cy="731520"/>
-          </a:xfrm>
-          <a:prstGeom prst="rect">
-            <a:avLst/>
-          </a:prstGeom>
-          <a:noFill/>
-          <a:ln>
-            <a:noFill/>
-          </a:ln>
-        </p:spPr>
-        <p:style>
-          <a:lnRef idx="1">
-            <a:schemeClr val="accent1"/>
-          </a:lnRef>
-          <a:fillRef idx="3">
-            <a:schemeClr val="accent1"/>
-          </a:fillRef>
-          <a:effectRef idx="2">
-            <a:schemeClr val="accent1"/>
-          </a:effectRef>
-          <a:fontRef idx="minor">
-            <a:schemeClr val="lt1"/>
-          </a:fontRef>
-        </p:style>
-        <p:txBody>
-          <a:bodyPr rtlCol="0" anchor="ctr" wrap="square" tIns="91440" bIns="91440">
-            <a:noAutofit/>
-          </a:bodyPr>
-          <a:lstStyle/>
-          <a:p>
-            <a:pPr algn="ctr"/>
-            <a:r>
-              <a:rPr sz="1800" b="1">
-                <a:solidFill>
-                  <a:srgbClr val="334155"/>
-                </a:solidFill>
-                <a:latin typeface="Aptos"/>
-              </a:rPr>
-              <a:t>Same platform. Higher-level objects as the serving problem gets harder.</a:t>
+              <a:t>Docs architecture view: KAITO packages serving, routing, and operations into one Kubernetes-native platform model.</a:t>
             </a:r>
           </a:p>
         </p:txBody>
@@ -14480,14 +14360,14 @@
         </p:nvSpPr>
         <p:spPr>
           <a:xfrm>
-            <a:off x="4434840" y="2331720"/>
-            <a:ext cx="3291840" cy="1097280"/>
+            <a:off x="749808" y="1078992"/>
+            <a:ext cx="10744200" cy="731520"/>
           </a:xfrm>
           <a:prstGeom prst="roundRect">
             <a:avLst/>
           </a:prstGeom>
           <a:solidFill>
-            <a:srgbClr val="2563EB"/>
+            <a:srgbClr val="FFFFFF"/>
           </a:solidFill>
           <a:ln>
             <a:noFill/>
@@ -14515,13 +14395,13 @@
           <a:p>
             <a:pPr algn="ctr"/>
             <a:r>
-              <a:rPr sz="3000" b="1">
-                <a:solidFill>
-                  <a:srgbClr val="FFFFFF"/>
+              <a:rPr sz="2100" b="1">
+                <a:solidFill>
+                  <a:srgbClr val="0F172A"/>
                 </a:solidFill>
                 <a:latin typeface="Aptos"/>
               </a:rPr>
-              <a:t>KEDA</a:t>
+              <a:t>KEDA fits LLM inference because it scales on external workload signals, not just CPU and memory proxies.</a:t>
             </a:r>
           </a:p>
         </p:txBody>
@@ -14534,8 +14414,75 @@
         </p:nvSpPr>
         <p:spPr>
           <a:xfrm>
-            <a:off x="868680" y="1417320"/>
-            <a:ext cx="2331720" cy="868680"/>
+            <a:off x="868680" y="1920240"/>
+            <a:ext cx="7269480" cy="3794760"/>
+          </a:xfrm>
+          <a:prstGeom prst="roundRect">
+            <a:avLst/>
+          </a:prstGeom>
+          <a:solidFill>
+            <a:srgbClr val="FFFFFF"/>
+          </a:solidFill>
+          <a:ln>
+            <a:noFill/>
+          </a:ln>
+        </p:spPr>
+        <p:style>
+          <a:lnRef idx="1">
+            <a:schemeClr val="accent1"/>
+          </a:lnRef>
+          <a:fillRef idx="3">
+            <a:schemeClr val="accent1"/>
+          </a:fillRef>
+          <a:effectRef idx="2">
+            <a:schemeClr val="accent1"/>
+          </a:effectRef>
+          <a:fontRef idx="minor">
+            <a:schemeClr val="lt1"/>
+          </a:fontRef>
+        </p:style>
+        <p:txBody>
+          <a:bodyPr rtlCol="0" anchor="ctr"/>
+          <a:lstStyle/>
+          <a:p>
+            <a:pPr algn="ctr"/>
+          </a:p>
+        </p:txBody>
+      </p:sp>
+      <p:pic>
+        <p:nvPicPr>
+          <p:cNvPr id="8" name="Picture 7" descr="keda-kaito-scaler-arch.png"/>
+          <p:cNvPicPr>
+            <a:picLocks noChangeAspect="1"/>
+          </p:cNvPicPr>
+          <p:nvPr/>
+        </p:nvPicPr>
+        <p:blipFill>
+          <a:blip r:embed="rId2"/>
+          <a:stretch>
+            <a:fillRect/>
+          </a:stretch>
+        </p:blipFill>
+        <p:spPr>
+          <a:xfrm>
+            <a:off x="1051560" y="2148840"/>
+            <a:ext cx="6903720" cy="3383280"/>
+          </a:xfrm>
+          <a:prstGeom prst="rect">
+            <a:avLst/>
+          </a:prstGeom>
+        </p:spPr>
+      </p:pic>
+      <p:sp>
+        <p:nvSpPr>
+          <p:cNvPr id="9" name="Rounded Rectangle 8"/>
+          <p:cNvSpPr/>
+          <p:nvPr/>
+        </p:nvSpPr>
+        <p:spPr>
+          <a:xfrm>
+            <a:off x="8366760" y="2011680"/>
+            <a:ext cx="3017520" cy="3611880"/>
           </a:xfrm>
           <a:prstGeom prst="roundRect">
             <a:avLst/>
@@ -14545,7 +14492,7 @@
           </a:solidFill>
           <a:ln w="15875">
             <a:solidFill>
-              <a:srgbClr val="CBD5E1"/>
+              <a:srgbClr val="16A34A"/>
             </a:solidFill>
           </a:ln>
         </p:spPr>
@@ -14569,40 +14516,36 @@
           </a:bodyPr>
           <a:lstStyle/>
           <a:p>
-            <a:pPr algn="ctr"/>
-            <a:r>
-              <a:rPr sz="1800" b="1">
+            <a:pPr algn="l"/>
+            <a:r>
+              <a:rPr sz="2000" b="0">
                 <a:solidFill>
                   <a:srgbClr val="0F172A"/>
                 </a:solidFill>
                 <a:latin typeface="Aptos"/>
               </a:rPr>
-              <a:t>external metrics</a:t>
-            </a:r>
-          </a:p>
-        </p:txBody>
-      </p:sp>
-      <p:sp>
-        <p:nvSpPr>
-          <p:cNvPr id="8" name="Rounded Rectangle 7"/>
-          <p:cNvSpPr/>
-          <p:nvPr/>
-        </p:nvSpPr>
-        <p:spPr>
-          <a:xfrm>
-            <a:off x="868680" y="4160520"/>
-            <a:ext cx="2331720" cy="868680"/>
-          </a:xfrm>
-          <a:prstGeom prst="roundRect">
-            <a:avLst/>
-          </a:prstGeom>
-          <a:solidFill>
-            <a:srgbClr val="FFFFFF"/>
-          </a:solidFill>
-          <a:ln w="15875">
-            <a:solidFill>
-              <a:srgbClr val="CBD5E1"/>
-            </a:solidFill>
+              <a:t/>
+            </a:r>
+          </a:p>
+        </p:txBody>
+      </p:sp>
+      <p:sp>
+        <p:nvSpPr>
+          <p:cNvPr id="10" name="Rectangle 9"/>
+          <p:cNvSpPr/>
+          <p:nvPr/>
+        </p:nvSpPr>
+        <p:spPr>
+          <a:xfrm>
+            <a:off x="8531352" y="2103120"/>
+            <a:ext cx="2688336" cy="384048"/>
+          </a:xfrm>
+          <a:prstGeom prst="rect">
+            <a:avLst/>
+          </a:prstGeom>
+          <a:noFill/>
+          <a:ln>
+            <a:noFill/>
           </a:ln>
         </p:spPr>
         <p:style>
@@ -14625,319 +14568,98 @@
           </a:bodyPr>
           <a:lstStyle/>
           <a:p>
-            <a:pPr algn="ctr"/>
-            <a:r>
-              <a:rPr sz="1800" b="1">
+            <a:pPr algn="l"/>
+            <a:r>
+              <a:rPr sz="1900" b="1">
                 <a:solidFill>
                   <a:srgbClr val="0F172A"/>
                 </a:solidFill>
                 <a:latin typeface="Aptos"/>
               </a:rPr>
-              <a:t>cron triggers</a:t>
-            </a:r>
-          </a:p>
-        </p:txBody>
-      </p:sp>
-      <p:sp>
-        <p:nvSpPr>
-          <p:cNvPr id="9" name="Rounded Rectangle 8"/>
-          <p:cNvSpPr/>
-          <p:nvPr/>
-        </p:nvSpPr>
-        <p:spPr>
-          <a:xfrm>
-            <a:off x="9006840" y="1417320"/>
-            <a:ext cx="2331720" cy="868680"/>
-          </a:xfrm>
-          <a:prstGeom prst="roundRect">
-            <a:avLst/>
-          </a:prstGeom>
-          <a:solidFill>
-            <a:srgbClr val="FFFFFF"/>
-          </a:solidFill>
-          <a:ln w="15875">
-            <a:solidFill>
-              <a:srgbClr val="CBD5E1"/>
-            </a:solidFill>
-          </a:ln>
-        </p:spPr>
-        <p:style>
-          <a:lnRef idx="1">
-            <a:schemeClr val="accent1"/>
-          </a:lnRef>
-          <a:fillRef idx="3">
-            <a:schemeClr val="accent1"/>
-          </a:fillRef>
-          <a:effectRef idx="2">
-            <a:schemeClr val="accent1"/>
-          </a:effectRef>
-          <a:fontRef idx="minor">
-            <a:schemeClr val="lt1"/>
-          </a:fontRef>
-        </p:style>
-        <p:txBody>
-          <a:bodyPr rtlCol="0" anchor="ctr" wrap="square" tIns="91440" bIns="91440">
-            <a:noAutofit/>
+              <a:t>Why it matters</a:t>
+            </a:r>
+          </a:p>
+        </p:txBody>
+      </p:sp>
+      <p:sp>
+        <p:nvSpPr>
+          <p:cNvPr id="11" name="TextBox 10"/>
+          <p:cNvSpPr txBox="1"/>
+          <p:nvPr/>
+        </p:nvSpPr>
+        <p:spPr>
+          <a:xfrm>
+            <a:off x="8549640" y="2542032"/>
+            <a:ext cx="2651760" cy="2953512"/>
+          </a:xfrm>
+          <a:prstGeom prst="rect">
+            <a:avLst/>
+          </a:prstGeom>
+          <a:noFill/>
+        </p:spPr>
+        <p:txBody>
+          <a:bodyPr wrap="square" lIns="0" rIns="0" tIns="0" bIns="0">
+            <a:spAutoFit/>
           </a:bodyPr>
           <a:lstStyle/>
           <a:p>
-            <a:pPr algn="ctr"/>
-            <a:r>
-              <a:rPr sz="1800" b="1">
-                <a:solidFill>
-                  <a:srgbClr val="0F172A"/>
-                </a:solidFill>
-                <a:latin typeface="Aptos"/>
-              </a:rPr>
-              <a:t>scale decisions</a:t>
-            </a:r>
-          </a:p>
-        </p:txBody>
-      </p:sp>
-      <p:sp>
-        <p:nvSpPr>
-          <p:cNvPr id="10" name="Rounded Rectangle 9"/>
-          <p:cNvSpPr/>
-          <p:nvPr/>
-        </p:nvSpPr>
-        <p:spPr>
-          <a:xfrm>
-            <a:off x="9006840" y="4160520"/>
-            <a:ext cx="2331720" cy="868680"/>
-          </a:xfrm>
-          <a:prstGeom prst="roundRect">
-            <a:avLst/>
-          </a:prstGeom>
-          <a:solidFill>
-            <a:srgbClr val="FFFFFF"/>
-          </a:solidFill>
-          <a:ln w="15875">
-            <a:solidFill>
-              <a:srgbClr val="CBD5E1"/>
-            </a:solidFill>
-          </a:ln>
-        </p:spPr>
-        <p:style>
-          <a:lnRef idx="1">
-            <a:schemeClr val="accent1"/>
-          </a:lnRef>
-          <a:fillRef idx="3">
-            <a:schemeClr val="accent1"/>
-          </a:fillRef>
-          <a:effectRef idx="2">
-            <a:schemeClr val="accent1"/>
-          </a:effectRef>
-          <a:fontRef idx="minor">
-            <a:schemeClr val="lt1"/>
-          </a:fontRef>
-        </p:style>
-        <p:txBody>
-          <a:bodyPr rtlCol="0" anchor="ctr" wrap="square" tIns="91440" bIns="91440">
-            <a:noAutofit/>
-          </a:bodyPr>
-          <a:lstStyle/>
-          <a:p>
-            <a:pPr algn="ctr"/>
-            <a:r>
-              <a:rPr sz="1800" b="1">
-                <a:solidFill>
-                  <a:srgbClr val="0F172A"/>
-                </a:solidFill>
-                <a:latin typeface="Aptos"/>
-              </a:rPr>
-              <a:t>inference workloads</a:t>
-            </a:r>
-          </a:p>
-        </p:txBody>
-      </p:sp>
-      <p:cxnSp>
-        <p:nvCxnSpPr>
-          <p:cNvPr id="11" name="Connector 10"/>
-          <p:cNvCxnSpPr/>
-          <p:nvPr/>
-        </p:nvCxnSpPr>
-        <p:spPr>
-          <a:xfrm>
-            <a:off x="3200400" y="1874519"/>
-            <a:ext cx="1234440" cy="822961"/>
-          </a:xfrm>
-          <a:prstGeom prst="line">
-            <a:avLst/>
-          </a:prstGeom>
-          <a:ln w="31750">
-            <a:solidFill>
-              <a:srgbClr val="16A34A"/>
-            </a:solidFill>
-          </a:ln>
-        </p:spPr>
-        <p:style>
-          <a:lnRef idx="2">
-            <a:schemeClr val="accent1"/>
-          </a:lnRef>
-          <a:fillRef idx="0">
-            <a:schemeClr val="accent1"/>
-          </a:fillRef>
-          <a:effectRef idx="1">
-            <a:schemeClr val="accent1"/>
-          </a:effectRef>
-          <a:fontRef idx="minor">
-            <a:schemeClr val="tx1"/>
-          </a:fontRef>
-        </p:style>
-      </p:cxnSp>
-      <p:cxnSp>
-        <p:nvCxnSpPr>
-          <p:cNvPr id="12" name="Connector 11"/>
-          <p:cNvCxnSpPr/>
-          <p:nvPr/>
-        </p:nvCxnSpPr>
-        <p:spPr>
-          <a:xfrm flipV="1">
-            <a:off x="3200400" y="3063240"/>
-            <a:ext cx="1234440" cy="1554480"/>
-          </a:xfrm>
-          <a:prstGeom prst="line">
-            <a:avLst/>
-          </a:prstGeom>
-          <a:ln w="31750">
-            <a:solidFill>
-              <a:srgbClr val="16A34A"/>
-            </a:solidFill>
-          </a:ln>
-        </p:spPr>
-        <p:style>
-          <a:lnRef idx="2">
-            <a:schemeClr val="accent1"/>
-          </a:lnRef>
-          <a:fillRef idx="0">
-            <a:schemeClr val="accent1"/>
-          </a:fillRef>
-          <a:effectRef idx="1">
-            <a:schemeClr val="accent1"/>
-          </a:effectRef>
-          <a:fontRef idx="minor">
-            <a:schemeClr val="tx1"/>
-          </a:fontRef>
-        </p:style>
-      </p:cxnSp>
-      <p:cxnSp>
-        <p:nvCxnSpPr>
-          <p:cNvPr id="13" name="Connector 12"/>
-          <p:cNvCxnSpPr/>
-          <p:nvPr/>
-        </p:nvCxnSpPr>
-        <p:spPr>
-          <a:xfrm flipV="1">
-            <a:off x="7726679" y="1874519"/>
-            <a:ext cx="1280161" cy="822961"/>
-          </a:xfrm>
-          <a:prstGeom prst="line">
-            <a:avLst/>
-          </a:prstGeom>
-          <a:ln w="31750">
-            <a:solidFill>
-              <a:srgbClr val="16A34A"/>
-            </a:solidFill>
-          </a:ln>
-        </p:spPr>
-        <p:style>
-          <a:lnRef idx="2">
-            <a:schemeClr val="accent1"/>
-          </a:lnRef>
-          <a:fillRef idx="0">
-            <a:schemeClr val="accent1"/>
-          </a:fillRef>
-          <a:effectRef idx="1">
-            <a:schemeClr val="accent1"/>
-          </a:effectRef>
-          <a:fontRef idx="minor">
-            <a:schemeClr val="tx1"/>
-          </a:fontRef>
-        </p:style>
-      </p:cxnSp>
-      <p:cxnSp>
-        <p:nvCxnSpPr>
-          <p:cNvPr id="14" name="Connector 13"/>
-          <p:cNvCxnSpPr/>
-          <p:nvPr/>
-        </p:nvCxnSpPr>
-        <p:spPr>
-          <a:xfrm>
-            <a:off x="7726679" y="3063240"/>
-            <a:ext cx="1280161" cy="1554480"/>
-          </a:xfrm>
-          <a:prstGeom prst="line">
-            <a:avLst/>
-          </a:prstGeom>
-          <a:ln w="31750">
-            <a:solidFill>
-              <a:srgbClr val="16A34A"/>
-            </a:solidFill>
-          </a:ln>
-        </p:spPr>
-        <p:style>
-          <a:lnRef idx="2">
-            <a:schemeClr val="accent1"/>
-          </a:lnRef>
-          <a:fillRef idx="0">
-            <a:schemeClr val="accent1"/>
-          </a:fillRef>
-          <a:effectRef idx="1">
-            <a:schemeClr val="accent1"/>
-          </a:effectRef>
-          <a:fontRef idx="minor">
-            <a:schemeClr val="tx1"/>
-          </a:fontRef>
-        </p:style>
-      </p:cxnSp>
-      <p:sp>
-        <p:nvSpPr>
-          <p:cNvPr id="15" name="Rectangle 14"/>
-          <p:cNvSpPr/>
-          <p:nvPr/>
-        </p:nvSpPr>
-        <p:spPr>
-          <a:xfrm>
-            <a:off x="1828800" y="5486400"/>
-            <a:ext cx="8595360" cy="502920"/>
-          </a:xfrm>
-          <a:prstGeom prst="rect">
-            <a:avLst/>
-          </a:prstGeom>
-          <a:noFill/>
-          <a:ln>
-            <a:noFill/>
-          </a:ln>
-        </p:spPr>
-        <p:style>
-          <a:lnRef idx="1">
-            <a:schemeClr val="accent1"/>
-          </a:lnRef>
-          <a:fillRef idx="3">
-            <a:schemeClr val="accent1"/>
-          </a:fillRef>
-          <a:effectRef idx="2">
-            <a:schemeClr val="accent1"/>
-          </a:effectRef>
-          <a:fontRef idx="minor">
-            <a:schemeClr val="lt1"/>
-          </a:fontRef>
-        </p:style>
-        <p:txBody>
-          <a:bodyPr rtlCol="0" anchor="ctr" wrap="square" tIns="91440" bIns="91440">
-            <a:noAutofit/>
-          </a:bodyPr>
-          <a:lstStyle/>
-          <a:p>
-            <a:pPr algn="ctr"/>
-            <a:r>
-              <a:rPr sz="1600" b="1">
+            <a:pPr>
+              <a:spcAft>
+                <a:spcPts val="500"/>
+              </a:spcAft>
+              <a:defRPr sz="1400">
                 <a:solidFill>
                   <a:srgbClr val="334155"/>
                 </a:solidFill>
-                <a:latin typeface="Aptos"/>
-              </a:rPr>
-              <a:t>KEDA shifts autoscaling from generic resource proxies to workload-aware external signals.</a:t>
+              </a:defRPr>
+            </a:pPr>
+            <a:r>
+              <a:t>Metric-based scaling for inference queues</a:t>
+            </a:r>
+          </a:p>
+          <a:p>
+            <a:pPr>
+              <a:spcAft>
+                <a:spcPts val="500"/>
+              </a:spcAft>
+              <a:defRPr sz="1400">
+                <a:solidFill>
+                  <a:srgbClr val="334155"/>
+                </a:solidFill>
+              </a:defRPr>
+            </a:pPr>
+            <a:r>
+              <a:t>Time-based scaling for predictable traffic</a:t>
+            </a:r>
+          </a:p>
+          <a:p>
+            <a:pPr>
+              <a:spcAft>
+                <a:spcPts val="500"/>
+              </a:spcAft>
+              <a:defRPr sz="1400">
+                <a:solidFill>
+                  <a:srgbClr val="334155"/>
+                </a:solidFill>
+              </a:defRPr>
+            </a:pPr>
+            <a:r>
+              <a:t>InferenceSet as the scaling boundary</a:t>
+            </a:r>
+          </a:p>
+          <a:p>
+            <a:pPr>
+              <a:spcAft>
+                <a:spcPts val="500"/>
+              </a:spcAft>
+              <a:defRPr sz="1400">
+                <a:solidFill>
+                  <a:srgbClr val="334155"/>
+                </a:solidFill>
+              </a:defRPr>
+            </a:pPr>
+            <a:r>
+              <a:t>Dedicated KAITO scaler removes extra Prometheus dependency for this flow</a:t>
             </a:r>
           </a:p>
         </p:txBody>

</xml_diff>

<commit_message>
docs: update kubecon NA 2026 P/D deck copy
</commit_message>
<xml_diff>
--- a/llm/kubecon-na-2026-pd-disaggregation.pptx
+++ b/llm/kubecon-na-2026-pd-disaggregation.pptx
@@ -4358,15 +4358,8 @@
           </a:bodyPr>
           <a:lstStyle/>
           <a:p>
-            <a:pPr algn="l"/>
-            <a:r>
-              <a:rPr sz="2400" b="1">
-                <a:solidFill>
-                  <a:srgbClr val="FFFFFF"/>
-                </a:solidFill>
-                <a:latin typeface="Aptos Display"/>
-              </a:rPr>
-              <a:t>Existing approaches in the ecosystem</a:t>
+            <a:r>
+              <a:t>Why put KAITO on top of llm-d?</a:t>
             </a:r>
           </a:p>
         </p:txBody>
@@ -4436,48 +4429,34 @@
           </a:bodyPr>
           <a:lstStyle/>
           <a:p>
-            <a:pPr>
-              <a:spcAft>
-                <a:spcPts val="800"/>
-              </a:spcAft>
-              <a:defRPr sz="2100">
-                <a:solidFill>
-                  <a:srgbClr val="334155"/>
-                </a:solidFill>
-              </a:defRPr>
-            </a:pPr>
-            <a:r>
-              <a:t>NVIDIA Dynamo: powerful, but tightly coupled to the NVIDIA stack</a:t>
-            </a:r>
-          </a:p>
-          <a:p>
-            <a:pPr>
-              <a:spcAft>
-                <a:spcPts val="800"/>
-              </a:spcAft>
-              <a:defRPr sz="2100">
-                <a:solidFill>
-                  <a:srgbClr val="334155"/>
-                </a:solidFill>
-              </a:defRPr>
-            </a:pPr>
-            <a:r>
-              <a:t>llm-d standalone: Kubernetes-native, but still operationally manual</a:t>
-            </a:r>
-          </a:p>
-          <a:p>
-            <a:pPr>
-              <a:spcAft>
-                <a:spcPts val="800"/>
-              </a:spcAft>
-              <a:defRPr sz="2100">
-                <a:solidFill>
-                  <a:srgbClr val="334155"/>
-                </a:solidFill>
-              </a:defRPr>
-            </a:pPr>
-            <a:r>
-              <a:t>need for a declarative Kubernetes abstraction layer on top</a:t>
+            <a:r>
+              <a:t>Manual llm-d stack: strong routing primitives, but too much wiring around sidecars, labels, ports, configmaps, and lifecycle ownership</a:t>
+            </a:r>
+          </a:p>
+          <a:p>
+            <a:r>
+              <a:t>Dynamo: full-stack disaggregated inference, but heavier runtime coupling and less natural fit for Kubernetes operators</a:t>
+            </a:r>
+          </a:p>
+          <a:p>
+            <a:r>
+              <a:t>KAITO + llm-d: declarative Kubernetes abstraction on top of proven routing primitives</a:t>
+            </a:r>
+          </a:p>
+          <a:p/>
+          <a:p>
+            <a:r>
+              <a:t>llm-d solves routing and scheduling</a:t>
+            </a:r>
+          </a:p>
+          <a:p>
+            <a:r>
+              <a:t>KAITO solves lifecycle and platform automation</a:t>
+            </a:r>
+          </a:p>
+          <a:p>
+            <a:r>
+              <a:t>Together they turn distributed inference into an operator workflow</a:t>
             </a:r>
           </a:p>
         </p:txBody>
@@ -4521,15 +4500,8 @@
           </a:bodyPr>
           <a:lstStyle/>
           <a:p>
-            <a:pPr algn="r"/>
-            <a:r>
-              <a:rPr sz="1100" b="0">
-                <a:solidFill>
-                  <a:srgbClr val="64748B"/>
-                </a:solidFill>
-                <a:latin typeface="Aptos"/>
-              </a:rPr>
-              <a:t>Keep this balanced and brief.</a:t>
+            <a:r>
+              <a:t>The key question is not just who can route requests — it is who owns all the surrounding contracts.</a:t>
             </a:r>
           </a:p>
         </p:txBody>
@@ -11215,15 +11187,8 @@
           </a:bodyPr>
           <a:lstStyle/>
           <a:p>
-            <a:pPr algn="l"/>
-            <a:r>
-              <a:rPr sz="2400" b="1">
-                <a:solidFill>
-                  <a:srgbClr val="FFFFFF"/>
-                </a:solidFill>
-                <a:latin typeface="Aptos Display"/>
-              </a:rPr>
-              <a:t>What MultiRoleInference declares</a:t>
+            <a:r>
+              <a:t>MultiRoleInference: one CRD for P/D disaggregation</a:t>
             </a:r>
           </a:p>
         </p:txBody>
@@ -11293,63 +11258,28 @@
           </a:bodyPr>
           <a:lstStyle/>
           <a:p>
-            <a:pPr>
-              <a:spcAft>
-                <a:spcPts val="800"/>
-              </a:spcAft>
-              <a:defRPr sz="2100">
-                <a:solidFill>
-                  <a:srgbClr val="334155"/>
-                </a:solidFill>
-              </a:defRPr>
-            </a:pPr>
             <a:r>
               <a:t>one logical inference service</a:t>
             </a:r>
           </a:p>
           <a:p>
-            <a:pPr>
-              <a:spcAft>
-                <a:spcPts val="800"/>
-              </a:spcAft>
-              <a:defRPr sz="2100">
-                <a:solidFill>
-                  <a:srgbClr val="334155"/>
-                </a:solidFill>
-              </a:defRPr>
-            </a:pPr>
-            <a:r>
-              <a:t>two roles</a:t>
-            </a:r>
-          </a:p>
-          <a:p>
-            <a:pPr>
-              <a:spcAft>
-                <a:spcPts val="800"/>
-              </a:spcAft>
-              <a:defRPr sz="2100">
-                <a:solidFill>
-                  <a:srgbClr val="334155"/>
-                </a:solidFill>
-              </a:defRPr>
-            </a:pPr>
-            <a:r>
-              <a:t>role-specific scaling and runtime behavior</a:t>
-            </a:r>
-          </a:p>
-          <a:p>
-            <a:pPr>
-              <a:spcAft>
-                <a:spcPts val="800"/>
-              </a:spcAft>
-              <a:defRPr sz="2100">
-                <a:solidFill>
-                  <a:srgbClr val="334155"/>
-                </a:solidFill>
-              </a:defRPr>
-            </a:pPr>
-            <a:r>
-              <a:t>a single user-facing object for the whole P/D topology</a:t>
+            <a:r>
+              <a:t>shared model intent and one service topology</a:t>
+            </a:r>
+          </a:p>
+          <a:p>
+            <a:r>
+              <a:t>prefill and decode declared as separate roles</a:t>
+            </a:r>
+          </a:p>
+          <a:p>
+            <a:r>
+              <a:t>role-specific replica counts and runtime behavior</a:t>
+            </a:r>
+          </a:p>
+          <a:p>
+            <a:r>
+              <a:t>one user-facing object for the whole P/D topology</a:t>
             </a:r>
           </a:p>
         </p:txBody>
@@ -11393,15 +11323,8 @@
           </a:bodyPr>
           <a:lstStyle/>
           <a:p>
-            <a:pPr algn="r"/>
-            <a:r>
-              <a:rPr sz="1100" b="0">
-                <a:solidFill>
-                  <a:srgbClr val="64748B"/>
-                </a:solidFill>
-                <a:latin typeface="Aptos"/>
-              </a:rPr>
-              <a:t>Show the API intent before the generated objects.</a:t>
+            <a:r>
+              <a:t>The CRD is the product surface; the controller should own the rest of the plumbing.</a:t>
             </a:r>
           </a:p>
         </p:txBody>
@@ -11609,15 +11532,8 @@
           </a:bodyPr>
           <a:lstStyle/>
           <a:p>
-            <a:pPr algn="l"/>
-            <a:r>
-              <a:rPr sz="2400" b="1">
-                <a:solidFill>
-                  <a:srgbClr val="FFFFFF"/>
-                </a:solidFill>
-                <a:latin typeface="Aptos Display"/>
-              </a:rPr>
-              <a:t>What MultiRoleInference generates</a:t>
+            <a:r>
+              <a:t>What one MultiRoleInference CR generates</a:t>
             </a:r>
           </a:p>
         </p:txBody>
@@ -11687,91 +11603,31 @@
           </a:bodyPr>
           <a:lstStyle/>
           <a:p>
-            <a:pPr>
-              <a:spcAft>
-                <a:spcPts val="800"/>
-              </a:spcAft>
-              <a:defRPr sz="2100">
-                <a:solidFill>
-                  <a:srgbClr val="334155"/>
-                </a:solidFill>
-              </a:defRPr>
-            </a:pPr>
-            <a:r>
-              <a:t>child InferenceSet for prefill</a:t>
-            </a:r>
-          </a:p>
-          <a:p>
-            <a:pPr>
-              <a:spcAft>
-                <a:spcPts val="800"/>
-              </a:spcAft>
-              <a:defRPr sz="2100">
-                <a:solidFill>
-                  <a:srgbClr val="334155"/>
-                </a:solidFill>
-              </a:defRPr>
-            </a:pPr>
-            <a:r>
-              <a:t>child InferenceSet for decode</a:t>
-            </a:r>
-          </a:p>
-          <a:p>
-            <a:pPr>
-              <a:spcAft>
-                <a:spcPts val="800"/>
-              </a:spcAft>
-              <a:defRPr sz="2100">
-                <a:solidFill>
-                  <a:srgbClr val="334155"/>
-                </a:solidFill>
-              </a:defRPr>
-            </a:pPr>
-            <a:r>
-              <a:t>decode-side llm-d routing sidecar injection</a:t>
-            </a:r>
-          </a:p>
-          <a:p>
-            <a:pPr>
-              <a:spcAft>
-                <a:spcPts val="800"/>
-              </a:spcAft>
-              <a:defRPr sz="2100">
-                <a:solidFill>
-                  <a:srgbClr val="334155"/>
-                </a:solidFill>
-              </a:defRPr>
-            </a:pPr>
-            <a:r>
-              <a:t>one InferencePool with correct targetPort wiring</a:t>
-            </a:r>
-          </a:p>
-          <a:p>
-            <a:pPr>
-              <a:spcAft>
-                <a:spcPts val="800"/>
-              </a:spcAft>
-              <a:defRPr sz="2100">
-                <a:solidFill>
-                  <a:srgbClr val="334155"/>
-                </a:solidFill>
-              </a:defRPr>
-            </a:pPr>
+            <a:r>
+              <a:t>prefill InferenceSet</a:t>
+            </a:r>
+          </a:p>
+          <a:p>
+            <a:r>
+              <a:t>decode InferenceSet</a:t>
+            </a:r>
+          </a:p>
+          <a:p>
+            <a:r>
+              <a:t>shared InferencePool</a:t>
+            </a:r>
+          </a:p>
+          <a:p>
             <a:r>
               <a:t>llm-d Router EPP deployment and plugin chain</a:t>
             </a:r>
           </a:p>
           <a:p>
-            <a:pPr>
-              <a:spcAft>
-                <a:spcPts val="800"/>
-              </a:spcAft>
-              <a:defRPr sz="2100">
-                <a:solidFill>
-                  <a:srgbClr val="334155"/>
-                </a:solidFill>
-              </a:defRPr>
-            </a:pPr>
+            <a:r>
+              <a:t>gateway-facing routing resources</a:t>
+            </a:r>
+          </a:p>
+          <a:p>
             <a:r>
               <a:t>per-role autoscaling hooks via child InferenceSets</a:t>
             </a:r>
@@ -11817,15 +11673,8 @@
           </a:bodyPr>
           <a:lstStyle/>
           <a:p>
-            <a:pPr algn="r"/>
-            <a:r>
-              <a:rPr sz="1100" b="0">
-                <a:solidFill>
-                  <a:srgbClr val="64748B"/>
-                </a:solidFill>
-                <a:latin typeface="Aptos"/>
-              </a:rPr>
-              <a:t>Show what KAITO creates for the user.</a:t>
+            <a:r>
+              <a:t>KAITO does not replace llm-d; it generates and keeps the llm-d-facing resources consistent.</a:t>
             </a:r>
           </a:p>
         </p:txBody>
@@ -12033,15 +11882,8 @@
           </a:bodyPr>
           <a:lstStyle/>
           <a:p>
-            <a:pPr algn="l"/>
-            <a:r>
-              <a:rPr sz="2400" b="1">
-                <a:solidFill>
-                  <a:srgbClr val="FFFFFF"/>
-                </a:solidFill>
-                <a:latin typeface="Aptos Display"/>
-              </a:rPr>
-              <a:t>Why the decode-side sidecar exists</a:t>
+            <a:r>
+              <a:t>The runtime contracts that make P/D actually work</a:t>
             </a:r>
           </a:p>
         </p:txBody>
@@ -12111,48 +11953,28 @@
           </a:bodyPr>
           <a:lstStyle/>
           <a:p>
-            <a:pPr>
-              <a:spcAft>
-                <a:spcPts val="800"/>
-              </a:spcAft>
-              <a:defRPr sz="2100">
-                <a:solidFill>
-                  <a:srgbClr val="334155"/>
-                </a:solidFill>
-              </a:defRPr>
-            </a:pPr>
-            <a:r>
-              <a:t>stable client-facing entrypoint on port 5000</a:t>
-            </a:r>
-          </a:p>
-          <a:p>
-            <a:pPr>
-              <a:spcAft>
-                <a:spcPts val="800"/>
-              </a:spcAft>
-              <a:defRPr sz="2100">
-                <a:solidFill>
-                  <a:srgbClr val="334155"/>
-                </a:solidFill>
-              </a:defRPr>
-            </a:pPr>
-            <a:r>
-              <a:t>internal prefill coordination</a:t>
-            </a:r>
-          </a:p>
-          <a:p>
-            <a:pPr>
-              <a:spcAft>
-                <a:spcPts val="800"/>
-              </a:spcAft>
-              <a:defRPr sz="2100">
-                <a:solidFill>
-                  <a:srgbClr val="334155"/>
-                </a:solidFill>
-              </a:defRPr>
-            </a:pPr>
-            <a:r>
-              <a:t>local decode remains stream owner on vLLM port 5001</a:t>
+            <a:r>
+              <a:t>decode-only sidecar is the stable pattern; prefill stays lightweight</a:t>
+            </a:r>
+          </a:p>
+          <a:p>
+            <a:r>
+              <a:t>InferencePool.targetPort must align with the routing path across the pool</a:t>
+            </a:r>
+          </a:p>
+          <a:p>
+            <a:r>
+              <a:t>role labels are functional metadata for worker selection</a:t>
+            </a:r>
+          </a:p>
+          <a:p>
+            <a:r>
+              <a:t>VLLM_NIXL_SIDE_CHANNEL_HOST must advertise a reachable Pod IP</a:t>
+            </a:r>
+          </a:p>
+          <a:p>
+            <a:r>
+              <a:t>most production failures here are contract bugs, not model bugs</a:t>
             </a:r>
           </a:p>
         </p:txBody>
@@ -12196,15 +12018,8 @@
           </a:bodyPr>
           <a:lstStyle/>
           <a:p>
-            <a:pPr algn="r"/>
-            <a:r>
-              <a:rPr sz="1100" b="0">
-                <a:solidFill>
-                  <a:srgbClr val="64748B"/>
-                </a:solidFill>
-                <a:latin typeface="Aptos"/>
-              </a:rPr>
-              <a:t>This is a good concrete implementation slide.</a:t>
+            <a:r>
+              <a:t>If the controller does not enforce these contracts, users end up debugging infrastructure wiring as if it were model behavior.</a:t>
             </a:r>
           </a:p>
         </p:txBody>
@@ -12412,15 +12227,8 @@
           </a:bodyPr>
           <a:lstStyle/>
           <a:p>
-            <a:pPr algn="l"/>
-            <a:r>
-              <a:rPr sz="2400" b="1">
-                <a:solidFill>
-                  <a:srgbClr val="FFFFFF"/>
-                </a:solidFill>
-                <a:latin typeface="Aptos Display"/>
-              </a:rPr>
-              <a:t>Request flow, part 1</a:t>
+            <a:r>
+              <a:t>End-to-end request flow, part 1</a:t>
             </a:r>
           </a:p>
         </p:txBody>
@@ -12490,63 +12298,23 @@
           </a:bodyPr>
           <a:lstStyle/>
           <a:p>
-            <a:pPr>
-              <a:spcAft>
-                <a:spcPts val="800"/>
-              </a:spcAft>
-              <a:defRPr sz="2100">
-                <a:solidFill>
-                  <a:srgbClr val="334155"/>
-                </a:solidFill>
-              </a:defRPr>
-            </a:pPr>
-            <a:r>
-              <a:t>request enters gateway</a:t>
-            </a:r>
-          </a:p>
-          <a:p>
-            <a:pPr>
-              <a:spcAft>
-                <a:spcPts val="800"/>
-              </a:spcAft>
-              <a:defRPr sz="2100">
-                <a:solidFill>
-                  <a:srgbClr val="334155"/>
-                </a:solidFill>
-              </a:defRPr>
-            </a:pPr>
-            <a:r>
-              <a:t>gateway targets the InferencePool</a:t>
-            </a:r>
-          </a:p>
-          <a:p>
-            <a:pPr>
-              <a:spcAft>
-                <a:spcPts val="800"/>
-              </a:spcAft>
-              <a:defRPr sz="2100">
-                <a:solidFill>
-                  <a:srgbClr val="334155"/>
-                </a:solidFill>
-              </a:defRPr>
-            </a:pPr>
-            <a:r>
-              <a:t>llm-d Router EPP decides whether prefill work is needed</a:t>
-            </a:r>
-          </a:p>
-          <a:p>
-            <a:pPr>
-              <a:spcAft>
-                <a:spcPts val="800"/>
-              </a:spcAft>
-              <a:defRPr sz="2100">
-                <a:solidFill>
-                  <a:srgbClr val="334155"/>
-                </a:solidFill>
-              </a:defRPr>
-            </a:pPr>
-            <a:r>
-              <a:t>decode endpoint is selected</a:t>
+            <a:r>
+              <a:t>1. client sends an OpenAI-compatible request to the gateway</a:t>
+            </a:r>
+          </a:p>
+          <a:p>
+            <a:r>
+              <a:t>2. gateway / HTTPRoute forwards to the InferencePool</a:t>
+            </a:r>
+          </a:p>
+          <a:p>
+            <a:r>
+              <a:t>3. llm-d Router EPP picks a decode worker first</a:t>
+            </a:r>
+          </a:p>
+          <a:p>
+            <a:r>
+              <a:t>4. if disaggregation helps, EPP also selects a prefill worker</a:t>
             </a:r>
           </a:p>
         </p:txBody>
@@ -12590,15 +12358,8 @@
           </a:bodyPr>
           <a:lstStyle/>
           <a:p>
-            <a:pPr algn="r"/>
-            <a:r>
-              <a:rPr sz="1100" b="0">
-                <a:solidFill>
-                  <a:srgbClr val="64748B"/>
-                </a:solidFill>
-                <a:latin typeface="Aptos"/>
-              </a:rPr>
-              <a:t>Animate this if possible.</a:t>
+            <a:r>
+              <a:t>Simple control plane, non-trivial runtime path.</a:t>
             </a:r>
           </a:p>
         </p:txBody>
@@ -12806,15 +12567,8 @@
           </a:bodyPr>
           <a:lstStyle/>
           <a:p>
-            <a:pPr algn="l"/>
-            <a:r>
-              <a:rPr sz="2400" b="1">
-                <a:solidFill>
-                  <a:srgbClr val="FFFFFF"/>
-                </a:solidFill>
-                <a:latin typeface="Aptos Display"/>
-              </a:rPr>
-              <a:t>Request flow, part 2</a:t>
+            <a:r>
+              <a:t>End-to-end request flow, part 2</a:t>
             </a:r>
           </a:p>
         </p:txBody>
@@ -12884,63 +12638,23 @@
           </a:bodyPr>
           <a:lstStyle/>
           <a:p>
-            <a:pPr>
-              <a:spcAft>
-                <a:spcPts val="800"/>
-              </a:spcAft>
-              <a:defRPr sz="2100">
-                <a:solidFill>
-                  <a:srgbClr val="334155"/>
-                </a:solidFill>
-              </a:defRPr>
-            </a:pPr>
-            <a:r>
-              <a:t>decode-side sidecar coordinates prefill</a:t>
-            </a:r>
-          </a:p>
-          <a:p>
-            <a:pPr>
-              <a:spcAft>
-                <a:spcPts val="800"/>
-              </a:spcAft>
-              <a:defRPr sz="2100">
-                <a:solidFill>
-                  <a:srgbClr val="334155"/>
-                </a:solidFill>
-              </a:defRPr>
-            </a:pPr>
-            <a:r>
-              <a:t>prefill builds KV cache</a:t>
-            </a:r>
-          </a:p>
-          <a:p>
-            <a:pPr>
-              <a:spcAft>
-                <a:spcPts val="800"/>
-              </a:spcAft>
-              <a:defRPr sz="2100">
-                <a:solidFill>
-                  <a:srgbClr val="334155"/>
-                </a:solidFill>
-              </a:defRPr>
-            </a:pPr>
-            <a:r>
-              <a:t>KV moves pod-to-pod via NIXL</a:t>
-            </a:r>
-          </a:p>
-          <a:p>
-            <a:pPr>
-              <a:spcAft>
-                <a:spcPts val="800"/>
-              </a:spcAft>
-              <a:defRPr sz="2100">
-                <a:solidFill>
-                  <a:srgbClr val="334155"/>
-                </a:solidFill>
-              </a:defRPr>
-            </a:pPr>
-            <a:r>
-              <a:t>local decode streams output</a:t>
+            <a:r>
+              <a:t>5. request lands on the decode sidecar, which coordinates the P/D workflow</a:t>
+            </a:r>
+          </a:p>
+          <a:p>
+            <a:r>
+              <a:t>6. prefill vLLM processes the prompt and produces KV cache state</a:t>
+            </a:r>
+          </a:p>
+          <a:p>
+            <a:r>
+              <a:t>7. decode vLLM pulls KV cache via NIXL and continues token generation locally</a:t>
+            </a:r>
+          </a:p>
+          <a:p>
+            <a:r>
+              <a:t>8. the response returns through the same gateway path back to the client</a:t>
             </a:r>
           </a:p>
         </p:txBody>
@@ -12984,15 +12698,8 @@
           </a:bodyPr>
           <a:lstStyle/>
           <a:p>
-            <a:pPr algn="r"/>
-            <a:r>
-              <a:rPr sz="1100" b="0">
-                <a:solidFill>
-                  <a:srgbClr val="64748B"/>
-                </a:solidFill>
-                <a:latin typeface="Aptos"/>
-              </a:rPr>
-              <a:t>Keep it stepwise, not all at once.</a:t>
+            <a:r>
+              <a:t>The user sees one endpoint; under the hood the platform coordinates scheduling, KV movement, and decode execution across multiple pods.</a:t>
             </a:r>
           </a:p>
         </p:txBody>

</xml_diff>

<commit_message>
docs: refine benchmark and lessons deck copy
</commit_message>
<xml_diff>
--- a/llm/kubecon-na-2026-pd-disaggregation.pptx
+++ b/llm/kubecon-na-2026-pd-disaggregation.pptx
@@ -16715,14 +16715,7 @@
           <a:bodyPr rtlCol="0" anchor="ctr"/>
           <a:lstStyle/>
           <a:p>
-            <a:pPr algn="ctr"/>
-            <a:r>
-              <a:rPr sz="1400" b="1">
-                <a:solidFill>
-                  <a:srgbClr val="0F172A"/>
-                </a:solidFill>
-                <a:latin typeface="Aptos"/>
-              </a:rPr>
+            <a:r>
               <a:t>30</a:t>
             </a:r>
           </a:p>
@@ -16767,15 +16760,8 @@
           </a:bodyPr>
           <a:lstStyle/>
           <a:p>
-            <a:pPr algn="l"/>
-            <a:r>
-              <a:rPr sz="2400" b="1">
-                <a:solidFill>
-                  <a:srgbClr val="FFFFFF"/>
-                </a:solidFill>
-                <a:latin typeface="Aptos Display"/>
-              </a:rPr>
-              <a:t>Evaluation results: TTFT</a:t>
+            <a:r>
+              <a:t>Benchmark: P95 TTFT vs. Prompt Length</a:t>
             </a:r>
           </a:p>
         </p:txBody>
@@ -16845,33 +16831,29 @@
           </a:bodyPr>
           <a:lstStyle/>
           <a:p>
-            <a:pPr>
-              <a:spcAft>
-                <a:spcPts val="800"/>
-              </a:spcAft>
-              <a:defRPr sz="2100">
-                <a:solidFill>
-                  <a:srgbClr val="334155"/>
-                </a:solidFill>
-              </a:defRPr>
-            </a:pPr>
-            <a:r>
-              <a:t>colocated vs disaggregated</a:t>
-            </a:r>
-          </a:p>
-          <a:p>
-            <a:pPr>
-              <a:spcAft>
-                <a:spcPts val="800"/>
-              </a:spcAft>
-              <a:defRPr sz="2100">
-                <a:solidFill>
-                  <a:srgbClr val="334155"/>
-                </a:solidFill>
-              </a:defRPr>
-            </a:pPr>
-            <a:r>
-              <a:t>explain which workloads gain most</a:t>
+            <a:r>
+              <a:t>short prompts: colocated is competitive because routing and KV-transfer overhead is not yet amortized</a:t>
+            </a:r>
+          </a:p>
+          <a:p>
+            <a:r>
+              <a:t>break-even zone: around [X] input tokens / [Y]% cache miss rate, P/D starts to reduce TTFT consistently</a:t>
+            </a:r>
+          </a:p>
+          <a:p>
+            <a:r>
+              <a:t>long prompts: P/D separates prefill pressure from decode throughput, so TTFT grows more slowly</a:t>
+            </a:r>
+          </a:p>
+          <a:p/>
+          <a:p>
+            <a:r>
+              <a:t>primary metric: P95 TTFT</a:t>
+            </a:r>
+          </a:p>
+          <a:p>
+            <a:r>
+              <a:t>secondary metrics: throughput, TPOT / ITL, GPU utilization, GPUs needed for the same SLO</a:t>
             </a:r>
           </a:p>
         </p:txBody>
@@ -16915,15 +16897,8 @@
           </a:bodyPr>
           <a:lstStyle/>
           <a:p>
-            <a:pPr algn="r"/>
-            <a:r>
-              <a:rPr sz="1100" b="0">
-                <a:solidFill>
-                  <a:srgbClr val="64748B"/>
-                </a:solidFill>
-                <a:latin typeface="Aptos"/>
-              </a:rPr>
-              <a:t>One chart, one interpretation.</a:t>
+            <a:r>
+              <a:t>Break-even rule of thumb: below the break-even point, keep it simple; above it, P/D buys lower TTFT and better decode stability.</a:t>
             </a:r>
           </a:p>
         </p:txBody>
@@ -17079,14 +17054,7 @@
           <a:bodyPr rtlCol="0" anchor="ctr"/>
           <a:lstStyle/>
           <a:p>
-            <a:pPr algn="ctr"/>
-            <a:r>
-              <a:rPr sz="1400" b="1">
-                <a:solidFill>
-                  <a:srgbClr val="0F172A"/>
-                </a:solidFill>
-                <a:latin typeface="Aptos"/>
-              </a:rPr>
+            <a:r>
               <a:t>31</a:t>
             </a:r>
           </a:p>
@@ -17131,15 +17099,8 @@
           </a:bodyPr>
           <a:lstStyle/>
           <a:p>
-            <a:pPr algn="l"/>
-            <a:r>
-              <a:rPr sz="2400" b="1">
-                <a:solidFill>
-                  <a:srgbClr val="FFFFFF"/>
-                </a:solidFill>
-                <a:latin typeface="Aptos Display"/>
-              </a:rPr>
-              <a:t>Evaluation results: throughput</a:t>
+            <a:r>
+              <a:t>Benchmark: Throughput Under Mixed Load</a:t>
             </a:r>
           </a:p>
         </p:txBody>
@@ -17209,18 +17170,19 @@
           </a:bodyPr>
           <a:lstStyle/>
           <a:p>
-            <a:pPr>
-              <a:spcAft>
-                <a:spcPts val="800"/>
-              </a:spcAft>
-              <a:defRPr sz="2100">
-                <a:solidFill>
-                  <a:srgbClr val="334155"/>
-                </a:solidFill>
-              </a:defRPr>
-            </a:pPr>
-            <a:r>
-              <a:t>compare throughput under mixed load</a:t>
+            <a:r>
+              <a:t>compare colocated serving vs. P/D under the same model, the same total GPU budget, and the same request distribution</a:t>
+            </a:r>
+          </a:p>
+          <a:p/>
+          <a:p>
+            <a:r>
+              <a:t>look for whether decode throughput stays stable while prefill pressure rises</a:t>
+            </a:r>
+          </a:p>
+          <a:p>
+            <a:r>
+              <a:t>the goal is not just more tokens / second; it is better isolation between prompt bursts and sustained generation</a:t>
             </a:r>
           </a:p>
         </p:txBody>
@@ -17264,15 +17226,8 @@
           </a:bodyPr>
           <a:lstStyle/>
           <a:p>
-            <a:pPr algn="r"/>
-            <a:r>
-              <a:rPr sz="1100" b="0">
-                <a:solidFill>
-                  <a:srgbClr val="64748B"/>
-                </a:solidFill>
-                <a:latin typeface="Aptos"/>
-              </a:rPr>
-              <a:t>Keep narration high signal.</a:t>
+            <a:r>
+              <a:t>Use one chart, one interpretation: does separating prefill preserve throughput under mixed traffic?</a:t>
             </a:r>
           </a:p>
         </p:txBody>
@@ -17428,14 +17383,7 @@
           <a:bodyPr rtlCol="0" anchor="ctr"/>
           <a:lstStyle/>
           <a:p>
-            <a:pPr algn="ctr"/>
-            <a:r>
-              <a:rPr sz="1400" b="1">
-                <a:solidFill>
-                  <a:srgbClr val="0F172A"/>
-                </a:solidFill>
-                <a:latin typeface="Aptos"/>
-              </a:rPr>
+            <a:r>
               <a:t>32</a:t>
             </a:r>
           </a:p>
@@ -17480,15 +17428,8 @@
           </a:bodyPr>
           <a:lstStyle/>
           <a:p>
-            <a:pPr algn="l"/>
-            <a:r>
-              <a:rPr sz="2400" b="1">
-                <a:solidFill>
-                  <a:srgbClr val="FFFFFF"/>
-                </a:solidFill>
-                <a:latin typeface="Aptos Display"/>
-              </a:rPr>
-              <a:t>Evaluation results: utilization / efficiency</a:t>
+            <a:r>
+              <a:t>Benchmark: Utilization / Efficiency</a:t>
             </a:r>
           </a:p>
         </p:txBody>
@@ -17558,18 +17499,19 @@
           </a:bodyPr>
           <a:lstStyle/>
           <a:p>
-            <a:pPr>
-              <a:spcAft>
-                <a:spcPts val="800"/>
-              </a:spcAft>
-              <a:defRPr sz="2100">
-                <a:solidFill>
-                  <a:srgbClr val="334155"/>
-                </a:solidFill>
-              </a:defRPr>
-            </a:pPr>
             <a:r>
               <a:t>show GPU utilization or capacity efficiency under asymmetric traffic</a:t>
+            </a:r>
+          </a:p>
+          <a:p/>
+          <a:p>
+            <a:r>
+              <a:t>colocated: one pool absorbs both prefill spikes and decode steady-state load</a:t>
+            </a:r>
+          </a:p>
+          <a:p>
+            <a:r>
+              <a:t>P/D: each pool can be provisioned and scaled for its own bottleneck</a:t>
             </a:r>
           </a:p>
         </p:txBody>
@@ -17613,15 +17555,8 @@
           </a:bodyPr>
           <a:lstStyle/>
           <a:p>
-            <a:pPr algn="r"/>
-            <a:r>
-              <a:rPr sz="1100" b="0">
-                <a:solidFill>
-                  <a:srgbClr val="64748B"/>
-                </a:solidFill>
-                <a:latin typeface="Aptos"/>
-              </a:rPr>
-              <a:t>Reinforce the “why separate pools” message.</a:t>
+            <a:r>
+              <a:t>The efficiency question is simple: do separate pools recover useful GPU capacity without hurting latency?</a:t>
             </a:r>
           </a:p>
         </p:txBody>
@@ -17777,14 +17712,7 @@
           <a:bodyPr rtlCol="0" anchor="ctr"/>
           <a:lstStyle/>
           <a:p>
-            <a:pPr algn="ctr"/>
-            <a:r>
-              <a:rPr sz="1400" b="1">
-                <a:solidFill>
-                  <a:srgbClr val="0F172A"/>
-                </a:solidFill>
-                <a:latin typeface="Aptos"/>
-              </a:rPr>
+            <a:r>
               <a:t>33</a:t>
             </a:r>
           </a:p>
@@ -17829,15 +17757,8 @@
           </a:bodyPr>
           <a:lstStyle/>
           <a:p>
-            <a:pPr algn="l"/>
-            <a:r>
-              <a:rPr sz="2400" b="1">
-                <a:solidFill>
-                  <a:srgbClr val="FFFFFF"/>
-                </a:solidFill>
-                <a:latin typeface="Aptos Display"/>
-              </a:rPr>
-              <a:t>When to use P/D, and when not to</a:t>
+            <a:r>
+              <a:t>When to Use P/D — and When Not To</a:t>
             </a:r>
           </a:p>
         </p:txBody>
@@ -17881,14 +17802,7 @@
           </a:bodyPr>
           <a:lstStyle/>
           <a:p>
-            <a:pPr algn="ctr"/>
-            <a:r>
-              <a:rPr sz="1800" b="1">
-                <a:solidFill>
-                  <a:srgbClr val="0F172A"/>
-                </a:solidFill>
-                <a:latin typeface="Aptos"/>
-              </a:rPr>
+            <a:r>
               <a:t>KV transfer cost / fabric quality</a:t>
             </a:r>
           </a:p>
@@ -17933,15 +17847,8 @@
           </a:bodyPr>
           <a:lstStyle/>
           <a:p>
-            <a:pPr algn="ctr"/>
-            <a:r>
-              <a:rPr sz="1500" b="1">
-                <a:solidFill>
-                  <a:srgbClr val="0F172A"/>
-                </a:solidFill>
-                <a:latin typeface="Aptos"/>
-              </a:rPr>
-              <a:t>Prefill / decode difference</a:t>
+            <a:r>
+              <a:t>Prefill / Decode difference</a:t>
             </a:r>
           </a:p>
         </p:txBody>
@@ -18985,14 +18892,7 @@
           <a:bodyPr rtlCol="0" anchor="ctr"/>
           <a:lstStyle/>
           <a:p>
-            <a:pPr algn="ctr"/>
-            <a:r>
-              <a:rPr sz="1400" b="1">
-                <a:solidFill>
-                  <a:srgbClr val="0F172A"/>
-                </a:solidFill>
-                <a:latin typeface="Aptos"/>
-              </a:rPr>
+            <a:r>
               <a:t>34</a:t>
             </a:r>
           </a:p>
@@ -19037,15 +18937,8 @@
           </a:bodyPr>
           <a:lstStyle/>
           <a:p>
-            <a:pPr algn="l"/>
-            <a:r>
-              <a:rPr sz="2400" b="1">
-                <a:solidFill>
-                  <a:srgbClr val="FFFFFF"/>
-                </a:solidFill>
-                <a:latin typeface="Aptos Display"/>
-              </a:rPr>
-              <a:t>Production lessons</a:t>
+            <a:r>
+              <a:t>AKS Lessons Learned: The Hard Part Is the Contracts</a:t>
             </a:r>
           </a:p>
         </p:txBody>
@@ -19115,63 +19008,33 @@
           </a:bodyPr>
           <a:lstStyle/>
           <a:p>
-            <a:pPr>
-              <a:spcAft>
-                <a:spcPts val="800"/>
-              </a:spcAft>
-              <a:defRPr sz="2100">
-                <a:solidFill>
-                  <a:srgbClr val="334155"/>
-                </a:solidFill>
-              </a:defRPr>
-            </a:pPr>
-            <a:r>
-              <a:t>startup ordering matters</a:t>
-            </a:r>
-          </a:p>
-          <a:p>
-            <a:pPr>
-              <a:spcAft>
-                <a:spcPts val="800"/>
-              </a:spcAft>
-              <a:defRPr sz="2100">
-                <a:solidFill>
-                  <a:srgbClr val="334155"/>
-                </a:solidFill>
-              </a:defRPr>
-            </a:pPr>
-            <a:r>
-              <a:t>decode-side sidecar placement rules matter</a:t>
-            </a:r>
-          </a:p>
-          <a:p>
-            <a:pPr>
-              <a:spcAft>
-                <a:spcPts val="800"/>
-              </a:spcAft>
-              <a:defRPr sz="2100">
-                <a:solidFill>
-                  <a:srgbClr val="334155"/>
-                </a:solidFill>
-              </a:defRPr>
-            </a:pPr>
-            <a:r>
-              <a:t>service / targetPort / label contracts matter</a:t>
-            </a:r>
-          </a:p>
-          <a:p>
-            <a:pPr>
-              <a:spcAft>
-                <a:spcPts val="800"/>
-              </a:spcAft>
-              <a:defRPr sz="2100">
-                <a:solidFill>
-                  <a:srgbClr val="334155"/>
-                </a:solidFill>
-              </a:defRPr>
-            </a:pPr>
-            <a:r>
-              <a:t>KV transfer path and side-channel setup must be verified early</a:t>
+            <a:r>
+              <a:t>use a decode-only sidecar; putting it on prefill added instability and unnecessary memory pressure</a:t>
+            </a:r>
+          </a:p>
+          <a:p>
+            <a:r>
+              <a:t>treat ports as API contracts: InferencePool.targetPort, sidecar port, and vLLM ports must line up exactly</a:t>
+            </a:r>
+          </a:p>
+          <a:p>
+            <a:r>
+              <a:t>treat labels as routing inputs: inference-role labels directly affect worker selection</a:t>
+            </a:r>
+          </a:p>
+          <a:p>
+            <a:r>
+              <a:t>automate NIXL endpoint wiring: VLLM_NIXL_SIDE_CHANNEL_HOST must advertise a reachable Pod IP</a:t>
+            </a:r>
+          </a:p>
+          <a:p>
+            <a:r>
+              <a:t>observe the stack at three layers: EPP routing, vLLM metrics, and KV-transfer / KV-event signals</a:t>
+            </a:r>
+          </a:p>
+          <a:p>
+            <a:r>
+              <a:t>invest in CPU-only E2E and mocked GPU-node flows before scaling out expensive GPU tests</a:t>
             </a:r>
           </a:p>
         </p:txBody>
@@ -19215,15 +19078,8 @@
           </a:bodyPr>
           <a:lstStyle/>
           <a:p>
-            <a:pPr algn="r"/>
-            <a:r>
-              <a:rPr sz="1100" b="0">
-                <a:solidFill>
-                  <a:srgbClr val="64748B"/>
-                </a:solidFill>
-                <a:latin typeface="Aptos"/>
-              </a:rPr>
-              <a:t>Give practical advice, not just architecture.</a:t>
+            <a:r>
+              <a:t>P/D is easy to explain on a whiteboard. Making the contracts reliable in a real AKS deployment is the real engineering work.</a:t>
             </a:r>
           </a:p>
         </p:txBody>
@@ -19379,14 +19235,7 @@
           <a:bodyPr rtlCol="0" anchor="ctr"/>
           <a:lstStyle/>
           <a:p>
-            <a:pPr algn="ctr"/>
-            <a:r>
-              <a:rPr sz="1400" b="1">
-                <a:solidFill>
-                  <a:srgbClr val="0F172A"/>
-                </a:solidFill>
-                <a:latin typeface="Aptos"/>
-              </a:rPr>
+            <a:r>
               <a:t>35</a:t>
             </a:r>
           </a:p>
@@ -19431,15 +19280,8 @@
           </a:bodyPr>
           <a:lstStyle/>
           <a:p>
-            <a:pPr algn="l"/>
-            <a:r>
-              <a:rPr sz="2400" b="1">
-                <a:solidFill>
-                  <a:srgbClr val="FFFFFF"/>
-                </a:solidFill>
-                <a:latin typeface="Aptos Display"/>
-              </a:rPr>
-              <a:t>What’s next for KAITO + llm-d</a:t>
+            <a:r>
+              <a:t>What’s Next for KAITO + llm-d</a:t>
             </a:r>
           </a:p>
         </p:txBody>
@@ -19509,61 +19351,21 @@
           </a:bodyPr>
           <a:lstStyle/>
           <a:p>
-            <a:pPr>
-              <a:spcAft>
-                <a:spcPts val="800"/>
-              </a:spcAft>
-              <a:defRPr sz="2100">
-                <a:solidFill>
-                  <a:srgbClr val="334155"/>
-                </a:solidFill>
-              </a:defRPr>
-            </a:pPr>
             <a:r>
               <a:t>near term: precise prefix-cache routing based on KV events</a:t>
             </a:r>
           </a:p>
           <a:p>
-            <a:pPr>
-              <a:spcAft>
-                <a:spcPts val="800"/>
-              </a:spcAft>
-              <a:defRPr sz="2100">
-                <a:solidFill>
-                  <a:srgbClr val="334155"/>
-                </a:solidFill>
-              </a:defRPr>
-            </a:pPr>
             <a:r>
               <a:t>near term: tiered prefix cache across HBM, CPU RAM, and optional filesystem tiers</a:t>
             </a:r>
           </a:p>
           <a:p>
-            <a:pPr>
-              <a:spcAft>
-                <a:spcPts val="800"/>
-              </a:spcAft>
-              <a:defRPr sz="2100">
-                <a:solidFill>
-                  <a:srgbClr val="334155"/>
-                </a:solidFill>
-              </a:defRPr>
-            </a:pPr>
             <a:r>
               <a:t>next topology: E/P/D and speculative decoding</a:t>
             </a:r>
           </a:p>
           <a:p>
-            <a:pPr>
-              <a:spcAft>
-                <a:spcPts val="800"/>
-              </a:spcAft>
-              <a:defRPr sz="2100">
-                <a:solidFill>
-                  <a:srgbClr val="334155"/>
-                </a:solidFill>
-              </a:defRPr>
-            </a:pPr>
             <a:r>
               <a:t>larger-scale systems: Wide Expert Parallelism and richer cross-node transport optimization</a:t>
             </a:r>
@@ -19609,14 +19411,7 @@
           </a:bodyPr>
           <a:lstStyle/>
           <a:p>
-            <a:pPr algn="r"/>
-            <a:r>
-              <a:rPr sz="1100" b="0">
-                <a:solidFill>
-                  <a:srgbClr val="64748B"/>
-                </a:solidFill>
-                <a:latin typeface="Aptos"/>
-              </a:rPr>
+            <a:r>
               <a:t>End with a concrete roadmap, not a vague future-work cloud.</a:t>
             </a:r>
           </a:p>

</xml_diff>

<commit_message>
docs: tighten front-half deck copy
</commit_message>
<xml_diff>
--- a/llm/kubecon-na-2026-pd-disaggregation.pptx
+++ b/llm/kubecon-na-2026-pd-disaggregation.pptx
@@ -4359,7 +4359,7 @@
           <a:lstStyle/>
           <a:p>
             <a:r>
-              <a:t>Why put KAITO on top of llm-d?</a:t>
+              <a:t>Why KAITO on Top of llm-d</a:t>
             </a:r>
           </a:p>
         </p:txBody>
@@ -4430,33 +4430,33 @@
           <a:lstStyle/>
           <a:p>
             <a:r>
-              <a:t>Manual llm-d stack: strong routing primitives, but too much wiring around sidecars, labels, ports, configmaps, and lifecycle ownership</a:t>
-            </a:r>
-          </a:p>
-          <a:p>
-            <a:r>
-              <a:t>Dynamo: full-stack disaggregated inference, but heavier runtime coupling and less natural fit for Kubernetes operators</a:t>
-            </a:r>
-          </a:p>
-          <a:p>
-            <a:r>
-              <a:t>KAITO + llm-d: declarative Kubernetes abstraction on top of proven routing primitives</a:t>
+              <a:t>Manual llm-d: powerful primitives, but lots of wiring</a:t>
+            </a:r>
+          </a:p>
+          <a:p>
+            <a:r>
+              <a:t>Dynamo: strong full stack, but heavier coupling</a:t>
+            </a:r>
+          </a:p>
+          <a:p>
+            <a:r>
+              <a:t>KAITO + llm-d: operator-friendly Kubernetes path</a:t>
             </a:r>
           </a:p>
           <a:p/>
           <a:p>
             <a:r>
-              <a:t>llm-d solves routing and scheduling</a:t>
-            </a:r>
-          </a:p>
-          <a:p>
-            <a:r>
-              <a:t>KAITO solves lifecycle and platform automation</a:t>
-            </a:r>
-          </a:p>
-          <a:p>
-            <a:r>
-              <a:t>Together they turn distributed inference into an operator workflow</a:t>
+              <a:t>llm-d handles routing</a:t>
+            </a:r>
+          </a:p>
+          <a:p>
+            <a:r>
+              <a:t>KAITO handles lifecycle</a:t>
+            </a:r>
+          </a:p>
+          <a:p>
+            <a:r>
+              <a:t>Together they make P/D usable</a:t>
             </a:r>
           </a:p>
         </p:txBody>
@@ -4501,7 +4501,7 @@
           <a:lstStyle/>
           <a:p>
             <a:r>
-              <a:t>The key question is not just who can route requests — it is who owns all the surrounding contracts.</a:t>
+              <a:t>The real question is who owns the contracts around the routing stack.</a:t>
             </a:r>
           </a:p>
         </p:txBody>
@@ -4709,15 +4709,8 @@
           </a:bodyPr>
           <a:lstStyle/>
           <a:p>
-            <a:pPr algn="l"/>
-            <a:r>
-              <a:rPr sz="2400" b="1">
-                <a:solidFill>
-                  <a:srgbClr val="FFFFFF"/>
-                </a:solidFill>
-                <a:latin typeface="Aptos Display"/>
-              </a:rPr>
-              <a:t>What KAITO is</a:t>
+            <a:r>
+              <a:t>What KAITO Adds</a:t>
             </a:r>
           </a:p>
         </p:txBody>
@@ -4763,15 +4756,8 @@
           </a:bodyPr>
           <a:lstStyle/>
           <a:p>
-            <a:pPr algn="ctr"/>
-            <a:r>
-              <a:rPr sz="2200" b="1">
-                <a:solidFill>
-                  <a:srgbClr val="0F172A"/>
-                </a:solidFill>
-                <a:latin typeface="Aptos"/>
-              </a:rPr>
-              <a:t>KAITO is the Kubernetes control-plane layer that takes you from model serving to distributed inference.</a:t>
+            <a:r>
+              <a:t>KAITO is the control-plane layer that carries you from model serving to distributed inference.</a:t>
             </a:r>
           </a:p>
         </p:txBody>
@@ -4882,18 +4868,26 @@
           </a:bodyPr>
           <a:lstStyle/>
           <a:p>
-            <a:pPr algn="l"/>
-            <a:r>
-              <a:rPr sz="1800" b="0">
-                <a:solidFill>
-                  <a:srgbClr val="334155"/>
-                </a:solidFill>
-                <a:latin typeface="Aptos"/>
-              </a:rPr>
-              <a:t>• Start with Workspace for one model workload
-• Add InferenceSet for replicas and autoscaling
-• Add InferencePool for inference-aware routing
-• Use MultiRoleInference for richer distributed topology</a:t>
+            <a:r>
+              <a:t>• Workspace starts the model workload</a:t>
+            </a:r>
+          </a:p>
+          <a:p/>
+          <a:p>
+            <a:r>
+              <a:t>• InferenceSet adds replicas and scaling</a:t>
+            </a:r>
+          </a:p>
+          <a:p/>
+          <a:p>
+            <a:r>
+              <a:t>• InferencePool adds inference-aware routing</a:t>
+            </a:r>
+          </a:p>
+          <a:p/>
+          <a:p>
+            <a:r>
+              <a:t>• MultiRoleInference adds richer topology</a:t>
             </a:r>
           </a:p>
         </p:txBody>
@@ -5004,15 +4998,8 @@
           </a:bodyPr>
           <a:lstStyle/>
           <a:p>
-            <a:pPr algn="ctr"/>
-            <a:r>
-              <a:rPr sz="1300" b="0">
-                <a:solidFill>
-                  <a:srgbClr val="64748B"/>
-                </a:solidFill>
-                <a:latin typeface="Aptos"/>
-              </a:rPr>
-              <a:t>Docs architecture view: KAITO packages serving, routing, and operations into one Kubernetes-native platform model.</a:t>
+            <a:r>
+              <a:t>One object model, from simple serving to distributed inference.</a:t>
             </a:r>
           </a:p>
         </p:txBody>
@@ -5220,15 +5207,8 @@
           </a:bodyPr>
           <a:lstStyle/>
           <a:p>
-            <a:pPr algn="l"/>
-            <a:r>
-              <a:rPr sz="2400" b="1">
-                <a:solidFill>
-                  <a:srgbClr val="FFFFFF"/>
-                </a:solidFill>
-                <a:latin typeface="Aptos Display"/>
-              </a:rPr>
-              <a:t>KAITO’s object model in one view</a:t>
+            <a:r>
+              <a:t>KAITO’s Object Model</a:t>
             </a:r>
           </a:p>
         </p:txBody>
@@ -5274,15 +5254,8 @@
           </a:bodyPr>
           <a:lstStyle/>
           <a:p>
-            <a:pPr algn="ctr"/>
-            <a:r>
-              <a:rPr sz="2100" b="1">
-                <a:solidFill>
-                  <a:srgbClr val="0F172A"/>
-                </a:solidFill>
-                <a:latin typeface="Aptos"/>
-              </a:rPr>
-              <a:t>KAITO grows in layers: serving -&gt; scaling -&gt; routing -&gt; distributed topology</a:t>
+            <a:r>
+              <a:t>One platform model: serving → scaling → routing → topology</a:t>
             </a:r>
           </a:p>
         </p:txBody>
@@ -5326,14 +5299,7 @@
           </a:bodyPr>
           <a:lstStyle/>
           <a:p>
-            <a:pPr algn="ctr"/>
-            <a:r>
-              <a:rPr sz="1200" b="1">
-                <a:solidFill>
-                  <a:srgbClr val="2563EB"/>
-                </a:solidFill>
-                <a:latin typeface="Aptos"/>
-              </a:rPr>
+            <a:r>
               <a:t>Serving</a:t>
             </a:r>
           </a:p>
@@ -5434,14 +5400,7 @@
           </a:bodyPr>
           <a:lstStyle/>
           <a:p>
-            <a:pPr algn="l"/>
-            <a:r>
-              <a:rPr sz="1900" b="1">
-                <a:solidFill>
-                  <a:srgbClr val="0F172A"/>
-                </a:solidFill>
-                <a:latin typeface="Aptos"/>
-              </a:rPr>
+            <a:r>
               <a:t>Workspace</a:t>
             </a:r>
           </a:p>
@@ -5469,48 +5428,18 @@
           </a:bodyPr>
           <a:lstStyle/>
           <a:p>
-            <a:pPr>
-              <a:spcAft>
-                <a:spcPts val="500"/>
-              </a:spcAft>
-              <a:defRPr sz="1400">
-                <a:solidFill>
-                  <a:srgbClr val="334155"/>
-                </a:solidFill>
-              </a:defRPr>
-            </a:pPr>
-            <a:r>
-              <a:t>Run a model workload</a:t>
-            </a:r>
-          </a:p>
-          <a:p>
-            <a:pPr>
-              <a:spcAft>
-                <a:spcPts val="500"/>
-              </a:spcAft>
-              <a:defRPr sz="1400">
-                <a:solidFill>
-                  <a:srgbClr val="334155"/>
-                </a:solidFill>
-              </a:defRPr>
-            </a:pPr>
-            <a:r>
-              <a:t>Serving or tuning</a:t>
-            </a:r>
-          </a:p>
-          <a:p>
-            <a:pPr>
-              <a:spcAft>
-                <a:spcPts val="500"/>
-              </a:spcAft>
-              <a:defRPr sz="1400">
-                <a:solidFill>
-                  <a:srgbClr val="334155"/>
-                </a:solidFill>
-              </a:defRPr>
-            </a:pPr>
-            <a:r>
-              <a:t>The basic workload entrypoint</a:t>
+            <a:r>
+              <a:t>Run one model workload</a:t>
+            </a:r>
+          </a:p>
+          <a:p>
+            <a:r>
+              <a:t>Serve or tune</a:t>
+            </a:r>
+          </a:p>
+          <a:p>
+            <a:r>
+              <a:t>Start here</a:t>
             </a:r>
           </a:p>
         </p:txBody>
@@ -5597,14 +5526,7 @@
           </a:bodyPr>
           <a:lstStyle/>
           <a:p>
-            <a:pPr algn="ctr"/>
-            <a:r>
-              <a:rPr sz="1200" b="1">
-                <a:solidFill>
-                  <a:srgbClr val="16A34A"/>
-                </a:solidFill>
-                <a:latin typeface="Aptos"/>
-              </a:rPr>
+            <a:r>
               <a:t>Scaling</a:t>
             </a:r>
           </a:p>
@@ -5705,14 +5627,7 @@
           </a:bodyPr>
           <a:lstStyle/>
           <a:p>
-            <a:pPr algn="l"/>
-            <a:r>
-              <a:rPr sz="1900" b="1">
-                <a:solidFill>
-                  <a:srgbClr val="0F172A"/>
-                </a:solidFill>
-                <a:latin typeface="Aptos"/>
-              </a:rPr>
+            <a:r>
               <a:t>InferenceSet</a:t>
             </a:r>
           </a:p>
@@ -5740,48 +5655,18 @@
           </a:bodyPr>
           <a:lstStyle/>
           <a:p>
-            <a:pPr>
-              <a:spcAft>
-                <a:spcPts val="500"/>
-              </a:spcAft>
-              <a:defRPr sz="1400">
-                <a:solidFill>
-                  <a:srgbClr val="334155"/>
-                </a:solidFill>
-              </a:defRPr>
-            </a:pPr>
-            <a:r>
-              <a:t>Replica management</a:t>
-            </a:r>
-          </a:p>
-          <a:p>
-            <a:pPr>
-              <a:spcAft>
-                <a:spcPts val="500"/>
-              </a:spcAft>
-              <a:defRPr sz="1400">
-                <a:solidFill>
-                  <a:srgbClr val="334155"/>
-                </a:solidFill>
-              </a:defRPr>
-            </a:pPr>
-            <a:r>
-              <a:t>Autoscaling boundary</a:t>
-            </a:r>
-          </a:p>
-          <a:p>
-            <a:pPr>
-              <a:spcAft>
-                <a:spcPts val="500"/>
-              </a:spcAft>
-              <a:defRPr sz="1400">
-                <a:solidFill>
-                  <a:srgbClr val="334155"/>
-                </a:solidFill>
-              </a:defRPr>
-            </a:pPr>
-            <a:r>
-              <a:t>Scale-out for inference</a:t>
+            <a:r>
+              <a:t>Replicas</a:t>
+            </a:r>
+          </a:p>
+          <a:p>
+            <a:r>
+              <a:t>Autoscaling</a:t>
+            </a:r>
+          </a:p>
+          <a:p>
+            <a:r>
+              <a:t>Inference scale-out</a:t>
             </a:r>
           </a:p>
         </p:txBody>
@@ -5868,14 +5753,7 @@
           </a:bodyPr>
           <a:lstStyle/>
           <a:p>
-            <a:pPr algn="ctr"/>
-            <a:r>
-              <a:rPr sz="1200" b="1">
-                <a:solidFill>
-                  <a:srgbClr val="EA580C"/>
-                </a:solidFill>
-                <a:latin typeface="Aptos"/>
-              </a:rPr>
+            <a:r>
               <a:t>Routing</a:t>
             </a:r>
           </a:p>
@@ -5976,14 +5854,7 @@
           </a:bodyPr>
           <a:lstStyle/>
           <a:p>
-            <a:pPr algn="l"/>
-            <a:r>
-              <a:rPr sz="1900" b="1">
-                <a:solidFill>
-                  <a:srgbClr val="0F172A"/>
-                </a:solidFill>
-                <a:latin typeface="Aptos"/>
-              </a:rPr>
+            <a:r>
               <a:t>InferencePool</a:t>
             </a:r>
           </a:p>
@@ -6011,48 +5882,18 @@
           </a:bodyPr>
           <a:lstStyle/>
           <a:p>
-            <a:pPr>
-              <a:spcAft>
-                <a:spcPts val="500"/>
-              </a:spcAft>
-              <a:defRPr sz="1400">
-                <a:solidFill>
-                  <a:srgbClr val="334155"/>
-                </a:solidFill>
-              </a:defRPr>
-            </a:pPr>
             <a:r>
               <a:t>Inference-aware routing</a:t>
             </a:r>
           </a:p>
           <a:p>
-            <a:pPr>
-              <a:spcAft>
-                <a:spcPts val="500"/>
-              </a:spcAft>
-              <a:defRPr sz="1400">
-                <a:solidFill>
-                  <a:srgbClr val="334155"/>
-                </a:solidFill>
-              </a:defRPr>
-            </a:pPr>
-            <a:r>
-              <a:t>Gateway-facing backend set</a:t>
-            </a:r>
-          </a:p>
-          <a:p>
-            <a:pPr>
-              <a:spcAft>
-                <a:spcPts val="500"/>
-              </a:spcAft>
-              <a:defRPr sz="1400">
-                <a:solidFill>
-                  <a:srgbClr val="334155"/>
-                </a:solidFill>
-              </a:defRPr>
-            </a:pPr>
-            <a:r>
-              <a:t>Connects serving to GWIE</a:t>
+            <a:r>
+              <a:t>Gateway-facing pool</a:t>
+            </a:r>
+          </a:p>
+          <a:p>
+            <a:r>
+              <a:t>Connects to GWIE</a:t>
             </a:r>
           </a:p>
         </p:txBody>
@@ -6139,14 +5980,7 @@
           </a:bodyPr>
           <a:lstStyle/>
           <a:p>
-            <a:pPr algn="ctr"/>
-            <a:r>
-              <a:rPr sz="1200" b="1">
-                <a:solidFill>
-                  <a:srgbClr val="6D28D9"/>
-                </a:solidFill>
-                <a:latin typeface="Aptos"/>
-              </a:rPr>
+            <a:r>
               <a:t>Topology</a:t>
             </a:r>
           </a:p>
@@ -6247,14 +6081,7 @@
           </a:bodyPr>
           <a:lstStyle/>
           <a:p>
-            <a:pPr algn="l"/>
-            <a:r>
-              <a:rPr sz="1900" b="1">
-                <a:solidFill>
-                  <a:srgbClr val="0F172A"/>
-                </a:solidFill>
-                <a:latin typeface="Aptos"/>
-              </a:rPr>
+            <a:r>
               <a:t>MultiRoleInference</a:t>
             </a:r>
           </a:p>
@@ -6282,48 +6109,18 @@
           </a:bodyPr>
           <a:lstStyle/>
           <a:p>
-            <a:pPr>
-              <a:spcAft>
-                <a:spcPts val="500"/>
-              </a:spcAft>
-              <a:defRPr sz="1400">
-                <a:solidFill>
-                  <a:srgbClr val="334155"/>
-                </a:solidFill>
-              </a:defRPr>
-            </a:pPr>
             <a:r>
               <a:t>One logical service</a:t>
             </a:r>
           </a:p>
           <a:p>
-            <a:pPr>
-              <a:spcAft>
-                <a:spcPts val="500"/>
-              </a:spcAft>
-              <a:defRPr sz="1400">
-                <a:solidFill>
-                  <a:srgbClr val="334155"/>
-                </a:solidFill>
-              </a:defRPr>
-            </a:pPr>
             <a:r>
               <a:t>Role-specific backends</a:t>
             </a:r>
           </a:p>
           <a:p>
-            <a:pPr>
-              <a:spcAft>
-                <a:spcPts val="500"/>
-              </a:spcAft>
-              <a:defRPr sz="1400">
-                <a:solidFill>
-                  <a:srgbClr val="334155"/>
-                </a:solidFill>
-              </a:defRPr>
-            </a:pPr>
-            <a:r>
-              <a:t>P/D and richer topology</a:t>
+            <a:r>
+              <a:t>P/D and beyond</a:t>
             </a:r>
           </a:p>
         </p:txBody>
@@ -6515,15 +6312,8 @@
           </a:bodyPr>
           <a:lstStyle/>
           <a:p>
-            <a:pPr algn="ctr"/>
-            <a:r>
-              <a:rPr sz="1400" b="0">
-                <a:solidFill>
-                  <a:srgbClr val="64748B"/>
-                </a:solidFill>
-                <a:latin typeface="Aptos"/>
-              </a:rPr>
-              <a:t>The object model stays consistent even as the inference topology becomes more advanced.</a:t>
+            <a:r>
+              <a:t>The model stays consistent even as the topology gets more complex.</a:t>
             </a:r>
           </a:p>
         </p:txBody>
@@ -6731,15 +6521,8 @@
           </a:bodyPr>
           <a:lstStyle/>
           <a:p>
-            <a:pPr algn="l"/>
-            <a:r>
-              <a:rPr sz="2400" b="1">
-                <a:solidFill>
-                  <a:srgbClr val="FFFFFF"/>
-                </a:solidFill>
-                <a:latin typeface="Aptos Display"/>
-              </a:rPr>
-              <a:t>KAITO starts with serving: `Workspace`</a:t>
+            <a:r>
+              <a:t>Workspace: The Serving Entry Point</a:t>
             </a:r>
           </a:p>
         </p:txBody>
@@ -6809,48 +6592,18 @@
           </a:bodyPr>
           <a:lstStyle/>
           <a:p>
-            <a:pPr>
-              <a:spcAft>
-                <a:spcPts val="800"/>
-              </a:spcAft>
-              <a:defRPr sz="2100">
-                <a:solidFill>
-                  <a:srgbClr val="334155"/>
-                </a:solidFill>
-              </a:defRPr>
-            </a:pPr>
-            <a:r>
-              <a:t>the basic workload entrypoint for model serving and tuning</a:t>
-            </a:r>
-          </a:p>
-          <a:p>
-            <a:pPr>
-              <a:spcAft>
-                <a:spcPts val="800"/>
-              </a:spcAft>
-              <a:defRPr sz="2100">
-                <a:solidFill>
-                  <a:srgbClr val="334155"/>
-                </a:solidFill>
-              </a:defRPr>
-            </a:pPr>
-            <a:r>
-              <a:t>good mental model: one model workload, one Kubernetes object</a:t>
-            </a:r>
-          </a:p>
-          <a:p>
-            <a:pPr>
-              <a:spcAft>
-                <a:spcPts val="800"/>
-              </a:spcAft>
-              <a:defRPr sz="2100">
-                <a:solidFill>
-                  <a:srgbClr val="334155"/>
-                </a:solidFill>
-              </a:defRPr>
-            </a:pPr>
-            <a:r>
-              <a:t>the place where KAITO begins before scaling and routing enter the picture</a:t>
+            <a:r>
+              <a:t>one model workload</a:t>
+            </a:r>
+          </a:p>
+          <a:p>
+            <a:r>
+              <a:t>one Kubernetes object</a:t>
+            </a:r>
+          </a:p>
+          <a:p>
+            <a:r>
+              <a:t>the clean starting point before scaling and routing show up</a:t>
             </a:r>
           </a:p>
         </p:txBody>
@@ -6894,15 +6647,8 @@
           </a:bodyPr>
           <a:lstStyle/>
           <a:p>
-            <a:pPr algn="r"/>
-            <a:r>
-              <a:rPr sz="1100" b="0">
-                <a:solidFill>
-                  <a:srgbClr val="64748B"/>
-                </a:solidFill>
-                <a:latin typeface="Aptos"/>
-              </a:rPr>
-              <a:t>Keep this simple.</a:t>
+            <a:r>
+              <a:t>Keep this slide simple and foundational.</a:t>
             </a:r>
           </a:p>
         </p:txBody>
@@ -7110,15 +6856,8 @@
           </a:bodyPr>
           <a:lstStyle/>
           <a:p>
-            <a:pPr algn="l"/>
-            <a:r>
-              <a:rPr sz="2400" b="1">
-                <a:solidFill>
-                  <a:srgbClr val="FFFFFF"/>
-                </a:solidFill>
-                <a:latin typeface="Aptos Display"/>
-              </a:rPr>
-              <a:t>KAITO scales serving: `InferenceSet` + `InferencePool`</a:t>
+            <a:r>
+              <a:t>InferenceSet + InferencePool: Scaling and Routing</a:t>
             </a:r>
           </a:p>
         </p:txBody>
@@ -7188,48 +6927,18 @@
           </a:bodyPr>
           <a:lstStyle/>
           <a:p>
-            <a:pPr>
-              <a:spcAft>
-                <a:spcPts val="800"/>
-              </a:spcAft>
-              <a:defRPr sz="2100">
-                <a:solidFill>
-                  <a:srgbClr val="334155"/>
-                </a:solidFill>
-              </a:defRPr>
-            </a:pPr>
             <a:r>
               <a:t>InferenceSet adds replicas and autoscaling</a:t>
             </a:r>
           </a:p>
           <a:p>
-            <a:pPr>
-              <a:spcAft>
-                <a:spcPts val="800"/>
-              </a:spcAft>
-              <a:defRPr sz="2100">
-                <a:solidFill>
-                  <a:srgbClr val="334155"/>
-                </a:solidFill>
-              </a:defRPr>
-            </a:pPr>
             <a:r>
               <a:t>InferencePool adds inference-aware routing through GWIE</a:t>
             </a:r>
           </a:p>
           <a:p>
-            <a:pPr>
-              <a:spcAft>
-                <a:spcPts val="800"/>
-              </a:spcAft>
-              <a:defRPr sz="2100">
-                <a:solidFill>
-                  <a:srgbClr val="334155"/>
-                </a:solidFill>
-              </a:defRPr>
-            </a:pPr>
-            <a:r>
-              <a:t>together, they move KAITO from “run a model” to “operate a serving system”</a:t>
+            <a:r>
+              <a:t>Together they turn serving into an operating model</a:t>
             </a:r>
           </a:p>
         </p:txBody>
@@ -7273,15 +6982,8 @@
           </a:bodyPr>
           <a:lstStyle/>
           <a:p>
-            <a:pPr algn="r"/>
-            <a:r>
-              <a:rPr sz="1100" b="0">
-                <a:solidFill>
-                  <a:srgbClr val="64748B"/>
-                </a:solidFill>
-                <a:latin typeface="Aptos"/>
-              </a:rPr>
-              <a:t>This is where KAITO starts to look like a serving platform, not just a deployment helper.</a:t>
+            <a:r>
+              <a:t>This is where KAITO starts to look like a serving platform.</a:t>
             </a:r>
           </a:p>
         </p:txBody>
@@ -7489,15 +7191,8 @@
           </a:bodyPr>
           <a:lstStyle/>
           <a:p>
-            <a:pPr algn="l"/>
-            <a:r>
-              <a:rPr sz="2400" b="1">
-                <a:solidFill>
-                  <a:srgbClr val="FFFFFF"/>
-                </a:solidFill>
-                <a:latin typeface="Aptos Display"/>
-              </a:rPr>
-              <a:t>KAITO extends naturally to distributed inference</a:t>
+            <a:r>
+              <a:t>MultiRoleInference: The Step to Distributed Topology</a:t>
             </a:r>
           </a:p>
         </p:txBody>
@@ -7567,48 +7262,18 @@
           </a:bodyPr>
           <a:lstStyle/>
           <a:p>
-            <a:pPr>
-              <a:spcAft>
-                <a:spcPts val="800"/>
-              </a:spcAft>
-              <a:defRPr sz="2100">
-                <a:solidFill>
-                  <a:srgbClr val="334155"/>
-                </a:solidFill>
-              </a:defRPr>
-            </a:pPr>
             <a:r>
               <a:t>MultiRoleInference is the object for richer topologies</a:t>
             </a:r>
           </a:p>
           <a:p>
-            <a:pPr>
-              <a:spcAft>
-                <a:spcPts val="800"/>
-              </a:spcAft>
-              <a:defRPr sz="2100">
-                <a:solidFill>
-                  <a:srgbClr val="334155"/>
-                </a:solidFill>
-              </a:defRPr>
-            </a:pPr>
-            <a:r>
-              <a:t>one logical service can expand into prefill and decode backends</a:t>
-            </a:r>
-          </a:p>
-          <a:p>
-            <a:pPr>
-              <a:spcAft>
-                <a:spcPts val="800"/>
-              </a:spcAft>
-              <a:defRPr sz="2100">
-                <a:solidFill>
-                  <a:srgbClr val="334155"/>
-                </a:solidFill>
-              </a:defRPr>
-            </a:pPr>
-            <a:r>
-              <a:t>the same Kubernetes object model continues even when the topology becomes distributed</a:t>
+            <a:r>
+              <a:t>one logical service expands into prefill and decode backends</a:t>
+            </a:r>
+          </a:p>
+          <a:p>
+            <a:r>
+              <a:t>the same object model continues into distributed inference</a:t>
             </a:r>
           </a:p>
         </p:txBody>
@@ -7652,15 +7317,8 @@
           </a:bodyPr>
           <a:lstStyle/>
           <a:p>
-            <a:pPr algn="r"/>
-            <a:r>
-              <a:rPr sz="1100" b="0">
-                <a:solidFill>
-                  <a:srgbClr val="64748B"/>
-                </a:solidFill>
-                <a:latin typeface="Aptos"/>
-              </a:rPr>
-              <a:t>This is the transition slide from “what KAITO is” to “why KAITO matters for P/D.”</a:t>
+            <a:r>
+              <a:t>This is the bridge from serving to P/D.</a:t>
             </a:r>
           </a:p>
         </p:txBody>
@@ -7868,15 +7526,8 @@
           </a:bodyPr>
           <a:lstStyle/>
           <a:p>
-            <a:pPr algn="l"/>
-            <a:r>
-              <a:rPr sz="2400" b="1">
-                <a:solidFill>
-                  <a:srgbClr val="FFFFFF"/>
-                </a:solidFill>
-                <a:latin typeface="Aptos Display"/>
-              </a:rPr>
-              <a:t>Why KAITO matters here</a:t>
+            <a:r>
+              <a:t>Why This Matters for Operators</a:t>
             </a:r>
           </a:p>
         </p:txBody>
@@ -7946,63 +7597,23 @@
           </a:bodyPr>
           <a:lstStyle/>
           <a:p>
-            <a:pPr>
-              <a:spcAft>
-                <a:spcPts val="800"/>
-              </a:spcAft>
-              <a:defRPr sz="2100">
-                <a:solidFill>
-                  <a:srgbClr val="334155"/>
-                </a:solidFill>
-              </a:defRPr>
-            </a:pPr>
-            <a:r>
-              <a:t>turns topology into declarative APIs</a:t>
-            </a:r>
-          </a:p>
-          <a:p>
-            <a:pPr>
-              <a:spcAft>
-                <a:spcPts val="800"/>
-              </a:spcAft>
-              <a:defRPr sz="2100">
-                <a:solidFill>
-                  <a:srgbClr val="334155"/>
-                </a:solidFill>
-              </a:defRPr>
-            </a:pPr>
-            <a:r>
-              <a:t>gives users a continuous path from Workspace to InferenceSet to InferencePool to MultiRoleInference</a:t>
-            </a:r>
-          </a:p>
-          <a:p>
-            <a:pPr>
-              <a:spcAft>
-                <a:spcPts val="800"/>
-              </a:spcAft>
-              <a:defRPr sz="2100">
-                <a:solidFill>
-                  <a:srgbClr val="334155"/>
-                </a:solidFill>
-              </a:defRPr>
-            </a:pPr>
-            <a:r>
-              <a:t>synthesizes lower-level objects automatically</a:t>
-            </a:r>
-          </a:p>
-          <a:p>
-            <a:pPr>
-              <a:spcAft>
-                <a:spcPts val="800"/>
-              </a:spcAft>
-              <a:defRPr sz="2100">
-                <a:solidFill>
-                  <a:srgbClr val="334155"/>
-                </a:solidFill>
-              </a:defRPr>
-            </a:pPr>
-            <a:r>
-              <a:t>keeps the same platform model even as the topology becomes distributed</a:t>
+            <a:r>
+              <a:t>topology becomes declarative</a:t>
+            </a:r>
+          </a:p>
+          <a:p>
+            <a:r>
+              <a:t>users move smoothly from Workspace to MRI</a:t>
+            </a:r>
+          </a:p>
+          <a:p>
+            <a:r>
+              <a:t>lower-level resources are synthesized automatically</a:t>
+            </a:r>
+          </a:p>
+          <a:p>
+            <a:r>
+              <a:t>the platform model stays stable as topology grows</a:t>
             </a:r>
           </a:p>
         </p:txBody>
@@ -8046,15 +7657,8 @@
           </a:bodyPr>
           <a:lstStyle/>
           <a:p>
-            <a:pPr algn="r"/>
-            <a:r>
-              <a:rPr sz="1100" b="0">
-                <a:solidFill>
-                  <a:srgbClr val="64748B"/>
-                </a:solidFill>
-                <a:latin typeface="Aptos"/>
-              </a:rPr>
-              <a:t>Explain the operator value.</a:t>
+            <a:r>
+              <a:t>The operator value is less wiring and fewer hidden contracts.</a:t>
             </a:r>
           </a:p>
         </p:txBody>
@@ -8262,15 +7866,8 @@
           </a:bodyPr>
           <a:lstStyle/>
           <a:p>
-            <a:pPr algn="l"/>
-            <a:r>
-              <a:rPr sz="2400" b="1">
-                <a:solidFill>
-                  <a:srgbClr val="FFFFFF"/>
-                </a:solidFill>
-                <a:latin typeface="Aptos Display"/>
-              </a:rPr>
-              <a:t>What the llm-d Router brings to the stack</a:t>
+            <a:r>
+              <a:t>What llm-d Router Adds</a:t>
             </a:r>
           </a:p>
         </p:txBody>
@@ -8340,63 +7937,23 @@
           </a:bodyPr>
           <a:lstStyle/>
           <a:p>
-            <a:pPr>
-              <a:spcAft>
-                <a:spcPts val="800"/>
-              </a:spcAft>
-              <a:defRPr sz="2100">
-                <a:solidFill>
-                  <a:srgbClr val="334155"/>
-                </a:solidFill>
-              </a:defRPr>
-            </a:pPr>
-            <a:r>
-              <a:t>EPP for Gateway API Inference Extension</a:t>
-            </a:r>
-          </a:p>
-          <a:p>
-            <a:pPr>
-              <a:spcAft>
-                <a:spcPts val="800"/>
-              </a:spcAft>
-              <a:defRPr sz="2100">
-                <a:solidFill>
-                  <a:srgbClr val="334155"/>
-                </a:solidFill>
-              </a:defRPr>
-            </a:pPr>
+            <a:r>
+              <a:t>EPP for GWIE</a:t>
+            </a:r>
+          </a:p>
+          <a:p>
             <a:r>
               <a:t>model-aware and role-aware endpoint selection</a:t>
             </a:r>
           </a:p>
           <a:p>
-            <a:pPr>
-              <a:spcAft>
-                <a:spcPts val="800"/>
-              </a:spcAft>
-              <a:defRPr sz="2100">
-                <a:solidFill>
-                  <a:srgbClr val="334155"/>
-                </a:solidFill>
-              </a:defRPr>
-            </a:pPr>
-            <a:r>
-              <a:t>KV-cache-aware and P/D-aware plugin chain</a:t>
-            </a:r>
-          </a:p>
-          <a:p>
-            <a:pPr>
-              <a:spcAft>
-                <a:spcPts val="800"/>
-              </a:spcAft>
-              <a:defRPr sz="2100">
-                <a:solidFill>
-                  <a:srgbClr val="334155"/>
-                </a:solidFill>
-              </a:defRPr>
-            </a:pPr>
-            <a:r>
-              <a:t>future advanced scheduling surface</a:t>
+            <a:r>
+              <a:t>KV-aware and P/D-aware plugin chain</a:t>
+            </a:r>
+          </a:p>
+          <a:p>
+            <a:r>
+              <a:t>room for more advanced scheduling later</a:t>
             </a:r>
           </a:p>
         </p:txBody>
@@ -8440,15 +7997,8 @@
           </a:bodyPr>
           <a:lstStyle/>
           <a:p>
-            <a:pPr algn="r"/>
-            <a:r>
-              <a:rPr sz="1100" b="0">
-                <a:solidFill>
-                  <a:srgbClr val="64748B"/>
-                </a:solidFill>
-                <a:latin typeface="Aptos"/>
-              </a:rPr>
-              <a:t>Explain that Gateway API Inference Extension gives the abstraction pattern, and the llm-d Router provides the advanced EPP implementation KAITO uses.</a:t>
+            <a:r>
+              <a:t>GWIE gives the pattern; llm-d Router provides the advanced implementation KAITO uses.</a:t>
             </a:r>
           </a:p>
         </p:txBody>
@@ -8656,15 +8206,8 @@
           </a:bodyPr>
           <a:lstStyle/>
           <a:p>
-            <a:pPr algn="l"/>
-            <a:r>
-              <a:rPr sz="2400" b="1">
-                <a:solidFill>
-                  <a:srgbClr val="FFFFFF"/>
-                </a:solidFill>
-                <a:latin typeface="Aptos Display"/>
-              </a:rPr>
-              <a:t>KAITO + llm-d Router + GWIE: division of labor</a:t>
+            <a:r>
+              <a:t>Division of Labor: KAITO, GWIE, and llm-d Router</a:t>
             </a:r>
           </a:p>
         </p:txBody>
@@ -8764,14 +8307,7 @@
           </a:bodyPr>
           <a:lstStyle/>
           <a:p>
-            <a:pPr algn="l"/>
-            <a:r>
-              <a:rPr sz="1900" b="1">
-                <a:solidFill>
-                  <a:srgbClr val="0F172A"/>
-                </a:solidFill>
-                <a:latin typeface="Aptos"/>
-              </a:rPr>
+            <a:r>
               <a:t>KAITO</a:t>
             </a:r>
           </a:p>
@@ -8799,46 +8335,16 @@
           </a:bodyPr>
           <a:lstStyle/>
           <a:p>
-            <a:pPr>
-              <a:spcAft>
-                <a:spcPts val="500"/>
-              </a:spcAft>
-              <a:defRPr sz="1400">
-                <a:solidFill>
-                  <a:srgbClr val="334155"/>
-                </a:solidFill>
-              </a:defRPr>
-            </a:pPr>
-            <a:r>
-              <a:t>declarative abstraction</a:t>
-            </a:r>
-          </a:p>
-          <a:p>
-            <a:pPr>
-              <a:spcAft>
-                <a:spcPts val="500"/>
-              </a:spcAft>
-              <a:defRPr sz="1400">
-                <a:solidFill>
-                  <a:srgbClr val="334155"/>
-                </a:solidFill>
-              </a:defRPr>
-            </a:pPr>
+            <a:r>
+              <a:t>abstraction</a:t>
+            </a:r>
+          </a:p>
+          <a:p>
             <a:r>
               <a:t>orchestration</a:t>
             </a:r>
           </a:p>
           <a:p>
-            <a:pPr>
-              <a:spcAft>
-                <a:spcPts val="500"/>
-              </a:spcAft>
-              <a:defRPr sz="1400">
-                <a:solidFill>
-                  <a:srgbClr val="334155"/>
-                </a:solidFill>
-              </a:defRPr>
-            </a:pPr>
             <a:r>
               <a:t>object model</a:t>
             </a:r>
@@ -8940,14 +8446,7 @@
           </a:bodyPr>
           <a:lstStyle/>
           <a:p>
-            <a:pPr algn="l"/>
-            <a:r>
-              <a:rPr sz="1900" b="1">
-                <a:solidFill>
-                  <a:srgbClr val="0F172A"/>
-                </a:solidFill>
-                <a:latin typeface="Aptos"/>
-              </a:rPr>
+            <a:r>
               <a:t>GWIE</a:t>
             </a:r>
           </a:p>
@@ -8975,48 +8474,18 @@
           </a:bodyPr>
           <a:lstStyle/>
           <a:p>
-            <a:pPr>
-              <a:spcAft>
-                <a:spcPts val="500"/>
-              </a:spcAft>
-              <a:defRPr sz="1400">
-                <a:solidFill>
-                  <a:srgbClr val="334155"/>
-                </a:solidFill>
-              </a:defRPr>
-            </a:pPr>
-            <a:r>
-              <a:t>inference routing contract</a:t>
-            </a:r>
-          </a:p>
-          <a:p>
-            <a:pPr>
-              <a:spcAft>
-                <a:spcPts val="500"/>
-              </a:spcAft>
-              <a:defRPr sz="1400">
-                <a:solidFill>
-                  <a:srgbClr val="334155"/>
-                </a:solidFill>
-              </a:defRPr>
-            </a:pPr>
+            <a:r>
+              <a:t>routing contract</a:t>
+            </a:r>
+          </a:p>
+          <a:p>
             <a:r>
               <a:t>InferencePool model</a:t>
             </a:r>
           </a:p>
           <a:p>
-            <a:pPr>
-              <a:spcAft>
-                <a:spcPts val="500"/>
-              </a:spcAft>
-              <a:defRPr sz="1400">
-                <a:solidFill>
-                  <a:srgbClr val="334155"/>
-                </a:solidFill>
-              </a:defRPr>
-            </a:pPr>
-            <a:r>
-              <a:t>Kubernetes-native routing pattern</a:t>
+            <a:r>
+              <a:t>Kubernetes-native pattern</a:t>
             </a:r>
           </a:p>
         </p:txBody>
@@ -9116,14 +8585,7 @@
           </a:bodyPr>
           <a:lstStyle/>
           <a:p>
-            <a:pPr algn="l"/>
-            <a:r>
-              <a:rPr sz="1900" b="1">
-                <a:solidFill>
-                  <a:srgbClr val="0F172A"/>
-                </a:solidFill>
-                <a:latin typeface="Aptos"/>
-              </a:rPr>
+            <a:r>
               <a:t>llm-d Router</a:t>
             </a:r>
           </a:p>
@@ -9151,48 +8613,18 @@
           </a:bodyPr>
           <a:lstStyle/>
           <a:p>
-            <a:pPr>
-              <a:spcAft>
-                <a:spcPts val="500"/>
-              </a:spcAft>
-              <a:defRPr sz="1400">
-                <a:solidFill>
-                  <a:srgbClr val="334155"/>
-                </a:solidFill>
-              </a:defRPr>
-            </a:pPr>
             <a:r>
               <a:t>EPP</a:t>
             </a:r>
           </a:p>
           <a:p>
-            <a:pPr>
-              <a:spcAft>
-                <a:spcPts val="500"/>
-              </a:spcAft>
-              <a:defRPr sz="1400">
-                <a:solidFill>
-                  <a:srgbClr val="334155"/>
-                </a:solidFill>
-              </a:defRPr>
-            </a:pPr>
             <a:r>
               <a:t>routing + scheduling</a:t>
             </a:r>
           </a:p>
           <a:p>
-            <a:pPr>
-              <a:spcAft>
-                <a:spcPts val="500"/>
-              </a:spcAft>
-              <a:defRPr sz="1400">
-                <a:solidFill>
-                  <a:srgbClr val="334155"/>
-                </a:solidFill>
-              </a:defRPr>
-            </a:pPr>
-            <a:r>
-              <a:t>KV/P-D-aware plugins</a:t>
+            <a:r>
+              <a:t>KV / P-D-aware plugins</a:t>
             </a:r>
           </a:p>
         </p:txBody>
@@ -9470,15 +8902,8 @@
           </a:bodyPr>
           <a:lstStyle/>
           <a:p>
-            <a:pPr algn="l"/>
-            <a:r>
-              <a:rPr sz="2400" b="1">
-                <a:solidFill>
-                  <a:srgbClr val="FFFFFF"/>
-                </a:solidFill>
-                <a:latin typeface="Aptos Display"/>
-              </a:rPr>
-              <a:t>End-to-end architecture diagram</a:t>
+            <a:r>
+              <a:t>End-to-End Architecture</a:t>
             </a:r>
           </a:p>
         </p:txBody>
@@ -9565,14 +8990,7 @@
           </a:bodyPr>
           <a:lstStyle/>
           <a:p>
-            <a:pPr algn="ctr"/>
-            <a:r>
-              <a:rPr sz="1200" b="1">
-                <a:solidFill>
-                  <a:srgbClr val="2563EB"/>
-                </a:solidFill>
-                <a:latin typeface="Aptos"/>
-              </a:rPr>
+            <a:r>
               <a:t>request path</a:t>
             </a:r>
           </a:p>
@@ -9617,14 +9035,7 @@
           </a:bodyPr>
           <a:lstStyle/>
           <a:p>
-            <a:pPr algn="ctr"/>
-            <a:r>
-              <a:rPr sz="1200" b="1">
-                <a:solidFill>
-                  <a:srgbClr val="6D28D9"/>
-                </a:solidFill>
-                <a:latin typeface="Aptos"/>
-              </a:rPr>
+            <a:r>
               <a:t>KV path</a:t>
             </a:r>
           </a:p>
@@ -9673,14 +9084,7 @@
           </a:bodyPr>
           <a:lstStyle/>
           <a:p>
-            <a:pPr algn="ctr"/>
-            <a:r>
-              <a:rPr sz="1800" b="1">
-                <a:solidFill>
-                  <a:srgbClr val="0F172A"/>
-                </a:solidFill>
-                <a:latin typeface="Aptos"/>
-              </a:rPr>
+            <a:r>
               <a:t>Client</a:t>
             </a:r>
           </a:p>
@@ -9729,14 +9133,7 @@
           </a:bodyPr>
           <a:lstStyle/>
           <a:p>
-            <a:pPr algn="ctr"/>
-            <a:r>
-              <a:rPr sz="1800" b="1">
-                <a:solidFill>
-                  <a:srgbClr val="0F172A"/>
-                </a:solidFill>
-                <a:latin typeface="Aptos"/>
-              </a:rPr>
+            <a:r>
               <a:t>Gateway</a:t>
             </a:r>
           </a:p>
@@ -9785,16 +9182,13 @@
           </a:bodyPr>
           <a:lstStyle/>
           <a:p>
-            <a:pPr algn="ctr"/>
-            <a:r>
-              <a:rPr sz="1800" b="1">
-                <a:solidFill>
-                  <a:srgbClr val="0F172A"/>
-                </a:solidFill>
-                <a:latin typeface="Aptos"/>
-              </a:rPr>
-              <a:t>InferencePool
-+ llm-d EPP</a:t>
+            <a:r>
+              <a:t>InferencePool</a:t>
+            </a:r>
+          </a:p>
+          <a:p>
+            <a:r>
+              <a:t>+ llm-d EPP</a:t>
             </a:r>
           </a:p>
         </p:txBody>
@@ -9842,16 +9236,13 @@
           </a:bodyPr>
           <a:lstStyle/>
           <a:p>
-            <a:pPr algn="ctr"/>
-            <a:r>
-              <a:rPr sz="1800" b="1">
-                <a:solidFill>
-                  <a:srgbClr val="0F172A"/>
-                </a:solidFill>
-                <a:latin typeface="Aptos"/>
-              </a:rPr>
-              <a:t>Prefill
-child InferenceSet</a:t>
+            <a:r>
+              <a:t>Prefill</a:t>
+            </a:r>
+          </a:p>
+          <a:p>
+            <a:r>
+              <a:t>child InferenceSet</a:t>
             </a:r>
           </a:p>
         </p:txBody>
@@ -9899,16 +9290,13 @@
           </a:bodyPr>
           <a:lstStyle/>
           <a:p>
-            <a:pPr algn="ctr"/>
-            <a:r>
-              <a:rPr sz="1800" b="1">
-                <a:solidFill>
-                  <a:srgbClr val="0F172A"/>
-                </a:solidFill>
-                <a:latin typeface="Aptos"/>
-              </a:rPr>
-              <a:t>Decode
-child InferenceSet</a:t>
+            <a:r>
+              <a:t>Decode</a:t>
+            </a:r>
+          </a:p>
+          <a:p>
+            <a:r>
+              <a:t>child InferenceSet</a:t>
             </a:r>
           </a:p>
         </p:txBody>
@@ -9956,16 +9344,13 @@
           </a:bodyPr>
           <a:lstStyle/>
           <a:p>
-            <a:pPr algn="ctr"/>
-            <a:r>
-              <a:rPr sz="1700" b="1">
-                <a:solidFill>
-                  <a:srgbClr val="0F172A"/>
-                </a:solidFill>
-                <a:latin typeface="Aptos"/>
-              </a:rPr>
-              <a:t>Routing sidecar
-+ local vLLM</a:t>
+            <a:r>
+              <a:t>Routing sidecar</a:t>
+            </a:r>
+          </a:p>
+          <a:p>
+            <a:r>
+              <a:t>+ local vLLM</a:t>
             </a:r>
           </a:p>
         </p:txBody>
@@ -10219,15 +9604,8 @@
           </a:bodyPr>
           <a:lstStyle/>
           <a:p>
-            <a:pPr algn="ctr"/>
-            <a:r>
-              <a:rPr sz="1500" b="1">
-                <a:solidFill>
-                  <a:srgbClr val="334155"/>
-                </a:solidFill>
-                <a:latin typeface="Aptos"/>
-              </a:rPr>
-              <a:t>Gateway routes requests; KV data moves directly between prefill and decode workers.</a:t>
+            <a:r>
+              <a:t>Gateway moves requests; KV moves directly between workers.</a:t>
             </a:r>
           </a:p>
         </p:txBody>
@@ -10314,15 +9692,8 @@
           </a:bodyPr>
           <a:lstStyle/>
           <a:p>
-            <a:pPr algn="ctr"/>
-            <a:r>
-              <a:rPr sz="1300" b="1">
-                <a:solidFill>
-                  <a:srgbClr val="64748B"/>
-                </a:solidFill>
-                <a:latin typeface="Aptos"/>
-              </a:rPr>
-              <a:t>Data-plane split: request path and KV-transfer path are different</a:t>
+            <a:r>
+              <a:t>Request path and KV-transfer path are different by design.</a:t>
             </a:r>
           </a:p>
         </p:txBody>
@@ -11188,7 +10559,7 @@
           <a:lstStyle/>
           <a:p>
             <a:r>
-              <a:t>MultiRoleInference: one CRD for P/D disaggregation</a:t>
+              <a:t>MultiRoleInference: One CRD for P/D</a:t>
             </a:r>
           </a:p>
         </p:txBody>
@@ -11264,22 +10635,22 @@
           </a:p>
           <a:p>
             <a:r>
-              <a:t>shared model intent and one service topology</a:t>
-            </a:r>
-          </a:p>
-          <a:p>
-            <a:r>
-              <a:t>prefill and decode declared as separate roles</a:t>
-            </a:r>
-          </a:p>
-          <a:p>
-            <a:r>
-              <a:t>role-specific replica counts and runtime behavior</a:t>
-            </a:r>
-          </a:p>
-          <a:p>
-            <a:r>
-              <a:t>one user-facing object for the whole P/D topology</a:t>
+              <a:t>shared model intent</a:t>
+            </a:r>
+          </a:p>
+          <a:p>
+            <a:r>
+              <a:t>prefill and decode as separate roles</a:t>
+            </a:r>
+          </a:p>
+          <a:p>
+            <a:r>
+              <a:t>role-specific scaling and runtime behavior</a:t>
+            </a:r>
+          </a:p>
+          <a:p>
+            <a:r>
+              <a:t>one user-facing object for the full topology</a:t>
             </a:r>
           </a:p>
         </p:txBody>
@@ -11324,7 +10695,7 @@
           <a:lstStyle/>
           <a:p>
             <a:r>
-              <a:t>The CRD is the product surface; the controller should own the rest of the plumbing.</a:t>
+              <a:t>The CRD is the product surface; the controller owns the plumbing.</a:t>
             </a:r>
           </a:p>
         </p:txBody>
@@ -11533,7 +10904,7 @@
           <a:lstStyle/>
           <a:p>
             <a:r>
-              <a:t>What one MultiRoleInference CR generates</a:t>
+              <a:t>What MultiRoleInference Generates</a:t>
             </a:r>
           </a:p>
         </p:txBody>
@@ -11619,7 +10990,7 @@
           </a:p>
           <a:p>
             <a:r>
-              <a:t>llm-d Router EPP deployment and plugin chain</a:t>
+              <a:t>llm-d Router EPP and plugin chain</a:t>
             </a:r>
           </a:p>
           <a:p>
@@ -11629,7 +11000,7 @@
           </a:p>
           <a:p>
             <a:r>
-              <a:t>per-role autoscaling hooks via child InferenceSets</a:t>
+              <a:t>per-role scaling hooks</a:t>
             </a:r>
           </a:p>
         </p:txBody>
@@ -11674,7 +11045,7 @@
           <a:lstStyle/>
           <a:p>
             <a:r>
-              <a:t>KAITO does not replace llm-d; it generates and keeps the llm-d-facing resources consistent.</a:t>
+              <a:t>KAITO keeps the llm-d-facing resources consistent for the user.</a:t>
             </a:r>
           </a:p>
         </p:txBody>
@@ -11883,7 +11254,7 @@
           <a:lstStyle/>
           <a:p>
             <a:r>
-              <a:t>The runtime contracts that make P/D actually work</a:t>
+              <a:t>The Contracts That Make P/D Work</a:t>
             </a:r>
           </a:p>
         </p:txBody>
@@ -11954,27 +11325,27 @@
           <a:lstStyle/>
           <a:p>
             <a:r>
-              <a:t>decode-only sidecar is the stable pattern; prefill stays lightweight</a:t>
-            </a:r>
-          </a:p>
-          <a:p>
-            <a:r>
-              <a:t>InferencePool.targetPort must align with the routing path across the pool</a:t>
-            </a:r>
-          </a:p>
-          <a:p>
-            <a:r>
-              <a:t>role labels are functional metadata for worker selection</a:t>
-            </a:r>
-          </a:p>
-          <a:p>
-            <a:r>
-              <a:t>VLLM_NIXL_SIDE_CHANNEL_HOST must advertise a reachable Pod IP</a:t>
-            </a:r>
-          </a:p>
-          <a:p>
-            <a:r>
-              <a:t>most production failures here are contract bugs, not model bugs</a:t>
+              <a:t>decode-only sidecar is the stable pattern</a:t>
+            </a:r>
+          </a:p>
+          <a:p>
+            <a:r>
+              <a:t>targetPort must line up with the routing path</a:t>
+            </a:r>
+          </a:p>
+          <a:p>
+            <a:r>
+              <a:t>role labels drive worker selection</a:t>
+            </a:r>
+          </a:p>
+          <a:p>
+            <a:r>
+              <a:t>NIXL side-channel must advertise a reachable Pod IP</a:t>
+            </a:r>
+          </a:p>
+          <a:p>
+            <a:r>
+              <a:t>most failures here are contract bugs</a:t>
             </a:r>
           </a:p>
         </p:txBody>
@@ -12019,7 +11390,7 @@
           <a:lstStyle/>
           <a:p>
             <a:r>
-              <a:t>If the controller does not enforce these contracts, users end up debugging infrastructure wiring as if it were model behavior.</a:t>
+              <a:t>If the controller does not enforce these rules, users debug plumbing instead of behavior.</a:t>
             </a:r>
           </a:p>
         </p:txBody>
@@ -12228,7 +11599,7 @@
           <a:lstStyle/>
           <a:p>
             <a:r>
-              <a:t>End-to-end request flow, part 1</a:t>
+              <a:t>Request Flow (1)</a:t>
             </a:r>
           </a:p>
         </p:txBody>
@@ -12299,22 +11670,22 @@
           <a:lstStyle/>
           <a:p>
             <a:r>
-              <a:t>1. client sends an OpenAI-compatible request to the gateway</a:t>
-            </a:r>
-          </a:p>
-          <a:p>
-            <a:r>
-              <a:t>2. gateway / HTTPRoute forwards to the InferencePool</a:t>
-            </a:r>
-          </a:p>
-          <a:p>
-            <a:r>
-              <a:t>3. llm-d Router EPP picks a decode worker first</a:t>
-            </a:r>
-          </a:p>
-          <a:p>
-            <a:r>
-              <a:t>4. if disaggregation helps, EPP also selects a prefill worker</a:t>
+              <a:t>1. request enters the gateway</a:t>
+            </a:r>
+          </a:p>
+          <a:p>
+            <a:r>
+              <a:t>2. gateway forwards to the InferencePool</a:t>
+            </a:r>
+          </a:p>
+          <a:p>
+            <a:r>
+              <a:t>3. llm-d Router EPP picks decode first</a:t>
+            </a:r>
+          </a:p>
+          <a:p>
+            <a:r>
+              <a:t>4. if needed, EPP also selects prefill</a:t>
             </a:r>
           </a:p>
         </p:txBody>
@@ -12359,7 +11730,7 @@
           <a:lstStyle/>
           <a:p>
             <a:r>
-              <a:t>Simple control plane, non-trivial runtime path.</a:t>
+              <a:t>Simple control plane; non-trivial runtime path.</a:t>
             </a:r>
           </a:p>
         </p:txBody>
@@ -12568,7 +11939,7 @@
           <a:lstStyle/>
           <a:p>
             <a:r>
-              <a:t>End-to-end request flow, part 2</a:t>
+              <a:t>Request Flow (2)</a:t>
             </a:r>
           </a:p>
         </p:txBody>
@@ -12639,22 +12010,22 @@
           <a:lstStyle/>
           <a:p>
             <a:r>
-              <a:t>5. request lands on the decode sidecar, which coordinates the P/D workflow</a:t>
-            </a:r>
-          </a:p>
-          <a:p>
-            <a:r>
-              <a:t>6. prefill vLLM processes the prompt and produces KV cache state</a:t>
-            </a:r>
-          </a:p>
-          <a:p>
-            <a:r>
-              <a:t>7. decode vLLM pulls KV cache via NIXL and continues token generation locally</a:t>
-            </a:r>
-          </a:p>
-          <a:p>
-            <a:r>
-              <a:t>8. the response returns through the same gateway path back to the client</a:t>
+              <a:t>5. decode sidecar coordinates the P/D workflow</a:t>
+            </a:r>
+          </a:p>
+          <a:p>
+            <a:r>
+              <a:t>6. prefill builds KV cache state</a:t>
+            </a:r>
+          </a:p>
+          <a:p>
+            <a:r>
+              <a:t>7. decode pulls KV via NIXL and generates output</a:t>
+            </a:r>
+          </a:p>
+          <a:p>
+            <a:r>
+              <a:t>8. response returns through the gateway</a:t>
             </a:r>
           </a:p>
         </p:txBody>
@@ -12699,7 +12070,7 @@
           <a:lstStyle/>
           <a:p>
             <a:r>
-              <a:t>The user sees one endpoint; under the hood the platform coordinates scheduling, KV movement, and decode execution across multiple pods.</a:t>
+              <a:t>One endpoint for the user; multiple coordinated pods underneath.</a:t>
             </a:r>
           </a:p>
         </p:txBody>
@@ -16832,28 +16203,17 @@
           <a:lstStyle/>
           <a:p>
             <a:r>
-              <a:t>short prompts: colocated is competitive because routing and KV-transfer overhead is not yet amortized</a:t>
-            </a:r>
-          </a:p>
-          <a:p>
-            <a:r>
-              <a:t>break-even zone: around [X] input tokens / [Y]% cache miss rate, P/D starts to reduce TTFT consistently</a:t>
-            </a:r>
-          </a:p>
-          <a:p>
-            <a:r>
-              <a:t>long prompts: P/D separates prefill pressure from decode throughput, so TTFT grows more slowly</a:t>
-            </a:r>
-          </a:p>
-          <a:p/>
-          <a:p>
-            <a:r>
-              <a:t>primary metric: P95 TTFT</a:t>
-            </a:r>
-          </a:p>
-          <a:p>
-            <a:r>
-              <a:t>secondary metrics: throughput, TPOT / ITL, GPU utilization, GPUs needed for the same SLO</a:t>
+              <a:t>short prompts: colocated is often enough</a:t>
+            </a:r>
+          </a:p>
+          <a:p>
+            <a:r>
+              <a:t>break-even: around [X] tokens / [Y]% miss, P/D pulls ahead</a:t>
+            </a:r>
+          </a:p>
+          <a:p>
+            <a:r>
+              <a:t>long prompts: P/D keeps TTFT flatter</a:t>
             </a:r>
           </a:p>
         </p:txBody>
@@ -16898,7 +16258,7 @@
           <a:lstStyle/>
           <a:p>
             <a:r>
-              <a:t>Break-even rule of thumb: below the break-even point, keep it simple; above it, P/D buys lower TTFT and better decode stability.</a:t>
+              <a:t>Above the break-even point, P/D buys lower TTFT and steadier decode.</a:t>
             </a:r>
           </a:p>
         </p:txBody>
@@ -17171,18 +16531,17 @@
           <a:lstStyle/>
           <a:p>
             <a:r>
-              <a:t>compare colocated serving vs. P/D under the same model, the same total GPU budget, and the same request distribution</a:t>
-            </a:r>
-          </a:p>
-          <a:p/>
-          <a:p>
-            <a:r>
-              <a:t>look for whether decode throughput stays stable while prefill pressure rises</a:t>
-            </a:r>
-          </a:p>
-          <a:p>
-            <a:r>
-              <a:t>the goal is not just more tokens / second; it is better isolation between prompt bursts and sustained generation</a:t>
+              <a:t>same model, same GPU budget, same traffic mix</a:t>
+            </a:r>
+          </a:p>
+          <a:p>
+            <a:r>
+              <a:t>question: does decode throughput stay stable as prefill pressure rises?</a:t>
+            </a:r>
+          </a:p>
+          <a:p>
+            <a:r>
+              <a:t>P/D should isolate prompt bursts from sustained generation</a:t>
             </a:r>
           </a:p>
         </p:txBody>
@@ -17227,7 +16586,7 @@
           <a:lstStyle/>
           <a:p>
             <a:r>
-              <a:t>Use one chart, one interpretation: does separating prefill preserve throughput under mixed traffic?</a:t>
+              <a:t>If throughput stays flatter under mixed load, the split is paying off.</a:t>
             </a:r>
           </a:p>
         </p:txBody>
@@ -17500,18 +16859,17 @@
           <a:lstStyle/>
           <a:p>
             <a:r>
-              <a:t>show GPU utilization or capacity efficiency under asymmetric traffic</a:t>
-            </a:r>
-          </a:p>
-          <a:p/>
-          <a:p>
-            <a:r>
-              <a:t>colocated: one pool absorbs both prefill spikes and decode steady-state load</a:t>
-            </a:r>
-          </a:p>
-          <a:p>
-            <a:r>
-              <a:t>P/D: each pool can be provisioned and scaled for its own bottleneck</a:t>
+              <a:t>colocated: one pool absorbs both burst and steady-state load</a:t>
+            </a:r>
+          </a:p>
+          <a:p>
+            <a:r>
+              <a:t>P/D: each pool can be sized for its own bottleneck</a:t>
+            </a:r>
+          </a:p>
+          <a:p>
+            <a:r>
+              <a:t>look for better utilization without latency regression</a:t>
             </a:r>
           </a:p>
         </p:txBody>
@@ -17556,7 +16914,7 @@
           <a:lstStyle/>
           <a:p>
             <a:r>
-              <a:t>The efficiency question is simple: do separate pools recover useful GPU capacity without hurting latency?</a:t>
+              <a:t>The win is useful capacity, not just a prettier utilization chart.</a:t>
             </a:r>
           </a:p>
         </p:txBody>

</xml_diff>

<commit_message>
slides: focus P/D autoscaling on public concepts and policies
Signed-off-by: andyzhangx <xiazhang@microsoft.com>
</commit_message>
<xml_diff>
--- a/llm/kubecon-na-2026-pd-disaggregation.pptx
+++ b/llm/kubecon-na-2026-pd-disaggregation.pptx
@@ -1818,7 +1818,7 @@
           <a:lstStyle/>
           <a:p>
             <a:r>
-              <a:t>The proposed phase-1 MRI integration uses vllm:num_requests_waiting for prefill and vllm:num_requests_running for decode. Both are native vLLM gauges, but their presence and role-scoped aggregation must be verified on the deployed runtime. KV utilization and latency are observational initially; derived signals belong to phase 2. This is not a claim that MRI role autoscaling is implemented today.</a:t>
+              <a:t>Use native vllm:num_requests_waiting for prefill and vllm:num_requests_running for decode as primary role-specific signals. Verify availability and aggregation on the actual runtime. KV utilization and latency add diagnostic context; a derived signal becomes a control input only after its semantics and safety policy are validated. This is a control-pattern recommendation, not a claim about an automatically available MRI feature.</a:t>
             </a:r>
           </a:p>
           <a:p/>
@@ -2005,7 +2005,7 @@
           <a:lstStyle/>
           <a:p>
             <a:r>
-              <a:t>Conceptual two-loop model for the proposed MRI integration. One ScaledObject per target InferenceSet is the KEDA boundary. Phase 1 uses the native vLLM waiting and running request gauges. Do not install conflicting HPAs for one target. Metric aggregation, freshness, model warm-up and safe scale-down require verification. The following five implementation slides expand the annotation-first design.</a:t>
+              <a:t>Conceptual two-loop design. A KEDA deployment can use one ScaledObject per target InferenceSet. Native vLLM waiting and running request gauges supply role-specific signals. Do not install conflicting autoscalers for one target. Metric aggregation, freshness, model warm-up and safe scale-down require verification. The following slides explain policy and signal choices independently of the configuration API.</a:t>
             </a:r>
           </a:p>
           <a:p/>
@@ -2101,7 +2101,7 @@
           <a:lstStyle/>
           <a:p>
             <a:r>
-              <a:t>The dedicated autoscaling design recommends versioned role-aware annotations for the initial implementation, with typed roles[].autoscaling as an alternative. An MRI adapter projects policies onto child metadata; the optional scaler integration reconciles ScaledObjects. The required MRI-child opt-in and lifecycle safeguards are not implemented merely by adding annotations. The following slides show proposed configuration and staged metric choices.</a:t>
+              <a:t>Public-facing design pattern: express service objectives, reconcile independent role policies, and scale each role as a complete serving replica. Policy representation and controller-specific wiring are implementation details and intentionally omitted here. Existing KEDA/InferenceSet capability is described on the earlier slide; this diagram is not a claim that automatic service-level policy projection is already available. Keep one authoritative autoscaler per target.</a:t>
             </a:r>
           </a:p>
           <a:p/>
@@ -2197,7 +2197,7 @@
           <a:lstStyle/>
           <a:p>
             <a:r>
-              <a:t>Design proposal, not a currently deployable MRI API. Policy is authored on MRI and projected to top-level child InferenceSet metadata, not spec.template.annotations. The existing scaler auto-provision predicates explicitly exclude MRI-owned InferenceSets; an intentional opt-in adapter path must be implemented. The scaler integration, not necessarily the core MRI controller, reconciles one ScaledObject per managed role. KEDA/HPA writes the child InferenceSet scale subresource; MRI leaves replicas alone when nil. Arrows show policy/metric flow, not Kubernetes owner references or literal metrics pushes. Lifecycle: MRI owns InferenceSet, InferenceSet owns ScaledObject, ScaledObject owns HPA. The metric scraper must scope endpoints to the actual role and avoid worker-series double counting.</a:t>
+              <a:t>Architectural control pattern, independent of how policies are encoded. Each role has its own signals, controller decision and serving-replica target. KEDA/HPA targeting an InferenceSet is one implementation. Scope samples to the actual role and deduplicate engine/worker series. Scale complete serving replicas and account for model loading before counting new capacity as ready. Arrows show conceptual policy and metric flow, not strict ownership references or push-based scraping. The serving topology still coordinates P/D requests while the capacity loops act independently. Implementation-specific automatic policy projection is outside this talk slide.</a:t>
             </a:r>
           </a:p>
           <a:p/>
@@ -2293,7 +2293,7 @@
           <a:lstStyle/>
           <a:p>
             <a:r>
-              <a:t>Phase 1 in the proposed implementation uses only vllm:num_requests_waiting for prefill and vllm:num_requests_running for decode. These gauges are registered by vLLM, but presence/type/units must be checked on the actual runtime image. They measure engine-local state, not requests still waiting in the router/EPP. Thresholds and bounds are copied from the design example, not deployment recommendations. The current scaler single-metric formula requests one replica per permitted step; bounds, model readiness, stabilization, cooldown and HPA behavior still apply. Values equal to either threshold hold under the stated strict above/below comparisons. KV utilization and latency histograms remain observational in phase 1. Missing/stale/non-finite data must not be treated as zero; the proposed missing-data guard requires implementation and testing.</a:t>
+              <a:t>Native vllm:num_requests_waiting and vllm:num_requests_running are the primary signals for the respective roles. Verify metric presence, type and units on the actual runtime. Engine-local queues exclude requests still waiting in the router/EPP. Thresholds and bounds are illustrative, not capacity recommendations. The design example uses bounded incremental adjustments; behavior still depends on readiness, stabilization, cooldown and the chosen controller. Equal-to-threshold values hold under the stated strict comparisons. KV utilization and latency support diagnosis; integrating them into automated decisions needs an explicit tested policy. Missing/stale/non-finite data must not become zero; hold/report semantics require implementation and validation.</a:t>
             </a:r>
           </a:p>
           <a:p/>
@@ -2389,7 +2389,7 @@
           <a:lstStyle/>
           <a:p>
             <a:r>
-              <a:t>These are two excerpts under the proposed annotation value roles map, not a complete deployable manifest. Full YAML and required version envelope are in the linked design. The MRI annotation autoscaling.kaito.sh/roles is not implemented today. Its adapter serializes each metrics list to scaledobject.kaito.sh/metrics on the matching child InferenceSet.metadata.annotations, maps min/max and supported scalar settings, and sets auto-provision true. Existing propagation to child template annotations is not sufficient, and the existing MRI-child exclusion must be deliberately adapted. Reject a role policy together with non-nil replicas. Preserve externally managed mode when both replicas and role policy are absent. Do not ask users to patch generated child resources. The AND key is shown for the single-metric v1 policy; adding a KV metric later does not automatically implement the desired asymmetric safety guard. Annotation-only updates require reconciliation even without a generation change. Typed roles[].autoscaling is a future alternative, not a second active source of truth.</a:t>
+              <a:t>The slide explains policy semantics without exposing configuration syntax. Values are illustrative and match the source design: waiting-request thresholds 8/1 and bounds 1–8 for prefill; running-request thresholds 24/4 and bounds 2–16 for decode. Evaluate role-scoped per-replica aggregation, not a whole-service sum. Apply strict above/below comparisons, hold between/equal to thresholds, and enforce bounds, fresh-data checks, readiness, stabilization and cooldown for both roles. Scale-down also requires safe treatment of in-flight work. Policy ownership must be unambiguous. The underlying representation is intentionally outside the external presentation.</a:t>
             </a:r>
           </a:p>
           <a:p/>
@@ -2410,7 +2410,7 @@
           </a:p>
           <a:p>
             <a:r>
-              <a:t>https://kaito-project.github.io/kaito/docs/keda-autoscaler-inference</a:t>
+              <a:t>https://docs.vllm.ai/en/stable/usage/metrics/</a:t>
             </a:r>
           </a:p>
           <a:p>
@@ -2485,7 +2485,7 @@
           <a:lstStyle/>
           <a:p>
             <a:r>
-              <a:t>Three modes: non-nil replicas with no policy means fixed; nil replicas with managed role policy means KAITO-managed autoscaling; both absent means externally managed replicas with no guarantee that an autoscaler exists. Both present is invalid. Autoscaling to fixed requires stopping/removing the owned ScaledObject/HPA and confirming it released control before MRI enforces a fixed value. Do not silently adopt or delete user-created scalers. Missing, stale, unreachable or non-finite metric samples prevent activation; for an active managed policy, the proposed contract holds scaling decisions and surfaces a condition/event. This requires verifying/hardening the complete scaler/HPA error and fallback path; it is not asserted to work today. Partial scrape coverage must not look like zero load. Readiness includes model load and actual serving eligibility; safe scale-down requires appropriate handling of in-flight work.</a:t>
+              <a:t>Safety contract: do not let a fixed-replica reconciler and an autoscaler compete for the same target. Stop the old writer before handing over control, and never silently adopt/delete user-managed autoscalers. Missing, stale, unreachable or non-finite metric samples should prevent activation or hold active decisions and surface a condition/event. This is the required behavior, not an assertion that all controller/HPA fallback paths implement it today; verify end to end. Partial scrape coverage must not look like zero load. Readiness includes model loading and actual serving eligibility. Protect in-flight requests and KV state during scale-down.</a:t>
             </a:r>
           </a:p>
           <a:p/>
@@ -2657,7 +2657,7 @@
           <a:lstStyle/>
           <a:p>
             <a:r>
-              <a:t>Phase 2 is a future plan, not existing metrics or a current MRI release capability. All table input names have the vllm: prefix. Proposed recording-rule names: kaito:decode_kv_cache_usage_max = max valid role-scoped vllm:kv_cache_usage_perc; kaito:decode_kv_cache_free_fraction_min = 1 - that maximum; kaito:prefill_ttft_p95_seconds = histogram_quantile(0.95, summed per-series 5m bucket rates preserving workload/role and le); kaito:decode_generation_tokens_per_second = sum of reset-aware rate(vllm:generation_tokens_total[5m]). Generation tokens is a native Counter exposed with the _total suffix. KV usage is a fraction 0–1; 0.8 is 80%. Maximum usage and minimum free fraction are complements, not independent evidence, bytes or effective request capacity. A fleet maximum does not identify a safe removal target. Histogram quantiles need sufficient observations and are engine-local, not client P/D latency. Apply rate before summing counters, account for resets, deduplicate engines and require fresh/full role coverage. Recording-rule outputs do not appear on vLLM /metrics; a verified adapter/query integration is required. The desired guard allows high running load to scale up independently of KV occupancy, while low load permits scale-down only with safe KV utilization. Simply appending KV to the existing conservative AND list can suppress needed scale-up and is not this policy. Start with observation; promote a signal to control only after failure and workload tests.</a:t>
+              <a:t>These are derived-signal design examples, not metrics natively emitted by vLLM or a claim of current MRI integration support. All table input names have the vllm: prefix. Proposed recording-rule names: kaito:decode_kv_cache_usage_max = max valid role-scoped vllm:kv_cache_usage_perc; kaito:decode_kv_cache_free_fraction_min = 1 - that maximum; kaito:prefill_ttft_p95_seconds = histogram_quantile(0.95, summed per-series 5m bucket rates preserving workload/role and le); kaito:decode_generation_tokens_per_second = sum of reset-aware rate(vllm:generation_tokens_total[5m]). Generation tokens is a native Counter exposed with the _total suffix. KV usage is a fraction 0–1; 0.8 is 80%. Maximum usage and minimum free fraction are complements, not independent evidence, bytes or effective request capacity. A fleet maximum does not identify a safe removal target. Histogram quantiles need sufficient observations and are engine-local, not client P/D latency. Apply rate before summing counters, account for resets, deduplicate engines and require fresh/full role coverage. Recording-rule outputs do not appear on vLLM /metrics; a verified adapter/query integration is required. The desired guard allows high running load to scale up independently of KV occupancy, while low load permits scale-down only with safe KV utilization. Simply appending KV to the existing conservative AND list can suppress needed scale-up and is not this policy. Start with observation; promote a signal to control only after failure and workload tests.</a:t>
             </a:r>
           </a:p>
           <a:p/>
@@ -3259,7 +3259,7 @@
           <a:lstStyle/>
           <a:p>
             <a:r>
-              <a:t>Phase 1 uses native vllm:num_requests_waiting and vllm:num_requests_running for the respective role. KV utilization is observational until an explicit tested safety guard is implemented. Validate runtime metric availability, role scope, units and freshness. Derived metrics are a later-stage design, not current vLLM output names.</a:t>
+              <a:t>Native vllm:num_requests_waiting and vllm:num_requests_running are the primary role-specific signals. KV utilization can inform a safety guard only with explicit tested semantics. Validate availability, role scope, units and freshness. Derived metrics require aggregation and collection; their names are not native vLLM outputs.</a:t>
             </a:r>
           </a:p>
           <a:p/>
@@ -26628,7 +26628,7 @@
               </a:defRPr>
             </a:pPr>
             <a:r>
-              <a:t>Autoscale the phase that is actually saturated</a:t>
+              <a:t>Autoscale the role that is actually saturated</a:t>
             </a:r>
           </a:p>
         </p:txBody>
@@ -27154,7 +27154,7 @@
               </a:defRPr>
             </a:pPr>
             <a:r>
-              <a:t>Phase 1 signal: vLLM waiting requests</a:t>
+              <a:t>Primary signal: vLLM waiting requests</a:t>
             </a:r>
           </a:p>
         </p:txBody>
@@ -27434,7 +27434,7 @@
               </a:defRPr>
             </a:pPr>
             <a:r>
-              <a:t>Phase 1 signal: vLLM running requests</a:t>
+              <a:t>Primary signal: vLLM running requests</a:t>
             </a:r>
           </a:p>
         </p:txBody>
@@ -30563,7 +30563,7 @@
               </a:defRPr>
             </a:pPr>
             <a:r>
-              <a:t>04 / PROPOSED API DIRECTION</a:t>
+              <a:t>04 / POLICY BOUNDARY</a:t>
             </a:r>
           </a:p>
         </p:txBody>
@@ -30605,7 +30605,7 @@
               </a:defRPr>
             </a:pPr>
             <a:r>
-              <a:t>Recommended UX: one MRI, per-role scaling intent</a:t>
+              <a:t>One service, independently managed role capacity</a:t>
             </a:r>
           </a:p>
         </p:txBody>
@@ -30647,7 +30647,7 @@
               </a:defRPr>
             </a:pPr>
             <a:r>
-              <a:t>This is a platform recommendation, not an implemented YAML schema.</a:t>
+              <a:t>Coordinate P/D at the service level; make capacity decisions separately for each role.</a:t>
             </a:r>
           </a:p>
         </p:txBody>
@@ -30732,7 +30732,7 @@
               </a:defRPr>
             </a:pPr>
             <a:r>
-              <a:t>Users should express the intent; controllers should generate the scaling plumbing.</a:t>
+              <a:t>Scale a complete serving replica—not an individual tensor-parallel worker.</a:t>
             </a:r>
           </a:p>
         </p:txBody>
@@ -30938,7 +30938,7 @@
               </a:defRPr>
             </a:pPr>
             <a:r>
-              <a:t>RECOMMENDATION / NOT A CURRENT API</a:t>
+              <a:t>DESIGN PATTERN / PER-ROLE CONTROL</a:t>
             </a:r>
           </a:p>
         </p:txBody>
@@ -31070,7 +31070,7 @@
               </a:defRPr>
             </a:pPr>
             <a:r>
-              <a:t>MRI role intent</a:t>
+              <a:t>Service-level intent</a:t>
             </a:r>
           </a:p>
         </p:txBody>
@@ -31112,7 +31112,7 @@
               </a:defRPr>
             </a:pPr>
             <a:r>
-              <a:t>Prefill: waiting-request policy</a:t>
+              <a:t>Prefill: latency objective</a:t>
             </a:r>
           </a:p>
           <a:p>
@@ -31131,7 +31131,7 @@
               </a:defRPr>
             </a:pPr>
             <a:r>
-              <a:t>Decode: running-request policy</a:t>
+              <a:t>Decode: delivery objective</a:t>
             </a:r>
           </a:p>
         </p:txBody>
@@ -31263,7 +31263,7 @@
               </a:defRPr>
             </a:pPr>
             <a:r>
-              <a:t>KAITO controller</a:t>
+              <a:t>Policy reconciliation</a:t>
             </a:r>
           </a:p>
         </p:txBody>
@@ -31305,7 +31305,7 @@
               </a:defRPr>
             </a:pPr>
             <a:r>
-              <a:t>Project policy onto child roles</a:t>
+              <a:t>Independent role targets</a:t>
             </a:r>
           </a:p>
         </p:txBody>
@@ -31969,7 +31969,7 @@
               </a:defRPr>
             </a:pPr>
             <a:r>
-              <a:t>04 / AUTOSCALING IMPLEMENTATION</a:t>
+              <a:t>04 / CONTROL-LOOP DESIGN</a:t>
             </a:r>
           </a:p>
         </p:txBody>
@@ -32011,7 +32011,7 @@
               </a:defRPr>
             </a:pPr>
             <a:r>
-              <a:t>One policy entry per role. One actuator per target.</a:t>
+              <a:t>Observe each role. Act on its own capacity.</a:t>
             </a:r>
           </a:p>
         </p:txBody>
@@ -32053,7 +32053,7 @@
               </a:defRPr>
             </a:pPr>
             <a:r>
-              <a:t>Proposed MRI integration: reuse the scaler instead of rebuilding KEDA inside KAITO.</a:t>
+              <a:t>Independent feedback loops connect role-specific load to role-specific serving capacity.</a:t>
             </a:r>
           </a:p>
         </p:txBody>
@@ -32138,7 +32138,7 @@
               </a:defRPr>
             </a:pPr>
             <a:r>
-              <a:t>Scale each role InferenceSet; do not scale the entire MRI or individual tensor-parallel pods.</a:t>
+              <a:t>Routing chooses where requests go; autoscaling changes how much capacity is available.</a:t>
             </a:r>
           </a:p>
         </p:txBody>
@@ -32389,7 +32389,7 @@
               </a:defRPr>
             </a:pPr>
             <a:r>
-              <a:t>MRI role annotations</a:t>
+              <a:t>Role-specific policies</a:t>
             </a:r>
           </a:p>
         </p:txBody>
@@ -32431,7 +32431,7 @@
               </a:defRPr>
             </a:pPr>
             <a:r>
-              <a:t>One user-facing resource</a:t>
+              <a:t>Signals, thresholds and bounds</a:t>
             </a:r>
           </a:p>
         </p:txBody>
@@ -32563,7 +32563,7 @@
               </a:defRPr>
             </a:pPr>
             <a:r>
-              <a:t>MRI adapter</a:t>
+              <a:t>Independent decisions</a:t>
             </a:r>
           </a:p>
         </p:txBody>
@@ -32605,7 +32605,7 @@
               </a:defRPr>
             </a:pPr>
             <a:r>
-              <a:t>Project to child metadata</a:t>
+              <a:t>One controller per target</a:t>
             </a:r>
           </a:p>
         </p:txBody>
@@ -32737,7 +32737,7 @@
               </a:defRPr>
             </a:pPr>
             <a:r>
-              <a:t>Scaler integration</a:t>
+              <a:t>Serving capacity</a:t>
             </a:r>
           </a:p>
         </p:txBody>
@@ -32779,7 +32779,7 @@
               </a:defRPr>
             </a:pPr>
             <a:r>
-              <a:t>Reconcile role ScaledObjects</a:t>
+              <a:t>Count model-ready replicas</a:t>
             </a:r>
           </a:p>
         </p:txBody>
@@ -33157,7 +33157,7 @@
               </a:defRPr>
             </a:pPr>
             <a:r>
-              <a:t>Prefill ScaledObject</a:t>
+              <a:t>Prefill autoscaler</a:t>
             </a:r>
           </a:p>
         </p:txBody>
@@ -33199,7 +33199,7 @@
               </a:defRPr>
             </a:pPr>
             <a:r>
-              <a:t>KEDA + one HPA for this target</a:t>
+              <a:t>Evaluate this role independently</a:t>
             </a:r>
           </a:p>
         </p:txBody>
@@ -33331,7 +33331,7 @@
               </a:defRPr>
             </a:pPr>
             <a:r>
-              <a:t>Prefill InferenceSet</a:t>
+              <a:t>Prefill replicas</a:t>
             </a:r>
           </a:p>
         </p:txBody>
@@ -33373,7 +33373,7 @@
               </a:defRPr>
             </a:pPr>
             <a:r>
-              <a:t>/scale → desired role replicas</a:t>
+              <a:t>Reconcile serving capacity</a:t>
             </a:r>
           </a:p>
         </p:txBody>
@@ -33751,7 +33751,7 @@
               </a:defRPr>
             </a:pPr>
             <a:r>
-              <a:t>Decode ScaledObject</a:t>
+              <a:t>Decode autoscaler</a:t>
             </a:r>
           </a:p>
         </p:txBody>
@@ -33793,7 +33793,7 @@
               </a:defRPr>
             </a:pPr>
             <a:r>
-              <a:t>KEDA + one HPA for this target</a:t>
+              <a:t>Evaluate this role independently</a:t>
             </a:r>
           </a:p>
         </p:txBody>
@@ -33925,7 +33925,7 @@
               </a:defRPr>
             </a:pPr>
             <a:r>
-              <a:t>Decode InferenceSet</a:t>
+              <a:t>Decode replicas</a:t>
             </a:r>
           </a:p>
         </p:txBody>
@@ -33967,7 +33967,7 @@
               </a:defRPr>
             </a:pPr>
             <a:r>
-              <a:t>/scale → desired role replicas</a:t>
+              <a:t>Reconcile serving capacity</a:t>
             </a:r>
           </a:p>
         </p:txBody>
@@ -34149,7 +34149,7 @@
               </a:defRPr>
             </a:pPr>
             <a:r>
-              <a:t>Phase 1: two native gauges, two scaling decisions</a:t>
+              <a:t>Two native gauges, two scaling decisions</a:t>
             </a:r>
           </a:p>
         </p:txBody>
@@ -35795,7 +35795,7 @@
               </a:defRPr>
             </a:pPr>
             <a:r>
-              <a:t>04 / PROPOSED CONFIGURATION</a:t>
+              <a:t>04 / ROLE-SPECIFIC DECISIONS</a:t>
             </a:r>
           </a:p>
         </p:txBody>
@@ -35837,7 +35837,7 @@
               </a:defRPr>
             </a:pPr>
             <a:r>
-              <a:t>Annotation-first: one MRI, two role policies</a:t>
+              <a:t>Different roles need different scaling policies</a:t>
             </a:r>
           </a:p>
         </p:txBody>
@@ -35879,7 +35879,7 @@
               </a:defRPr>
             </a:pPr>
             <a:r>
-              <a:t>PROPOSED API — not supported merely by adding these annotations to an existing MRI.</a:t>
+              <a:t>Use the same safety contract, but tune each role against its own workload and objective.</a:t>
             </a:r>
           </a:p>
         </p:txBody>
@@ -35964,7 +35964,7 @@
               </a:defRPr>
             </a:pPr>
             <a:r>
-              <a:t>Set role replicas: null for managed autoscaling. Typed roles[].autoscaling remains an alternative.</a:t>
+              <a:t>Illustrative policy—not universal tuning. Validate thresholds, cooldown and model warm-up.</a:t>
             </a:r>
           </a:p>
         </p:txBody>
@@ -36090,111 +36090,23 @@
       </p:sp>
       <p:sp>
         <p:nvSpPr>
-          <p:cNvPr id="10" name="TextBox 9"/>
-          <p:cNvSpPr txBox="1"/>
-          <p:nvPr/>
-        </p:nvSpPr>
-        <p:spPr>
-          <a:xfrm>
-            <a:off x="530352" y="1975104"/>
-            <a:ext cx="11064240" cy="356616"/>
-          </a:xfrm>
-          <a:prstGeom prst="rect">
-            <a:avLst/>
-          </a:prstGeom>
-          <a:noFill/>
-        </p:spPr>
-        <p:txBody>
-          <a:bodyPr wrap="square" lIns="13716" rIns="13716" tIns="13716" bIns="13716">
-            <a:spAutoFit/>
-          </a:bodyPr>
-          <a:lstStyle/>
-          <a:p>
-            <a:pPr>
-              <a:spcBef>
-                <a:spcPts val="0"/>
-              </a:spcBef>
-              <a:spcAft>
-                <a:spcPts val="500"/>
-              </a:spcAft>
-              <a:defRPr sz="1900" b="1">
-                <a:solidFill>
-                  <a:srgbClr val="2563EB"/>
-                </a:solidFill>
-                <a:latin typeface="Courier New"/>
-              </a:defRPr>
-            </a:pPr>
-            <a:r>
-              <a:t>metadata.annotations["autoscaling.kaito.sh/roles"]</a:t>
-            </a:r>
-          </a:p>
-        </p:txBody>
-      </p:sp>
-      <p:sp>
-        <p:nvSpPr>
-          <p:cNvPr id="11" name="TextBox 10"/>
-          <p:cNvSpPr txBox="1"/>
-          <p:nvPr/>
-        </p:nvSpPr>
-        <p:spPr>
-          <a:xfrm>
-            <a:off x="530352" y="2441448"/>
-            <a:ext cx="11064240" cy="274320"/>
-          </a:xfrm>
-          <a:prstGeom prst="rect">
-            <a:avLst/>
-          </a:prstGeom>
-          <a:noFill/>
-        </p:spPr>
-        <p:txBody>
-          <a:bodyPr wrap="square" lIns="13716" rIns="13716" tIns="13716" bIns="13716">
-            <a:spAutoFit/>
-          </a:bodyPr>
-          <a:lstStyle/>
-          <a:p>
-            <a:pPr>
-              <a:spcBef>
-                <a:spcPts val="0"/>
-              </a:spcBef>
-              <a:spcAft>
-                <a:spcPts val="500"/>
-              </a:spcAft>
-              <a:defRPr sz="1400" b="0">
-                <a:solidFill>
-                  <a:srgbClr val="586A80"/>
-                </a:solidFill>
-                <a:latin typeface="Arial"/>
-              </a:defRPr>
-            </a:pPr>
-            <a:r>
-              <a:t>Annotation value: version: v1alpha1 + roles map. Role-policy excerpts:</a:t>
-            </a:r>
-          </a:p>
-        </p:txBody>
-      </p:sp>
-      <p:sp>
-        <p:nvSpPr>
-          <p:cNvPr id="12" name="Rounded Rectangle 11"/>
+          <p:cNvPr id="10" name="Rectangle 9"/>
           <p:cNvSpPr/>
           <p:nvPr/>
         </p:nvSpPr>
         <p:spPr>
           <a:xfrm>
-            <a:off x="502920" y="2926080"/>
-            <a:ext cx="5440680" cy="2670048"/>
-          </a:xfrm>
-          <a:prstGeom prst="roundRect">
-            <a:avLst>
-              <a:gd name="adj" fmla="val 10000"/>
-            </a:avLst>
+            <a:off x="502920" y="2057400"/>
+            <a:ext cx="2903220" cy="562356"/>
+          </a:xfrm>
+          <a:prstGeom prst="rect">
+            <a:avLst/>
           </a:prstGeom>
           <a:solidFill>
-            <a:srgbClr val="FFFFFF"/>
+            <a:srgbClr val="102039"/>
           </a:solidFill>
-          <a:ln w="12700">
-            <a:solidFill>
-              <a:srgbClr val="D9E2EE"/>
-            </a:solidFill>
+          <a:ln>
+            <a:noFill/>
           </a:ln>
         </p:spPr>
         <p:style>
@@ -36221,14 +36133,14 @@
       </p:sp>
       <p:sp>
         <p:nvSpPr>
-          <p:cNvPr id="13" name="TextBox 12"/>
-          <p:cNvSpPr txBox="1"/>
-          <p:nvPr/>
-        </p:nvSpPr>
-        <p:spPr>
-          <a:xfrm>
-            <a:off x="685800" y="3090672"/>
-            <a:ext cx="5074920" cy="2359152"/>
+          <p:cNvPr id="11" name="TextBox 10"/>
+          <p:cNvSpPr txBox="1"/>
+          <p:nvPr/>
+        </p:nvSpPr>
+        <p:spPr>
+          <a:xfrm>
+            <a:off x="612648" y="2176272"/>
+            <a:ext cx="2706624" cy="402336"/>
           </a:xfrm>
           <a:prstGeom prst="rect">
             <a:avLst/>
@@ -36242,227 +36154,44 @@
           <a:lstStyle/>
           <a:p>
             <a:pPr>
-              <a:lnSpc>
-                <a:spcPct val="100000"/>
-              </a:lnSpc>
-              <a:spcBef>
-                <a:spcPts val="0"/>
-              </a:spcBef>
-              <a:spcAft>
-                <a:spcPts val="100"/>
-              </a:spcAft>
-              <a:defRPr sz="1500" b="0">
-                <a:solidFill>
-                  <a:srgbClr val="087F8C"/>
-                </a:solidFill>
-                <a:latin typeface="Courier New"/>
-              </a:defRPr>
-            </a:pPr>
-            <a:r>
-              <a:t>prefill:</a:t>
-            </a:r>
-          </a:p>
-          <a:p>
-            <a:pPr>
-              <a:lnSpc>
-                <a:spcPct val="100000"/>
-              </a:lnSpc>
-              <a:spcBef>
-                <a:spcPts val="0"/>
-              </a:spcBef>
-              <a:spcAft>
-                <a:spcPts val="100"/>
-              </a:spcAft>
-              <a:defRPr sz="1500" b="0">
-                <a:solidFill>
-                  <a:srgbClr val="087F8C"/>
-                </a:solidFill>
-                <a:latin typeface="Courier New"/>
-              </a:defRPr>
-            </a:pPr>
-            <a:r>
-              <a:t>  min-replicas: "1"</a:t>
-            </a:r>
-          </a:p>
-          <a:p>
-            <a:pPr>
-              <a:lnSpc>
-                <a:spcPct val="100000"/>
-              </a:lnSpc>
-              <a:spcBef>
-                <a:spcPts val="0"/>
-              </a:spcBef>
-              <a:spcAft>
-                <a:spcPts val="100"/>
-              </a:spcAft>
-              <a:defRPr sz="1500" b="0">
-                <a:solidFill>
-                  <a:srgbClr val="087F8C"/>
-                </a:solidFill>
-                <a:latin typeface="Courier New"/>
-              </a:defRPr>
-            </a:pPr>
-            <a:r>
-              <a:t>  max-replicas: "8"</a:t>
-            </a:r>
-          </a:p>
-          <a:p>
-            <a:pPr>
-              <a:lnSpc>
-                <a:spcPct val="100000"/>
-              </a:lnSpc>
-              <a:spcBef>
-                <a:spcPts val="0"/>
-              </a:spcBef>
-              <a:spcAft>
-                <a:spcPts val="100"/>
-              </a:spcAft>
-              <a:defRPr sz="1500" b="0">
-                <a:solidFill>
-                  <a:srgbClr val="087F8C"/>
-                </a:solidFill>
-                <a:latin typeface="Courier New"/>
-              </a:defRPr>
-            </a:pPr>
-            <a:r>
-              <a:t>  combinepolicy: AND</a:t>
-            </a:r>
-          </a:p>
-          <a:p>
-            <a:pPr>
-              <a:lnSpc>
-                <a:spcPct val="100000"/>
-              </a:lnSpc>
-              <a:spcBef>
-                <a:spcPts val="0"/>
-              </a:spcBef>
-              <a:spcAft>
-                <a:spcPts val="100"/>
-              </a:spcAft>
-              <a:defRPr sz="1500" b="0">
-                <a:solidFill>
-                  <a:srgbClr val="087F8C"/>
-                </a:solidFill>
-                <a:latin typeface="Courier New"/>
-              </a:defRPr>
-            </a:pPr>
-            <a:r>
-              <a:t>  metrics:</a:t>
-            </a:r>
-          </a:p>
-          <a:p>
-            <a:pPr>
-              <a:lnSpc>
-                <a:spcPct val="100000"/>
-              </a:lnSpc>
-              <a:spcBef>
-                <a:spcPts val="0"/>
-              </a:spcBef>
-              <a:spcAft>
-                <a:spcPts val="100"/>
-              </a:spcAft>
-              <a:defRPr sz="1500" b="0">
-                <a:solidFill>
-                  <a:srgbClr val="087F8C"/>
-                </a:solidFill>
-                <a:latin typeface="Courier New"/>
-              </a:defRPr>
-            </a:pPr>
-            <a:r>
-              <a:t>  - name: vllm:num_requests_waiting</a:t>
-            </a:r>
-          </a:p>
-          <a:p>
-            <a:pPr>
-              <a:lnSpc>
-                <a:spcPct val="100000"/>
-              </a:lnSpc>
-              <a:spcBef>
-                <a:spcPts val="0"/>
-              </a:spcBef>
-              <a:spcAft>
-                <a:spcPts val="100"/>
-              </a:spcAft>
-              <a:defRPr sz="1500" b="0">
-                <a:solidFill>
-                  <a:srgbClr val="087F8C"/>
-                </a:solidFill>
-                <a:latin typeface="Courier New"/>
-              </a:defRPr>
-            </a:pPr>
-            <a:r>
-              <a:t>    type: gauge</a:t>
-            </a:r>
-          </a:p>
-          <a:p>
-            <a:pPr>
-              <a:lnSpc>
-                <a:spcPct val="100000"/>
-              </a:lnSpc>
-              <a:spcBef>
-                <a:spcPts val="0"/>
-              </a:spcBef>
-              <a:spcAft>
-                <a:spcPts val="100"/>
-              </a:spcAft>
-              <a:defRPr sz="1500" b="0">
-                <a:solidFill>
-                  <a:srgbClr val="087F8C"/>
-                </a:solidFill>
-                <a:latin typeface="Courier New"/>
-              </a:defRPr>
-            </a:pPr>
-            <a:r>
-              <a:t>    upthreshold: 8</a:t>
-            </a:r>
-          </a:p>
-          <a:p>
-            <a:pPr>
-              <a:lnSpc>
-                <a:spcPct val="100000"/>
-              </a:lnSpc>
-              <a:spcBef>
-                <a:spcPts val="0"/>
-              </a:spcBef>
-              <a:spcAft>
-                <a:spcPts val="100"/>
-              </a:spcAft>
-              <a:defRPr sz="1500" b="0">
-                <a:solidFill>
-                  <a:srgbClr val="087F8C"/>
-                </a:solidFill>
-                <a:latin typeface="Courier New"/>
-              </a:defRPr>
-            </a:pPr>
-            <a:r>
-              <a:t>    downthreshold: 1</a:t>
-            </a:r>
-          </a:p>
-        </p:txBody>
-      </p:sp>
-      <p:sp>
-        <p:nvSpPr>
-          <p:cNvPr id="14" name="Rounded Rectangle 13"/>
+              <a:spcBef>
+                <a:spcPts val="0"/>
+              </a:spcBef>
+              <a:spcAft>
+                <a:spcPts val="500"/>
+              </a:spcAft>
+              <a:defRPr sz="1400" b="1">
+                <a:solidFill>
+                  <a:srgbClr val="FFFFFF"/>
+                </a:solidFill>
+                <a:latin typeface="Arial"/>
+              </a:defRPr>
+            </a:pPr>
+            <a:r>
+              <a:t>POLICY</a:t>
+            </a:r>
+          </a:p>
+        </p:txBody>
+      </p:sp>
+      <p:sp>
+        <p:nvSpPr>
+          <p:cNvPr id="12" name="Rectangle 11"/>
           <p:cNvSpPr/>
           <p:nvPr/>
         </p:nvSpPr>
         <p:spPr>
           <a:xfrm>
-            <a:off x="6199632" y="2926080"/>
-            <a:ext cx="5440680" cy="2670048"/>
-          </a:xfrm>
-          <a:prstGeom prst="roundRect">
-            <a:avLst>
-              <a:gd name="adj" fmla="val 10000"/>
-            </a:avLst>
+            <a:off x="3429000" y="2057400"/>
+            <a:ext cx="4101083" cy="562356"/>
+          </a:xfrm>
+          <a:prstGeom prst="rect">
+            <a:avLst/>
           </a:prstGeom>
           <a:solidFill>
-            <a:srgbClr val="FFFFFF"/>
+            <a:srgbClr val="102039"/>
           </a:solidFill>
-          <a:ln w="12700">
-            <a:solidFill>
-              <a:srgbClr val="D9E2EE"/>
-            </a:solidFill>
+          <a:ln>
+            <a:noFill/>
           </a:ln>
         </p:spPr>
         <p:style>
@@ -36489,14 +36218,99 @@
       </p:sp>
       <p:sp>
         <p:nvSpPr>
+          <p:cNvPr id="13" name="TextBox 12"/>
+          <p:cNvSpPr txBox="1"/>
+          <p:nvPr/>
+        </p:nvSpPr>
+        <p:spPr>
+          <a:xfrm>
+            <a:off x="3538728" y="2176272"/>
+            <a:ext cx="3904487" cy="402336"/>
+          </a:xfrm>
+          <a:prstGeom prst="rect">
+            <a:avLst/>
+          </a:prstGeom>
+          <a:noFill/>
+        </p:spPr>
+        <p:txBody>
+          <a:bodyPr wrap="square" lIns="13716" rIns="13716" tIns="13716" bIns="13716">
+            <a:spAutoFit/>
+          </a:bodyPr>
+          <a:lstStyle/>
+          <a:p>
+            <a:pPr>
+              <a:spcBef>
+                <a:spcPts val="0"/>
+              </a:spcBef>
+              <a:spcAft>
+                <a:spcPts val="500"/>
+              </a:spcAft>
+              <a:defRPr sz="1400" b="1">
+                <a:solidFill>
+                  <a:srgbClr val="FFFFFF"/>
+                </a:solidFill>
+                <a:latin typeface="Arial"/>
+              </a:defRPr>
+            </a:pPr>
+            <a:r>
+              <a:t>PREFILL</a:t>
+            </a:r>
+          </a:p>
+        </p:txBody>
+      </p:sp>
+      <p:sp>
+        <p:nvSpPr>
+          <p:cNvPr id="14" name="Rectangle 13"/>
+          <p:cNvSpPr/>
+          <p:nvPr/>
+        </p:nvSpPr>
+        <p:spPr>
+          <a:xfrm>
+            <a:off x="7552944" y="2057400"/>
+            <a:ext cx="4101083" cy="562356"/>
+          </a:xfrm>
+          <a:prstGeom prst="rect">
+            <a:avLst/>
+          </a:prstGeom>
+          <a:solidFill>
+            <a:srgbClr val="102039"/>
+          </a:solidFill>
+          <a:ln>
+            <a:noFill/>
+          </a:ln>
+        </p:spPr>
+        <p:style>
+          <a:lnRef idx="1">
+            <a:schemeClr val="accent1"/>
+          </a:lnRef>
+          <a:fillRef idx="3">
+            <a:schemeClr val="accent1"/>
+          </a:fillRef>
+          <a:effectRef idx="2">
+            <a:schemeClr val="accent1"/>
+          </a:effectRef>
+          <a:fontRef idx="minor">
+            <a:schemeClr val="lt1"/>
+          </a:fontRef>
+        </p:style>
+        <p:txBody>
+          <a:bodyPr rtlCol="0" anchor="ctr"/>
+          <a:lstStyle/>
+          <a:p>
+            <a:pPr algn="ctr"/>
+          </a:p>
+        </p:txBody>
+      </p:sp>
+      <p:sp>
+        <p:nvSpPr>
           <p:cNvPr id="15" name="TextBox 14"/>
           <p:cNvSpPr txBox="1"/>
           <p:nvPr/>
         </p:nvSpPr>
         <p:spPr>
           <a:xfrm>
-            <a:off x="6382512" y="3090672"/>
-            <a:ext cx="5074920" cy="2359152"/>
+            <a:off x="7662671" y="2176272"/>
+            <a:ext cx="3904487" cy="402336"/>
           </a:xfrm>
           <a:prstGeom prst="rect">
             <a:avLst/>
@@ -36510,200 +36324,1296 @@
           <a:lstStyle/>
           <a:p>
             <a:pPr>
-              <a:lnSpc>
-                <a:spcPct val="100000"/>
-              </a:lnSpc>
-              <a:spcBef>
-                <a:spcPts val="0"/>
-              </a:spcBef>
-              <a:spcAft>
-                <a:spcPts val="100"/>
+              <a:spcBef>
+                <a:spcPts val="0"/>
+              </a:spcBef>
+              <a:spcAft>
+                <a:spcPts val="500"/>
+              </a:spcAft>
+              <a:defRPr sz="1400" b="1">
+                <a:solidFill>
+                  <a:srgbClr val="FFFFFF"/>
+                </a:solidFill>
+                <a:latin typeface="Arial"/>
+              </a:defRPr>
+            </a:pPr>
+            <a:r>
+              <a:t>DECODE</a:t>
+            </a:r>
+          </a:p>
+        </p:txBody>
+      </p:sp>
+      <p:sp>
+        <p:nvSpPr>
+          <p:cNvPr id="16" name="Rectangle 15"/>
+          <p:cNvSpPr/>
+          <p:nvPr/>
+        </p:nvSpPr>
+        <p:spPr>
+          <a:xfrm>
+            <a:off x="502920" y="2642616"/>
+            <a:ext cx="2903220" cy="562356"/>
+          </a:xfrm>
+          <a:prstGeom prst="rect">
+            <a:avLst/>
+          </a:prstGeom>
+          <a:solidFill>
+            <a:srgbClr val="FFFFFF"/>
+          </a:solidFill>
+          <a:ln>
+            <a:noFill/>
+          </a:ln>
+        </p:spPr>
+        <p:style>
+          <a:lnRef idx="1">
+            <a:schemeClr val="accent1"/>
+          </a:lnRef>
+          <a:fillRef idx="3">
+            <a:schemeClr val="accent1"/>
+          </a:fillRef>
+          <a:effectRef idx="2">
+            <a:schemeClr val="accent1"/>
+          </a:effectRef>
+          <a:fontRef idx="minor">
+            <a:schemeClr val="lt1"/>
+          </a:fontRef>
+        </p:style>
+        <p:txBody>
+          <a:bodyPr rtlCol="0" anchor="ctr"/>
+          <a:lstStyle/>
+          <a:p>
+            <a:pPr algn="ctr"/>
+          </a:p>
+        </p:txBody>
+      </p:sp>
+      <p:sp>
+        <p:nvSpPr>
+          <p:cNvPr id="17" name="TextBox 16"/>
+          <p:cNvSpPr txBox="1"/>
+          <p:nvPr/>
+        </p:nvSpPr>
+        <p:spPr>
+          <a:xfrm>
+            <a:off x="612648" y="2761488"/>
+            <a:ext cx="2706624" cy="402336"/>
+          </a:xfrm>
+          <a:prstGeom prst="rect">
+            <a:avLst/>
+          </a:prstGeom>
+          <a:noFill/>
+        </p:spPr>
+        <p:txBody>
+          <a:bodyPr wrap="square" lIns="13716" rIns="13716" tIns="13716" bIns="13716">
+            <a:spAutoFit/>
+          </a:bodyPr>
+          <a:lstStyle/>
+          <a:p>
+            <a:pPr>
+              <a:spcBef>
+                <a:spcPts val="0"/>
+              </a:spcBef>
+              <a:spcAft>
+                <a:spcPts val="500"/>
               </a:spcAft>
               <a:defRPr sz="1500" b="0">
                 <a:solidFill>
-                  <a:srgbClr val="7354B8"/>
-                </a:solidFill>
-                <a:latin typeface="Courier New"/>
-              </a:defRPr>
-            </a:pPr>
-            <a:r>
-              <a:t>decode:</a:t>
-            </a:r>
-          </a:p>
+                  <a:srgbClr val="2563EB"/>
+                </a:solidFill>
+                <a:latin typeface="Arial"/>
+              </a:defRPr>
+            </a:pPr>
+            <a:r>
+              <a:t>Primary signal</a:t>
+            </a:r>
+          </a:p>
+        </p:txBody>
+      </p:sp>
+      <p:sp>
+        <p:nvSpPr>
+          <p:cNvPr id="18" name="Rectangle 17"/>
+          <p:cNvSpPr/>
+          <p:nvPr/>
+        </p:nvSpPr>
+        <p:spPr>
+          <a:xfrm>
+            <a:off x="3429000" y="2642616"/>
+            <a:ext cx="4101083" cy="562356"/>
+          </a:xfrm>
+          <a:prstGeom prst="rect">
+            <a:avLst/>
+          </a:prstGeom>
+          <a:solidFill>
+            <a:srgbClr val="FFFFFF"/>
+          </a:solidFill>
+          <a:ln>
+            <a:noFill/>
+          </a:ln>
+        </p:spPr>
+        <p:style>
+          <a:lnRef idx="1">
+            <a:schemeClr val="accent1"/>
+          </a:lnRef>
+          <a:fillRef idx="3">
+            <a:schemeClr val="accent1"/>
+          </a:fillRef>
+          <a:effectRef idx="2">
+            <a:schemeClr val="accent1"/>
+          </a:effectRef>
+          <a:fontRef idx="minor">
+            <a:schemeClr val="lt1"/>
+          </a:fontRef>
+        </p:style>
+        <p:txBody>
+          <a:bodyPr rtlCol="0" anchor="ctr"/>
+          <a:lstStyle/>
+          <a:p>
+            <a:pPr algn="ctr"/>
+          </a:p>
+        </p:txBody>
+      </p:sp>
+      <p:sp>
+        <p:nvSpPr>
+          <p:cNvPr id="19" name="TextBox 18"/>
+          <p:cNvSpPr txBox="1"/>
+          <p:nvPr/>
+        </p:nvSpPr>
+        <p:spPr>
+          <a:xfrm>
+            <a:off x="3538728" y="2761488"/>
+            <a:ext cx="3904487" cy="402336"/>
+          </a:xfrm>
+          <a:prstGeom prst="rect">
+            <a:avLst/>
+          </a:prstGeom>
+          <a:noFill/>
+        </p:spPr>
+        <p:txBody>
+          <a:bodyPr wrap="square" lIns="13716" rIns="13716" tIns="13716" bIns="13716">
+            <a:spAutoFit/>
+          </a:bodyPr>
+          <a:lstStyle/>
           <a:p>
             <a:pPr>
-              <a:lnSpc>
-                <a:spcPct val="100000"/>
-              </a:lnSpc>
-              <a:spcBef>
-                <a:spcPts val="0"/>
-              </a:spcBef>
-              <a:spcAft>
-                <a:spcPts val="100"/>
+              <a:spcBef>
+                <a:spcPts val="0"/>
+              </a:spcBef>
+              <a:spcAft>
+                <a:spcPts val="500"/>
               </a:spcAft>
               <a:defRPr sz="1500" b="0">
                 <a:solidFill>
-                  <a:srgbClr val="7354B8"/>
-                </a:solidFill>
-                <a:latin typeface="Courier New"/>
-              </a:defRPr>
-            </a:pPr>
-            <a:r>
-              <a:t>  min-replicas: "2"</a:t>
-            </a:r>
-          </a:p>
+                  <a:srgbClr val="172941"/>
+                </a:solidFill>
+                <a:latin typeface="Arial"/>
+              </a:defRPr>
+            </a:pPr>
+            <a:r>
+              <a:t>Waiting requests</a:t>
+            </a:r>
+          </a:p>
+        </p:txBody>
+      </p:sp>
+      <p:sp>
+        <p:nvSpPr>
+          <p:cNvPr id="20" name="Rectangle 19"/>
+          <p:cNvSpPr/>
+          <p:nvPr/>
+        </p:nvSpPr>
+        <p:spPr>
+          <a:xfrm>
+            <a:off x="7552944" y="2642616"/>
+            <a:ext cx="4101083" cy="562356"/>
+          </a:xfrm>
+          <a:prstGeom prst="rect">
+            <a:avLst/>
+          </a:prstGeom>
+          <a:solidFill>
+            <a:srgbClr val="FFFFFF"/>
+          </a:solidFill>
+          <a:ln>
+            <a:noFill/>
+          </a:ln>
+        </p:spPr>
+        <p:style>
+          <a:lnRef idx="1">
+            <a:schemeClr val="accent1"/>
+          </a:lnRef>
+          <a:fillRef idx="3">
+            <a:schemeClr val="accent1"/>
+          </a:fillRef>
+          <a:effectRef idx="2">
+            <a:schemeClr val="accent1"/>
+          </a:effectRef>
+          <a:fontRef idx="minor">
+            <a:schemeClr val="lt1"/>
+          </a:fontRef>
+        </p:style>
+        <p:txBody>
+          <a:bodyPr rtlCol="0" anchor="ctr"/>
+          <a:lstStyle/>
+          <a:p>
+            <a:pPr algn="ctr"/>
+          </a:p>
+        </p:txBody>
+      </p:sp>
+      <p:sp>
+        <p:nvSpPr>
+          <p:cNvPr id="21" name="TextBox 20"/>
+          <p:cNvSpPr txBox="1"/>
+          <p:nvPr/>
+        </p:nvSpPr>
+        <p:spPr>
+          <a:xfrm>
+            <a:off x="7662671" y="2761488"/>
+            <a:ext cx="3904487" cy="402336"/>
+          </a:xfrm>
+          <a:prstGeom prst="rect">
+            <a:avLst/>
+          </a:prstGeom>
+          <a:noFill/>
+        </p:spPr>
+        <p:txBody>
+          <a:bodyPr wrap="square" lIns="13716" rIns="13716" tIns="13716" bIns="13716">
+            <a:spAutoFit/>
+          </a:bodyPr>
+          <a:lstStyle/>
           <a:p>
             <a:pPr>
-              <a:lnSpc>
-                <a:spcPct val="100000"/>
-              </a:lnSpc>
-              <a:spcBef>
-                <a:spcPts val="0"/>
-              </a:spcBef>
-              <a:spcAft>
-                <a:spcPts val="100"/>
+              <a:spcBef>
+                <a:spcPts val="0"/>
+              </a:spcBef>
+              <a:spcAft>
+                <a:spcPts val="500"/>
               </a:spcAft>
               <a:defRPr sz="1500" b="0">
                 <a:solidFill>
-                  <a:srgbClr val="7354B8"/>
-                </a:solidFill>
-                <a:latin typeface="Courier New"/>
-              </a:defRPr>
-            </a:pPr>
-            <a:r>
-              <a:t>  max-replicas: "16"</a:t>
-            </a:r>
-          </a:p>
+                  <a:srgbClr val="172941"/>
+                </a:solidFill>
+                <a:latin typeface="Arial"/>
+              </a:defRPr>
+            </a:pPr>
+            <a:r>
+              <a:t>Running requests</a:t>
+            </a:r>
+          </a:p>
+        </p:txBody>
+      </p:sp>
+      <p:sp>
+        <p:nvSpPr>
+          <p:cNvPr id="22" name="Rectangle 21"/>
+          <p:cNvSpPr/>
+          <p:nvPr/>
+        </p:nvSpPr>
+        <p:spPr>
+          <a:xfrm>
+            <a:off x="502920" y="3227832"/>
+            <a:ext cx="2903220" cy="562356"/>
+          </a:xfrm>
+          <a:prstGeom prst="rect">
+            <a:avLst/>
+          </a:prstGeom>
+          <a:solidFill>
+            <a:srgbClr val="EAF1FF"/>
+          </a:solidFill>
+          <a:ln>
+            <a:noFill/>
+          </a:ln>
+        </p:spPr>
+        <p:style>
+          <a:lnRef idx="1">
+            <a:schemeClr val="accent1"/>
+          </a:lnRef>
+          <a:fillRef idx="3">
+            <a:schemeClr val="accent1"/>
+          </a:fillRef>
+          <a:effectRef idx="2">
+            <a:schemeClr val="accent1"/>
+          </a:effectRef>
+          <a:fontRef idx="minor">
+            <a:schemeClr val="lt1"/>
+          </a:fontRef>
+        </p:style>
+        <p:txBody>
+          <a:bodyPr rtlCol="0" anchor="ctr"/>
+          <a:lstStyle/>
+          <a:p>
+            <a:pPr algn="ctr"/>
+          </a:p>
+        </p:txBody>
+      </p:sp>
+      <p:sp>
+        <p:nvSpPr>
+          <p:cNvPr id="23" name="TextBox 22"/>
+          <p:cNvSpPr txBox="1"/>
+          <p:nvPr/>
+        </p:nvSpPr>
+        <p:spPr>
+          <a:xfrm>
+            <a:off x="612648" y="3346704"/>
+            <a:ext cx="2706624" cy="402336"/>
+          </a:xfrm>
+          <a:prstGeom prst="rect">
+            <a:avLst/>
+          </a:prstGeom>
+          <a:noFill/>
+        </p:spPr>
+        <p:txBody>
+          <a:bodyPr wrap="square" lIns="13716" rIns="13716" tIns="13716" bIns="13716">
+            <a:spAutoFit/>
+          </a:bodyPr>
+          <a:lstStyle/>
           <a:p>
             <a:pPr>
-              <a:lnSpc>
-                <a:spcPct val="100000"/>
-              </a:lnSpc>
-              <a:spcBef>
-                <a:spcPts val="0"/>
-              </a:spcBef>
-              <a:spcAft>
-                <a:spcPts val="100"/>
+              <a:spcBef>
+                <a:spcPts val="0"/>
+              </a:spcBef>
+              <a:spcAft>
+                <a:spcPts val="500"/>
               </a:spcAft>
               <a:defRPr sz="1500" b="0">
                 <a:solidFill>
-                  <a:srgbClr val="7354B8"/>
-                </a:solidFill>
-                <a:latin typeface="Courier New"/>
-              </a:defRPr>
-            </a:pPr>
-            <a:r>
-              <a:t>  combinepolicy: AND</a:t>
-            </a:r>
-          </a:p>
+                  <a:srgbClr val="2563EB"/>
+                </a:solidFill>
+                <a:latin typeface="Arial"/>
+              </a:defRPr>
+            </a:pPr>
+            <a:r>
+              <a:t>Example replica range</a:t>
+            </a:r>
+          </a:p>
+        </p:txBody>
+      </p:sp>
+      <p:sp>
+        <p:nvSpPr>
+          <p:cNvPr id="24" name="Rectangle 23"/>
+          <p:cNvSpPr/>
+          <p:nvPr/>
+        </p:nvSpPr>
+        <p:spPr>
+          <a:xfrm>
+            <a:off x="3429000" y="3227832"/>
+            <a:ext cx="4101083" cy="562356"/>
+          </a:xfrm>
+          <a:prstGeom prst="rect">
+            <a:avLst/>
+          </a:prstGeom>
+          <a:solidFill>
+            <a:srgbClr val="EAF1FF"/>
+          </a:solidFill>
+          <a:ln>
+            <a:noFill/>
+          </a:ln>
+        </p:spPr>
+        <p:style>
+          <a:lnRef idx="1">
+            <a:schemeClr val="accent1"/>
+          </a:lnRef>
+          <a:fillRef idx="3">
+            <a:schemeClr val="accent1"/>
+          </a:fillRef>
+          <a:effectRef idx="2">
+            <a:schemeClr val="accent1"/>
+          </a:effectRef>
+          <a:fontRef idx="minor">
+            <a:schemeClr val="lt1"/>
+          </a:fontRef>
+        </p:style>
+        <p:txBody>
+          <a:bodyPr rtlCol="0" anchor="ctr"/>
+          <a:lstStyle/>
+          <a:p>
+            <a:pPr algn="ctr"/>
+          </a:p>
+        </p:txBody>
+      </p:sp>
+      <p:sp>
+        <p:nvSpPr>
+          <p:cNvPr id="25" name="TextBox 24"/>
+          <p:cNvSpPr txBox="1"/>
+          <p:nvPr/>
+        </p:nvSpPr>
+        <p:spPr>
+          <a:xfrm>
+            <a:off x="3538728" y="3346704"/>
+            <a:ext cx="3904487" cy="402336"/>
+          </a:xfrm>
+          <a:prstGeom prst="rect">
+            <a:avLst/>
+          </a:prstGeom>
+          <a:noFill/>
+        </p:spPr>
+        <p:txBody>
+          <a:bodyPr wrap="square" lIns="13716" rIns="13716" tIns="13716" bIns="13716">
+            <a:spAutoFit/>
+          </a:bodyPr>
+          <a:lstStyle/>
           <a:p>
             <a:pPr>
-              <a:lnSpc>
-                <a:spcPct val="100000"/>
-              </a:lnSpc>
-              <a:spcBef>
-                <a:spcPts val="0"/>
-              </a:spcBef>
-              <a:spcAft>
-                <a:spcPts val="100"/>
+              <a:spcBef>
+                <a:spcPts val="0"/>
+              </a:spcBef>
+              <a:spcAft>
+                <a:spcPts val="500"/>
               </a:spcAft>
               <a:defRPr sz="1500" b="0">
                 <a:solidFill>
-                  <a:srgbClr val="7354B8"/>
-                </a:solidFill>
-                <a:latin typeface="Courier New"/>
-              </a:defRPr>
-            </a:pPr>
-            <a:r>
-              <a:t>  metrics:</a:t>
-            </a:r>
-          </a:p>
+                  <a:srgbClr val="172941"/>
+                </a:solidFill>
+                <a:latin typeface="Arial"/>
+              </a:defRPr>
+            </a:pPr>
+            <a:r>
+              <a:t>1–8</a:t>
+            </a:r>
+          </a:p>
+        </p:txBody>
+      </p:sp>
+      <p:sp>
+        <p:nvSpPr>
+          <p:cNvPr id="26" name="Rectangle 25"/>
+          <p:cNvSpPr/>
+          <p:nvPr/>
+        </p:nvSpPr>
+        <p:spPr>
+          <a:xfrm>
+            <a:off x="7552944" y="3227832"/>
+            <a:ext cx="4101083" cy="562356"/>
+          </a:xfrm>
+          <a:prstGeom prst="rect">
+            <a:avLst/>
+          </a:prstGeom>
+          <a:solidFill>
+            <a:srgbClr val="EAF1FF"/>
+          </a:solidFill>
+          <a:ln>
+            <a:noFill/>
+          </a:ln>
+        </p:spPr>
+        <p:style>
+          <a:lnRef idx="1">
+            <a:schemeClr val="accent1"/>
+          </a:lnRef>
+          <a:fillRef idx="3">
+            <a:schemeClr val="accent1"/>
+          </a:fillRef>
+          <a:effectRef idx="2">
+            <a:schemeClr val="accent1"/>
+          </a:effectRef>
+          <a:fontRef idx="minor">
+            <a:schemeClr val="lt1"/>
+          </a:fontRef>
+        </p:style>
+        <p:txBody>
+          <a:bodyPr rtlCol="0" anchor="ctr"/>
+          <a:lstStyle/>
+          <a:p>
+            <a:pPr algn="ctr"/>
+          </a:p>
+        </p:txBody>
+      </p:sp>
+      <p:sp>
+        <p:nvSpPr>
+          <p:cNvPr id="27" name="TextBox 26"/>
+          <p:cNvSpPr txBox="1"/>
+          <p:nvPr/>
+        </p:nvSpPr>
+        <p:spPr>
+          <a:xfrm>
+            <a:off x="7662671" y="3346704"/>
+            <a:ext cx="3904487" cy="402336"/>
+          </a:xfrm>
+          <a:prstGeom prst="rect">
+            <a:avLst/>
+          </a:prstGeom>
+          <a:noFill/>
+        </p:spPr>
+        <p:txBody>
+          <a:bodyPr wrap="square" lIns="13716" rIns="13716" tIns="13716" bIns="13716">
+            <a:spAutoFit/>
+          </a:bodyPr>
+          <a:lstStyle/>
           <a:p>
             <a:pPr>
-              <a:lnSpc>
-                <a:spcPct val="100000"/>
-              </a:lnSpc>
-              <a:spcBef>
-                <a:spcPts val="0"/>
-              </a:spcBef>
-              <a:spcAft>
-                <a:spcPts val="100"/>
+              <a:spcBef>
+                <a:spcPts val="0"/>
+              </a:spcBef>
+              <a:spcAft>
+                <a:spcPts val="500"/>
               </a:spcAft>
               <a:defRPr sz="1500" b="0">
                 <a:solidFill>
-                  <a:srgbClr val="7354B8"/>
-                </a:solidFill>
-                <a:latin typeface="Courier New"/>
-              </a:defRPr>
-            </a:pPr>
-            <a:r>
-              <a:t>  - name: vllm:num_requests_running</a:t>
-            </a:r>
-          </a:p>
+                  <a:srgbClr val="172941"/>
+                </a:solidFill>
+                <a:latin typeface="Arial"/>
+              </a:defRPr>
+            </a:pPr>
+            <a:r>
+              <a:t>2–16</a:t>
+            </a:r>
+          </a:p>
+        </p:txBody>
+      </p:sp>
+      <p:sp>
+        <p:nvSpPr>
+          <p:cNvPr id="28" name="Rectangle 27"/>
+          <p:cNvSpPr/>
+          <p:nvPr/>
+        </p:nvSpPr>
+        <p:spPr>
+          <a:xfrm>
+            <a:off x="502920" y="3813048"/>
+            <a:ext cx="2903220" cy="562356"/>
+          </a:xfrm>
+          <a:prstGeom prst="rect">
+            <a:avLst/>
+          </a:prstGeom>
+          <a:solidFill>
+            <a:srgbClr val="FFFFFF"/>
+          </a:solidFill>
+          <a:ln>
+            <a:noFill/>
+          </a:ln>
+        </p:spPr>
+        <p:style>
+          <a:lnRef idx="1">
+            <a:schemeClr val="accent1"/>
+          </a:lnRef>
+          <a:fillRef idx="3">
+            <a:schemeClr val="accent1"/>
+          </a:fillRef>
+          <a:effectRef idx="2">
+            <a:schemeClr val="accent1"/>
+          </a:effectRef>
+          <a:fontRef idx="minor">
+            <a:schemeClr val="lt1"/>
+          </a:fontRef>
+        </p:style>
+        <p:txBody>
+          <a:bodyPr rtlCol="0" anchor="ctr"/>
+          <a:lstStyle/>
+          <a:p>
+            <a:pPr algn="ctr"/>
+          </a:p>
+        </p:txBody>
+      </p:sp>
+      <p:sp>
+        <p:nvSpPr>
+          <p:cNvPr id="29" name="TextBox 28"/>
+          <p:cNvSpPr txBox="1"/>
+          <p:nvPr/>
+        </p:nvSpPr>
+        <p:spPr>
+          <a:xfrm>
+            <a:off x="612648" y="3931920"/>
+            <a:ext cx="2706624" cy="402336"/>
+          </a:xfrm>
+          <a:prstGeom prst="rect">
+            <a:avLst/>
+          </a:prstGeom>
+          <a:noFill/>
+        </p:spPr>
+        <p:txBody>
+          <a:bodyPr wrap="square" lIns="13716" rIns="13716" tIns="13716" bIns="13716">
+            <a:spAutoFit/>
+          </a:bodyPr>
+          <a:lstStyle/>
           <a:p>
             <a:pPr>
-              <a:lnSpc>
-                <a:spcPct val="100000"/>
-              </a:lnSpc>
-              <a:spcBef>
-                <a:spcPts val="0"/>
-              </a:spcBef>
-              <a:spcAft>
-                <a:spcPts val="100"/>
+              <a:spcBef>
+                <a:spcPts val="0"/>
+              </a:spcBef>
+              <a:spcAft>
+                <a:spcPts val="500"/>
               </a:spcAft>
               <a:defRPr sz="1500" b="0">
                 <a:solidFill>
-                  <a:srgbClr val="7354B8"/>
-                </a:solidFill>
-                <a:latin typeface="Courier New"/>
-              </a:defRPr>
-            </a:pPr>
-            <a:r>
-              <a:t>    type: gauge</a:t>
-            </a:r>
-          </a:p>
+                  <a:srgbClr val="2563EB"/>
+                </a:solidFill>
+                <a:latin typeface="Arial"/>
+              </a:defRPr>
+            </a:pPr>
+            <a:r>
+              <a:t>Example scale-up</a:t>
+            </a:r>
+          </a:p>
+        </p:txBody>
+      </p:sp>
+      <p:sp>
+        <p:nvSpPr>
+          <p:cNvPr id="30" name="Rectangle 29"/>
+          <p:cNvSpPr/>
+          <p:nvPr/>
+        </p:nvSpPr>
+        <p:spPr>
+          <a:xfrm>
+            <a:off x="3429000" y="3813048"/>
+            <a:ext cx="4101083" cy="562356"/>
+          </a:xfrm>
+          <a:prstGeom prst="rect">
+            <a:avLst/>
+          </a:prstGeom>
+          <a:solidFill>
+            <a:srgbClr val="FFFFFF"/>
+          </a:solidFill>
+          <a:ln>
+            <a:noFill/>
+          </a:ln>
+        </p:spPr>
+        <p:style>
+          <a:lnRef idx="1">
+            <a:schemeClr val="accent1"/>
+          </a:lnRef>
+          <a:fillRef idx="3">
+            <a:schemeClr val="accent1"/>
+          </a:fillRef>
+          <a:effectRef idx="2">
+            <a:schemeClr val="accent1"/>
+          </a:effectRef>
+          <a:fontRef idx="minor">
+            <a:schemeClr val="lt1"/>
+          </a:fontRef>
+        </p:style>
+        <p:txBody>
+          <a:bodyPr rtlCol="0" anchor="ctr"/>
+          <a:lstStyle/>
+          <a:p>
+            <a:pPr algn="ctr"/>
+          </a:p>
+        </p:txBody>
+      </p:sp>
+      <p:sp>
+        <p:nvSpPr>
+          <p:cNvPr id="31" name="TextBox 30"/>
+          <p:cNvSpPr txBox="1"/>
+          <p:nvPr/>
+        </p:nvSpPr>
+        <p:spPr>
+          <a:xfrm>
+            <a:off x="3538728" y="3931920"/>
+            <a:ext cx="3904487" cy="402336"/>
+          </a:xfrm>
+          <a:prstGeom prst="rect">
+            <a:avLst/>
+          </a:prstGeom>
+          <a:noFill/>
+        </p:spPr>
+        <p:txBody>
+          <a:bodyPr wrap="square" lIns="13716" rIns="13716" tIns="13716" bIns="13716">
+            <a:spAutoFit/>
+          </a:bodyPr>
+          <a:lstStyle/>
           <a:p>
             <a:pPr>
-              <a:lnSpc>
-                <a:spcPct val="100000"/>
-              </a:lnSpc>
-              <a:spcBef>
-                <a:spcPts val="0"/>
-              </a:spcBef>
-              <a:spcAft>
-                <a:spcPts val="100"/>
+              <a:spcBef>
+                <a:spcPts val="0"/>
+              </a:spcBef>
+              <a:spcAft>
+                <a:spcPts val="500"/>
               </a:spcAft>
               <a:defRPr sz="1500" b="0">
                 <a:solidFill>
-                  <a:srgbClr val="7354B8"/>
-                </a:solidFill>
-                <a:latin typeface="Courier New"/>
-              </a:defRPr>
-            </a:pPr>
-            <a:r>
-              <a:t>    upthreshold: 24</a:t>
-            </a:r>
-          </a:p>
+                  <a:srgbClr val="172941"/>
+                </a:solidFill>
+                <a:latin typeface="Arial"/>
+              </a:defRPr>
+            </a:pPr>
+            <a:r>
+              <a:t>Signal &gt; 8</a:t>
+            </a:r>
+          </a:p>
+        </p:txBody>
+      </p:sp>
+      <p:sp>
+        <p:nvSpPr>
+          <p:cNvPr id="32" name="Rectangle 31"/>
+          <p:cNvSpPr/>
+          <p:nvPr/>
+        </p:nvSpPr>
+        <p:spPr>
+          <a:xfrm>
+            <a:off x="7552944" y="3813048"/>
+            <a:ext cx="4101083" cy="562356"/>
+          </a:xfrm>
+          <a:prstGeom prst="rect">
+            <a:avLst/>
+          </a:prstGeom>
+          <a:solidFill>
+            <a:srgbClr val="FFFFFF"/>
+          </a:solidFill>
+          <a:ln>
+            <a:noFill/>
+          </a:ln>
+        </p:spPr>
+        <p:style>
+          <a:lnRef idx="1">
+            <a:schemeClr val="accent1"/>
+          </a:lnRef>
+          <a:fillRef idx="3">
+            <a:schemeClr val="accent1"/>
+          </a:fillRef>
+          <a:effectRef idx="2">
+            <a:schemeClr val="accent1"/>
+          </a:effectRef>
+          <a:fontRef idx="minor">
+            <a:schemeClr val="lt1"/>
+          </a:fontRef>
+        </p:style>
+        <p:txBody>
+          <a:bodyPr rtlCol="0" anchor="ctr"/>
+          <a:lstStyle/>
+          <a:p>
+            <a:pPr algn="ctr"/>
+          </a:p>
+        </p:txBody>
+      </p:sp>
+      <p:sp>
+        <p:nvSpPr>
+          <p:cNvPr id="33" name="TextBox 32"/>
+          <p:cNvSpPr txBox="1"/>
+          <p:nvPr/>
+        </p:nvSpPr>
+        <p:spPr>
+          <a:xfrm>
+            <a:off x="7662671" y="3931920"/>
+            <a:ext cx="3904487" cy="402336"/>
+          </a:xfrm>
+          <a:prstGeom prst="rect">
+            <a:avLst/>
+          </a:prstGeom>
+          <a:noFill/>
+        </p:spPr>
+        <p:txBody>
+          <a:bodyPr wrap="square" lIns="13716" rIns="13716" tIns="13716" bIns="13716">
+            <a:spAutoFit/>
+          </a:bodyPr>
+          <a:lstStyle/>
           <a:p>
             <a:pPr>
-              <a:lnSpc>
-                <a:spcPct val="100000"/>
-              </a:lnSpc>
-              <a:spcBef>
-                <a:spcPts val="0"/>
-              </a:spcBef>
-              <a:spcAft>
-                <a:spcPts val="100"/>
+              <a:spcBef>
+                <a:spcPts val="0"/>
+              </a:spcBef>
+              <a:spcAft>
+                <a:spcPts val="500"/>
               </a:spcAft>
               <a:defRPr sz="1500" b="0">
                 <a:solidFill>
-                  <a:srgbClr val="7354B8"/>
-                </a:solidFill>
-                <a:latin typeface="Courier New"/>
-              </a:defRPr>
-            </a:pPr>
-            <a:r>
-              <a:t>    downthreshold: 4</a:t>
+                  <a:srgbClr val="172941"/>
+                </a:solidFill>
+                <a:latin typeface="Arial"/>
+              </a:defRPr>
+            </a:pPr>
+            <a:r>
+              <a:t>Signal &gt; 24</a:t>
+            </a:r>
+          </a:p>
+        </p:txBody>
+      </p:sp>
+      <p:sp>
+        <p:nvSpPr>
+          <p:cNvPr id="34" name="Rectangle 33"/>
+          <p:cNvSpPr/>
+          <p:nvPr/>
+        </p:nvSpPr>
+        <p:spPr>
+          <a:xfrm>
+            <a:off x="502920" y="4398264"/>
+            <a:ext cx="2903220" cy="562356"/>
+          </a:xfrm>
+          <a:prstGeom prst="rect">
+            <a:avLst/>
+          </a:prstGeom>
+          <a:solidFill>
+            <a:srgbClr val="EAF1FF"/>
+          </a:solidFill>
+          <a:ln>
+            <a:noFill/>
+          </a:ln>
+        </p:spPr>
+        <p:style>
+          <a:lnRef idx="1">
+            <a:schemeClr val="accent1"/>
+          </a:lnRef>
+          <a:fillRef idx="3">
+            <a:schemeClr val="accent1"/>
+          </a:fillRef>
+          <a:effectRef idx="2">
+            <a:schemeClr val="accent1"/>
+          </a:effectRef>
+          <a:fontRef idx="minor">
+            <a:schemeClr val="lt1"/>
+          </a:fontRef>
+        </p:style>
+        <p:txBody>
+          <a:bodyPr rtlCol="0" anchor="ctr"/>
+          <a:lstStyle/>
+          <a:p>
+            <a:pPr algn="ctr"/>
+          </a:p>
+        </p:txBody>
+      </p:sp>
+      <p:sp>
+        <p:nvSpPr>
+          <p:cNvPr id="35" name="TextBox 34"/>
+          <p:cNvSpPr txBox="1"/>
+          <p:nvPr/>
+        </p:nvSpPr>
+        <p:spPr>
+          <a:xfrm>
+            <a:off x="612648" y="4517136"/>
+            <a:ext cx="2706624" cy="402336"/>
+          </a:xfrm>
+          <a:prstGeom prst="rect">
+            <a:avLst/>
+          </a:prstGeom>
+          <a:noFill/>
+        </p:spPr>
+        <p:txBody>
+          <a:bodyPr wrap="square" lIns="13716" rIns="13716" tIns="13716" bIns="13716">
+            <a:spAutoFit/>
+          </a:bodyPr>
+          <a:lstStyle/>
+          <a:p>
+            <a:pPr>
+              <a:spcBef>
+                <a:spcPts val="0"/>
+              </a:spcBef>
+              <a:spcAft>
+                <a:spcPts val="500"/>
+              </a:spcAft>
+              <a:defRPr sz="1500" b="0">
+                <a:solidFill>
+                  <a:srgbClr val="2563EB"/>
+                </a:solidFill>
+                <a:latin typeface="Arial"/>
+              </a:defRPr>
+            </a:pPr>
+            <a:r>
+              <a:t>Example scale-down</a:t>
+            </a:r>
+          </a:p>
+        </p:txBody>
+      </p:sp>
+      <p:sp>
+        <p:nvSpPr>
+          <p:cNvPr id="36" name="Rectangle 35"/>
+          <p:cNvSpPr/>
+          <p:nvPr/>
+        </p:nvSpPr>
+        <p:spPr>
+          <a:xfrm>
+            <a:off x="3429000" y="4398264"/>
+            <a:ext cx="4101083" cy="562356"/>
+          </a:xfrm>
+          <a:prstGeom prst="rect">
+            <a:avLst/>
+          </a:prstGeom>
+          <a:solidFill>
+            <a:srgbClr val="EAF1FF"/>
+          </a:solidFill>
+          <a:ln>
+            <a:noFill/>
+          </a:ln>
+        </p:spPr>
+        <p:style>
+          <a:lnRef idx="1">
+            <a:schemeClr val="accent1"/>
+          </a:lnRef>
+          <a:fillRef idx="3">
+            <a:schemeClr val="accent1"/>
+          </a:fillRef>
+          <a:effectRef idx="2">
+            <a:schemeClr val="accent1"/>
+          </a:effectRef>
+          <a:fontRef idx="minor">
+            <a:schemeClr val="lt1"/>
+          </a:fontRef>
+        </p:style>
+        <p:txBody>
+          <a:bodyPr rtlCol="0" anchor="ctr"/>
+          <a:lstStyle/>
+          <a:p>
+            <a:pPr algn="ctr"/>
+          </a:p>
+        </p:txBody>
+      </p:sp>
+      <p:sp>
+        <p:nvSpPr>
+          <p:cNvPr id="37" name="TextBox 36"/>
+          <p:cNvSpPr txBox="1"/>
+          <p:nvPr/>
+        </p:nvSpPr>
+        <p:spPr>
+          <a:xfrm>
+            <a:off x="3538728" y="4517136"/>
+            <a:ext cx="3904487" cy="402336"/>
+          </a:xfrm>
+          <a:prstGeom prst="rect">
+            <a:avLst/>
+          </a:prstGeom>
+          <a:noFill/>
+        </p:spPr>
+        <p:txBody>
+          <a:bodyPr wrap="square" lIns="13716" rIns="13716" tIns="13716" bIns="13716">
+            <a:spAutoFit/>
+          </a:bodyPr>
+          <a:lstStyle/>
+          <a:p>
+            <a:pPr>
+              <a:spcBef>
+                <a:spcPts val="0"/>
+              </a:spcBef>
+              <a:spcAft>
+                <a:spcPts val="500"/>
+              </a:spcAft>
+              <a:defRPr sz="1500" b="0">
+                <a:solidFill>
+                  <a:srgbClr val="172941"/>
+                </a:solidFill>
+                <a:latin typeface="Arial"/>
+              </a:defRPr>
+            </a:pPr>
+            <a:r>
+              <a:t>Signal &lt; 1</a:t>
+            </a:r>
+          </a:p>
+        </p:txBody>
+      </p:sp>
+      <p:sp>
+        <p:nvSpPr>
+          <p:cNvPr id="38" name="Rectangle 37"/>
+          <p:cNvSpPr/>
+          <p:nvPr/>
+        </p:nvSpPr>
+        <p:spPr>
+          <a:xfrm>
+            <a:off x="7552944" y="4398264"/>
+            <a:ext cx="4101083" cy="562356"/>
+          </a:xfrm>
+          <a:prstGeom prst="rect">
+            <a:avLst/>
+          </a:prstGeom>
+          <a:solidFill>
+            <a:srgbClr val="EAF1FF"/>
+          </a:solidFill>
+          <a:ln>
+            <a:noFill/>
+          </a:ln>
+        </p:spPr>
+        <p:style>
+          <a:lnRef idx="1">
+            <a:schemeClr val="accent1"/>
+          </a:lnRef>
+          <a:fillRef idx="3">
+            <a:schemeClr val="accent1"/>
+          </a:fillRef>
+          <a:effectRef idx="2">
+            <a:schemeClr val="accent1"/>
+          </a:effectRef>
+          <a:fontRef idx="minor">
+            <a:schemeClr val="lt1"/>
+          </a:fontRef>
+        </p:style>
+        <p:txBody>
+          <a:bodyPr rtlCol="0" anchor="ctr"/>
+          <a:lstStyle/>
+          <a:p>
+            <a:pPr algn="ctr"/>
+          </a:p>
+        </p:txBody>
+      </p:sp>
+      <p:sp>
+        <p:nvSpPr>
+          <p:cNvPr id="39" name="TextBox 38"/>
+          <p:cNvSpPr txBox="1"/>
+          <p:nvPr/>
+        </p:nvSpPr>
+        <p:spPr>
+          <a:xfrm>
+            <a:off x="7662671" y="4517136"/>
+            <a:ext cx="3904487" cy="402336"/>
+          </a:xfrm>
+          <a:prstGeom prst="rect">
+            <a:avLst/>
+          </a:prstGeom>
+          <a:noFill/>
+        </p:spPr>
+        <p:txBody>
+          <a:bodyPr wrap="square" lIns="13716" rIns="13716" tIns="13716" bIns="13716">
+            <a:spAutoFit/>
+          </a:bodyPr>
+          <a:lstStyle/>
+          <a:p>
+            <a:pPr>
+              <a:spcBef>
+                <a:spcPts val="0"/>
+              </a:spcBef>
+              <a:spcAft>
+                <a:spcPts val="500"/>
+              </a:spcAft>
+              <a:defRPr sz="1500" b="0">
+                <a:solidFill>
+                  <a:srgbClr val="172941"/>
+                </a:solidFill>
+                <a:latin typeface="Arial"/>
+              </a:defRPr>
+            </a:pPr>
+            <a:r>
+              <a:t>Signal &lt; 4</a:t>
+            </a:r>
+          </a:p>
+        </p:txBody>
+      </p:sp>
+      <p:sp>
+        <p:nvSpPr>
+          <p:cNvPr id="40" name="Rectangle 39"/>
+          <p:cNvSpPr/>
+          <p:nvPr/>
+        </p:nvSpPr>
+        <p:spPr>
+          <a:xfrm>
+            <a:off x="502920" y="4983480"/>
+            <a:ext cx="2903220" cy="562356"/>
+          </a:xfrm>
+          <a:prstGeom prst="rect">
+            <a:avLst/>
+          </a:prstGeom>
+          <a:solidFill>
+            <a:srgbClr val="FFFFFF"/>
+          </a:solidFill>
+          <a:ln>
+            <a:noFill/>
+          </a:ln>
+        </p:spPr>
+        <p:style>
+          <a:lnRef idx="1">
+            <a:schemeClr val="accent1"/>
+          </a:lnRef>
+          <a:fillRef idx="3">
+            <a:schemeClr val="accent1"/>
+          </a:fillRef>
+          <a:effectRef idx="2">
+            <a:schemeClr val="accent1"/>
+          </a:effectRef>
+          <a:fontRef idx="minor">
+            <a:schemeClr val="lt1"/>
+          </a:fontRef>
+        </p:style>
+        <p:txBody>
+          <a:bodyPr rtlCol="0" anchor="ctr"/>
+          <a:lstStyle/>
+          <a:p>
+            <a:pPr algn="ctr"/>
+          </a:p>
+        </p:txBody>
+      </p:sp>
+      <p:sp>
+        <p:nvSpPr>
+          <p:cNvPr id="41" name="TextBox 40"/>
+          <p:cNvSpPr txBox="1"/>
+          <p:nvPr/>
+        </p:nvSpPr>
+        <p:spPr>
+          <a:xfrm>
+            <a:off x="612648" y="5102352"/>
+            <a:ext cx="2706624" cy="402336"/>
+          </a:xfrm>
+          <a:prstGeom prst="rect">
+            <a:avLst/>
+          </a:prstGeom>
+          <a:noFill/>
+        </p:spPr>
+        <p:txBody>
+          <a:bodyPr wrap="square" lIns="13716" rIns="13716" tIns="13716" bIns="13716">
+            <a:spAutoFit/>
+          </a:bodyPr>
+          <a:lstStyle/>
+          <a:p>
+            <a:pPr>
+              <a:spcBef>
+                <a:spcPts val="0"/>
+              </a:spcBef>
+              <a:spcAft>
+                <a:spcPts val="500"/>
+              </a:spcAft>
+              <a:defRPr sz="1500" b="0">
+                <a:solidFill>
+                  <a:srgbClr val="2563EB"/>
+                </a:solidFill>
+                <a:latin typeface="Arial"/>
+              </a:defRPr>
+            </a:pPr>
+            <a:r>
+              <a:t>Shared guardrails</a:t>
+            </a:r>
+          </a:p>
+        </p:txBody>
+      </p:sp>
+      <p:sp>
+        <p:nvSpPr>
+          <p:cNvPr id="42" name="Rectangle 41"/>
+          <p:cNvSpPr/>
+          <p:nvPr/>
+        </p:nvSpPr>
+        <p:spPr>
+          <a:xfrm>
+            <a:off x="3429000" y="4983480"/>
+            <a:ext cx="4101083" cy="562356"/>
+          </a:xfrm>
+          <a:prstGeom prst="rect">
+            <a:avLst/>
+          </a:prstGeom>
+          <a:solidFill>
+            <a:srgbClr val="FFFFFF"/>
+          </a:solidFill>
+          <a:ln>
+            <a:noFill/>
+          </a:ln>
+        </p:spPr>
+        <p:style>
+          <a:lnRef idx="1">
+            <a:schemeClr val="accent1"/>
+          </a:lnRef>
+          <a:fillRef idx="3">
+            <a:schemeClr val="accent1"/>
+          </a:fillRef>
+          <a:effectRef idx="2">
+            <a:schemeClr val="accent1"/>
+          </a:effectRef>
+          <a:fontRef idx="minor">
+            <a:schemeClr val="lt1"/>
+          </a:fontRef>
+        </p:style>
+        <p:txBody>
+          <a:bodyPr rtlCol="0" anchor="ctr"/>
+          <a:lstStyle/>
+          <a:p>
+            <a:pPr algn="ctr"/>
+          </a:p>
+        </p:txBody>
+      </p:sp>
+      <p:sp>
+        <p:nvSpPr>
+          <p:cNvPr id="43" name="TextBox 42"/>
+          <p:cNvSpPr txBox="1"/>
+          <p:nvPr/>
+        </p:nvSpPr>
+        <p:spPr>
+          <a:xfrm>
+            <a:off x="3538728" y="5102352"/>
+            <a:ext cx="3904487" cy="402336"/>
+          </a:xfrm>
+          <a:prstGeom prst="rect">
+            <a:avLst/>
+          </a:prstGeom>
+          <a:noFill/>
+        </p:spPr>
+        <p:txBody>
+          <a:bodyPr wrap="square" lIns="13716" rIns="13716" tIns="13716" bIns="13716">
+            <a:spAutoFit/>
+          </a:bodyPr>
+          <a:lstStyle/>
+          <a:p>
+            <a:pPr>
+              <a:spcBef>
+                <a:spcPts val="0"/>
+              </a:spcBef>
+              <a:spcAft>
+                <a:spcPts val="500"/>
+              </a:spcAft>
+              <a:defRPr sz="1500" b="0">
+                <a:solidFill>
+                  <a:srgbClr val="172941"/>
+                </a:solidFill>
+                <a:latin typeface="Arial"/>
+              </a:defRPr>
+            </a:pPr>
+            <a:r>
+              <a:t>Readiness + fresh metrics</a:t>
+            </a:r>
+          </a:p>
+        </p:txBody>
+      </p:sp>
+      <p:sp>
+        <p:nvSpPr>
+          <p:cNvPr id="44" name="Rectangle 43"/>
+          <p:cNvSpPr/>
+          <p:nvPr/>
+        </p:nvSpPr>
+        <p:spPr>
+          <a:xfrm>
+            <a:off x="7552944" y="4983480"/>
+            <a:ext cx="4101083" cy="562356"/>
+          </a:xfrm>
+          <a:prstGeom prst="rect">
+            <a:avLst/>
+          </a:prstGeom>
+          <a:solidFill>
+            <a:srgbClr val="FFFFFF"/>
+          </a:solidFill>
+          <a:ln>
+            <a:noFill/>
+          </a:ln>
+        </p:spPr>
+        <p:style>
+          <a:lnRef idx="1">
+            <a:schemeClr val="accent1"/>
+          </a:lnRef>
+          <a:fillRef idx="3">
+            <a:schemeClr val="accent1"/>
+          </a:fillRef>
+          <a:effectRef idx="2">
+            <a:schemeClr val="accent1"/>
+          </a:effectRef>
+          <a:fontRef idx="minor">
+            <a:schemeClr val="lt1"/>
+          </a:fontRef>
+        </p:style>
+        <p:txBody>
+          <a:bodyPr rtlCol="0" anchor="ctr"/>
+          <a:lstStyle/>
+          <a:p>
+            <a:pPr algn="ctr"/>
+          </a:p>
+        </p:txBody>
+      </p:sp>
+      <p:sp>
+        <p:nvSpPr>
+          <p:cNvPr id="45" name="TextBox 44"/>
+          <p:cNvSpPr txBox="1"/>
+          <p:nvPr/>
+        </p:nvSpPr>
+        <p:spPr>
+          <a:xfrm>
+            <a:off x="7662671" y="5102352"/>
+            <a:ext cx="3904487" cy="402336"/>
+          </a:xfrm>
+          <a:prstGeom prst="rect">
+            <a:avLst/>
+          </a:prstGeom>
+          <a:noFill/>
+        </p:spPr>
+        <p:txBody>
+          <a:bodyPr wrap="square" lIns="13716" rIns="13716" tIns="13716" bIns="13716">
+            <a:spAutoFit/>
+          </a:bodyPr>
+          <a:lstStyle/>
+          <a:p>
+            <a:pPr>
+              <a:spcBef>
+                <a:spcPts val="0"/>
+              </a:spcBef>
+              <a:spcAft>
+                <a:spcPts val="500"/>
+              </a:spcAft>
+              <a:defRPr sz="1500" b="0">
+                <a:solidFill>
+                  <a:srgbClr val="172941"/>
+                </a:solidFill>
+                <a:latin typeface="Arial"/>
+              </a:defRPr>
+            </a:pPr>
+            <a:r>
+              <a:t>Readiness + fresh metrics</a:t>
             </a:r>
           </a:p>
         </p:txBody>
@@ -36771,7 +37681,7 @@
               </a:defRPr>
             </a:pPr>
             <a:r>
-              <a:t>04 / REQUIRED IMPLEMENTATION GATES</a:t>
+              <a:t>04 / OPERATIONAL SAFEGUARDS</a:t>
             </a:r>
           </a:p>
         </p:txBody>
@@ -36940,7 +37850,7 @@
               </a:defRPr>
             </a:pPr>
             <a:r>
-              <a:t>These are required safeguards—not behavior gained merely by adding an annotation.</a:t>
+              <a:t>Avoid competing controllers, count only ready capacity, and protect in-flight requests.</a:t>
             </a:r>
           </a:p>
         </p:txBody>
@@ -37275,7 +38185,7 @@
               </a:defRPr>
             </a:pPr>
             <a:r>
-              <a:t>Fixed: replicas set</a:t>
+              <a:t>One policy owns replica count</a:t>
             </a:r>
           </a:p>
           <a:p>
@@ -37294,7 +38204,7 @@
               </a:defRPr>
             </a:pPr>
             <a:r>
-              <a:t>Managed: policy + nil replicas</a:t>
+              <a:t>Separate targets for P and D</a:t>
             </a:r>
           </a:p>
           <a:p>
@@ -37313,7 +38223,7 @@
               </a:defRPr>
             </a:pPr>
             <a:r>
-              <a:t>External: both absent</a:t>
+              <a:t>No competing autoscalers</a:t>
             </a:r>
           </a:p>
         </p:txBody>
@@ -37901,7 +38811,7 @@
               </a:defRPr>
             </a:pPr>
             <a:r>
-              <a:t>Reject replicas + managed policy; one authoritative HPA/ScaledObject path per target.</a:t>
+              <a:t>On missing or invalid signals: hold decisions and report the problem. Missing is not zero.</a:t>
             </a:r>
           </a:p>
         </p:txBody>
@@ -39477,7 +40387,7 @@
               </a:defRPr>
             </a:pPr>
             <a:r>
-              <a:t>04 / LATER-STAGE DESIGN</a:t>
+              <a:t>04 / SIGNAL INTERPRETATION</a:t>
             </a:r>
           </a:p>
         </p:txBody>
@@ -39519,7 +40429,7 @@
               </a:defRPr>
             </a:pPr>
             <a:r>
-              <a:t>Phase 2: derive from vLLM, then validate the policy</a:t>
+              <a:t>Derived signals add context to scaling decisions</a:t>
             </a:r>
           </a:p>
         </p:txBody>
@@ -39561,7 +40471,7 @@
               </a:defRPr>
             </a:pPr>
             <a:r>
-              <a:t>Native sources below; derived recording rules and their collection adapter are future work.</a:t>
+              <a:t>Aggregate native vLLM metrics to understand KV utilization, latency and throughput.</a:t>
             </a:r>
           </a:p>
         </p:txBody>
@@ -39646,7 +40556,7 @@
               </a:defRPr>
             </a:pPr>
             <a:r>
-              <a:t>A KV downscale guard is not the current AND policy. Do not turn throughput alone into demand.</a:t>
+              <a:t>KV occupancy is not demand. High or low throughput alone should not change replica counts.</a:t>
             </a:r>
           </a:p>
         </p:txBody>
@@ -40020,7 +40930,7 @@
               </a:defRPr>
             </a:pPr>
             <a:r>
-              <a:t>USE AFTER VALIDATION</a:t>
+              <a:t>DECISION SUPPORT</a:t>
             </a:r>
           </a:p>
         </p:txBody>

</xml_diff>